<commit_message>
first draft of all chapters
</commit_message>
<xml_diff>
--- a/Lecture_Slides/PH 123 Lecture 36.pptx
+++ b/Lecture_Slides/PH 123 Lecture 36.pptx
@@ -6,12 +6,13 @@
   </p:sldMasterIdLst>
   <p:sldIdLst>
     <p:sldId id="256" r:id="rId2"/>
-    <p:sldId id="341" r:id="rId3"/>
-    <p:sldId id="265" r:id="rId4"/>
-    <p:sldId id="285" r:id="rId5"/>
-    <p:sldId id="340" r:id="rId6"/>
-    <p:sldId id="283" r:id="rId7"/>
-    <p:sldId id="257" r:id="rId8"/>
+    <p:sldId id="484" r:id="rId3"/>
+    <p:sldId id="341" r:id="rId4"/>
+    <p:sldId id="265" r:id="rId5"/>
+    <p:sldId id="285" r:id="rId6"/>
+    <p:sldId id="340" r:id="rId7"/>
+    <p:sldId id="283" r:id="rId8"/>
+    <p:sldId id="257" r:id="rId9"/>
   </p:sldIdLst>
   <p:sldSz cx="12192000" cy="6858000"/>
   <p:notesSz cx="6858000" cy="9144000"/>
@@ -110,13 +111,18 @@
       </a:defRPr>
     </a:lvl9pPr>
   </p:defaultTextStyle>
+  <p:extLst>
+    <p:ext uri="{EFAFB233-063F-42B5-8137-9DF3F51BA10A}">
+      <p15:sldGuideLst xmlns:p15="http://schemas.microsoft.com/office/powerpoint/2012/main"/>
+    </p:ext>
+  </p:extLst>
 </p:presentation>
 </file>
 
 <file path=ppt/revisionInfo.xml><?xml version="1.0" encoding="utf-8"?>
 <p1510:revInfo xmlns:a="http://schemas.openxmlformats.org/drawingml/2006/main" xmlns:r="http://schemas.openxmlformats.org/officeDocument/2006/relationships" xmlns:p1510="http://schemas.microsoft.com/office/powerpoint/2015/10/main">
   <p1510:revLst>
-    <p1510:client id="{19433E2F-A7AC-4341-9FA4-5680B2C19CE3}" v="1" dt="2025-07-03T22:45:43.068"/>
+    <p1510:client id="{19433E2F-A7AC-4341-9FA4-5680B2C19CE3}" v="2" dt="2025-07-08T19:01:42.760"/>
   </p1510:revLst>
 </p1510:revInfo>
 </file>
@@ -126,7 +132,7 @@
   <pc:docChgLst>
     <pc:chgData name="Lines, Todd" userId="afaf7c3a-e8aa-4568-882a-02ad8f9e19b0" providerId="ADAL" clId="{19433E2F-A7AC-4341-9FA4-5680B2C19CE3}"/>
     <pc:docChg chg="custSel addSld modSld">
-      <pc:chgData name="Lines, Todd" userId="afaf7c3a-e8aa-4568-882a-02ad8f9e19b0" providerId="ADAL" clId="{19433E2F-A7AC-4341-9FA4-5680B2C19CE3}" dt="2025-07-03T22:45:43.067" v="5"/>
+      <pc:chgData name="Lines, Todd" userId="afaf7c3a-e8aa-4568-882a-02ad8f9e19b0" providerId="ADAL" clId="{19433E2F-A7AC-4341-9FA4-5680B2C19CE3}" dt="2025-07-08T19:01:50.896" v="8" actId="20577"/>
       <pc:docMkLst>
         <pc:docMk/>
       </pc:docMkLst>
@@ -143,22 +149,6 @@
           <pc:docMk/>
           <pc:sldMk cId="3556862412" sldId="341"/>
         </pc:sldMkLst>
-        <pc:spChg chg="del">
-          <ac:chgData name="Lines, Todd" userId="afaf7c3a-e8aa-4568-882a-02ad8f9e19b0" providerId="ADAL" clId="{19433E2F-A7AC-4341-9FA4-5680B2C19CE3}" dt="2025-07-03T22:44:05.329" v="1" actId="478"/>
-          <ac:spMkLst>
-            <pc:docMk/>
-            <pc:sldMk cId="3556862412" sldId="341"/>
-            <ac:spMk id="2" creationId="{13CF5273-D19C-028C-5362-9A89FB01E951}"/>
-          </ac:spMkLst>
-        </pc:spChg>
-        <pc:spChg chg="del">
-          <ac:chgData name="Lines, Todd" userId="afaf7c3a-e8aa-4568-882a-02ad8f9e19b0" providerId="ADAL" clId="{19433E2F-A7AC-4341-9FA4-5680B2C19CE3}" dt="2025-07-03T22:44:05.329" v="1" actId="478"/>
-          <ac:spMkLst>
-            <pc:docMk/>
-            <pc:sldMk cId="3556862412" sldId="341"/>
-            <ac:spMk id="3" creationId="{E7A8934F-4B16-04B2-D208-E2FEE78C8BBB}"/>
-          </ac:spMkLst>
-        </pc:spChg>
         <pc:picChg chg="add mod">
           <ac:chgData name="Lines, Todd" userId="afaf7c3a-e8aa-4568-882a-02ad8f9e19b0" providerId="ADAL" clId="{19433E2F-A7AC-4341-9FA4-5680B2C19CE3}" dt="2025-07-03T22:44:15.552" v="4" actId="14100"/>
           <ac:picMkLst>
@@ -167,6 +157,21 @@
             <ac:picMk id="5" creationId="{FE9C3FC7-9DC0-D72B-55CE-8DD1D7DED647}"/>
           </ac:picMkLst>
         </pc:picChg>
+      </pc:sldChg>
+      <pc:sldChg chg="modSp add mod">
+        <pc:chgData name="Lines, Todd" userId="afaf7c3a-e8aa-4568-882a-02ad8f9e19b0" providerId="ADAL" clId="{19433E2F-A7AC-4341-9FA4-5680B2C19CE3}" dt="2025-07-08T19:01:50.896" v="8" actId="20577"/>
+        <pc:sldMkLst>
+          <pc:docMk/>
+          <pc:sldMk cId="0" sldId="484"/>
+        </pc:sldMkLst>
+        <pc:spChg chg="mod">
+          <ac:chgData name="Lines, Todd" userId="afaf7c3a-e8aa-4568-882a-02ad8f9e19b0" providerId="ADAL" clId="{19433E2F-A7AC-4341-9FA4-5680B2C19CE3}" dt="2025-07-08T19:01:50.896" v="8" actId="20577"/>
+          <ac:spMkLst>
+            <pc:docMk/>
+            <pc:sldMk cId="0" sldId="484"/>
+            <ac:spMk id="35843" creationId="{25E6F564-0ACC-BFA0-5D1C-098F0645008F}"/>
+          </ac:spMkLst>
+        </pc:spChg>
       </pc:sldChg>
     </pc:docChg>
   </pc:docChgLst>
@@ -320,7 +325,7 @@
           <a:p>
             <a:fld id="{5D14FE54-3E4B-43AC-AC6A-78E009FC7A62}" type="datetimeFigureOut">
               <a:rPr lang="en-US" smtClean="0"/>
-              <a:t>7/3/2025</a:t>
+              <a:t>7/8/2025</a:t>
             </a:fld>
             <a:endParaRPr lang="en-US"/>
           </a:p>
@@ -518,7 +523,7 @@
           <a:p>
             <a:fld id="{5D14FE54-3E4B-43AC-AC6A-78E009FC7A62}" type="datetimeFigureOut">
               <a:rPr lang="en-US" smtClean="0"/>
-              <a:t>7/3/2025</a:t>
+              <a:t>7/8/2025</a:t>
             </a:fld>
             <a:endParaRPr lang="en-US"/>
           </a:p>
@@ -726,7 +731,7 @@
           <a:p>
             <a:fld id="{5D14FE54-3E4B-43AC-AC6A-78E009FC7A62}" type="datetimeFigureOut">
               <a:rPr lang="en-US" smtClean="0"/>
-              <a:t>7/3/2025</a:t>
+              <a:t>7/8/2025</a:t>
             </a:fld>
             <a:endParaRPr lang="en-US"/>
           </a:p>
@@ -924,7 +929,7 @@
           <a:p>
             <a:fld id="{5D14FE54-3E4B-43AC-AC6A-78E009FC7A62}" type="datetimeFigureOut">
               <a:rPr lang="en-US" smtClean="0"/>
-              <a:t>7/3/2025</a:t>
+              <a:t>7/8/2025</a:t>
             </a:fld>
             <a:endParaRPr lang="en-US"/>
           </a:p>
@@ -1199,7 +1204,7 @@
           <a:p>
             <a:fld id="{5D14FE54-3E4B-43AC-AC6A-78E009FC7A62}" type="datetimeFigureOut">
               <a:rPr lang="en-US" smtClean="0"/>
-              <a:t>7/3/2025</a:t>
+              <a:t>7/8/2025</a:t>
             </a:fld>
             <a:endParaRPr lang="en-US"/>
           </a:p>
@@ -1464,7 +1469,7 @@
           <a:p>
             <a:fld id="{5D14FE54-3E4B-43AC-AC6A-78E009FC7A62}" type="datetimeFigureOut">
               <a:rPr lang="en-US" smtClean="0"/>
-              <a:t>7/3/2025</a:t>
+              <a:t>7/8/2025</a:t>
             </a:fld>
             <a:endParaRPr lang="en-US"/>
           </a:p>
@@ -1876,7 +1881,7 @@
           <a:p>
             <a:fld id="{5D14FE54-3E4B-43AC-AC6A-78E009FC7A62}" type="datetimeFigureOut">
               <a:rPr lang="en-US" smtClean="0"/>
-              <a:t>7/3/2025</a:t>
+              <a:t>7/8/2025</a:t>
             </a:fld>
             <a:endParaRPr lang="en-US"/>
           </a:p>
@@ -2017,7 +2022,7 @@
           <a:p>
             <a:fld id="{5D14FE54-3E4B-43AC-AC6A-78E009FC7A62}" type="datetimeFigureOut">
               <a:rPr lang="en-US" smtClean="0"/>
-              <a:t>7/3/2025</a:t>
+              <a:t>7/8/2025</a:t>
             </a:fld>
             <a:endParaRPr lang="en-US"/>
           </a:p>
@@ -2130,7 +2135,7 @@
           <a:p>
             <a:fld id="{5D14FE54-3E4B-43AC-AC6A-78E009FC7A62}" type="datetimeFigureOut">
               <a:rPr lang="en-US" smtClean="0"/>
-              <a:t>7/3/2025</a:t>
+              <a:t>7/8/2025</a:t>
             </a:fld>
             <a:endParaRPr lang="en-US"/>
           </a:p>
@@ -2441,7 +2446,7 @@
           <a:p>
             <a:fld id="{5D14FE54-3E4B-43AC-AC6A-78E009FC7A62}" type="datetimeFigureOut">
               <a:rPr lang="en-US" smtClean="0"/>
-              <a:t>7/3/2025</a:t>
+              <a:t>7/8/2025</a:t>
             </a:fld>
             <a:endParaRPr lang="en-US"/>
           </a:p>
@@ -2729,7 +2734,7 @@
           <a:p>
             <a:fld id="{5D14FE54-3E4B-43AC-AC6A-78E009FC7A62}" type="datetimeFigureOut">
               <a:rPr lang="en-US" smtClean="0"/>
-              <a:t>7/3/2025</a:t>
+              <a:t>7/8/2025</a:t>
             </a:fld>
             <a:endParaRPr lang="en-US"/>
           </a:p>
@@ -2970,7 +2975,7 @@
           <a:p>
             <a:fld id="{5D14FE54-3E4B-43AC-AC6A-78E009FC7A62}" type="datetimeFigureOut">
               <a:rPr lang="en-US" smtClean="0"/>
-              <a:t>7/3/2025</a:t>
+              <a:t>7/8/2025</a:t>
             </a:fld>
             <a:endParaRPr lang="en-US"/>
           </a:p>
@@ -3470,6 +3475,314 @@
           <a:chExt cx="0" cy="0"/>
         </a:xfrm>
       </p:grpSpPr>
+      <p:sp>
+        <p:nvSpPr>
+          <p:cNvPr id="35842" name="Title 1">
+            <a:extLst>
+              <a:ext uri="{FF2B5EF4-FFF2-40B4-BE49-F238E27FC236}">
+                <a16:creationId xmlns:a16="http://schemas.microsoft.com/office/drawing/2014/main" id="{F43ACF25-DEF1-F1E0-E112-C04FCEC49AE5}"/>
+              </a:ext>
+            </a:extLst>
+          </p:cNvPr>
+          <p:cNvSpPr>
+            <a:spLocks noGrp="1" noChangeArrowheads="1"/>
+          </p:cNvSpPr>
+          <p:nvPr>
+            <p:ph type="title"/>
+          </p:nvPr>
+        </p:nvSpPr>
+        <p:spPr/>
+        <p:txBody>
+          <a:bodyPr/>
+          <a:lstStyle/>
+          <a:p>
+            <a:r>
+              <a:rPr lang="en-US" altLang="en-US"/>
+              <a:t>Question 123.11.4</a:t>
+            </a:r>
+          </a:p>
+        </p:txBody>
+      </p:sp>
+      <p:sp>
+        <p:nvSpPr>
+          <p:cNvPr id="35843" name="Content Placeholder 2">
+            <a:extLst>
+              <a:ext uri="{FF2B5EF4-FFF2-40B4-BE49-F238E27FC236}">
+                <a16:creationId xmlns:a16="http://schemas.microsoft.com/office/drawing/2014/main" id="{25E6F564-0ACC-BFA0-5D1C-098F0645008F}"/>
+              </a:ext>
+            </a:extLst>
+          </p:cNvPr>
+          <p:cNvSpPr>
+            <a:spLocks noGrp="1" noChangeArrowheads="1"/>
+          </p:cNvSpPr>
+          <p:nvPr>
+            <p:ph idx="1"/>
+          </p:nvPr>
+        </p:nvSpPr>
+        <p:spPr/>
+        <p:txBody>
+          <a:bodyPr/>
+          <a:lstStyle/>
+          <a:p>
+            <a:pPr>
+              <a:buFontTx/>
+              <a:buNone/>
+            </a:pPr>
+            <a:r>
+              <a:rPr lang="en-US" altLang="en-US" dirty="0"/>
+              <a:t>You put a gas in a cylinder with a piston through a process that changes the temperature. </a:t>
+            </a:r>
+            <a:r>
+              <a:rPr lang="en-US" altLang="en-US"/>
+              <a:t>Can Q = 0</a:t>
+            </a:r>
+            <a:r>
+              <a:rPr lang="en-US" altLang="en-US" dirty="0"/>
+              <a:t>?</a:t>
+            </a:r>
+          </a:p>
+          <a:p>
+            <a:pPr>
+              <a:buFontTx/>
+              <a:buAutoNum type="alphaLcParenR"/>
+            </a:pPr>
+            <a:r>
+              <a:rPr lang="en-US" altLang="en-US" dirty="0"/>
+              <a:t>Yes, if it is the right process</a:t>
+            </a:r>
+          </a:p>
+          <a:p>
+            <a:pPr>
+              <a:buFontTx/>
+              <a:buAutoNum type="alphaLcParenR"/>
+            </a:pPr>
+            <a:r>
+              <a:rPr lang="en-US" altLang="en-US" dirty="0"/>
+              <a:t>No</a:t>
+            </a:r>
+          </a:p>
+          <a:p>
+            <a:pPr>
+              <a:buFontTx/>
+              <a:buAutoNum type="alphaLcParenR"/>
+            </a:pPr>
+            <a:r>
+              <a:rPr lang="en-US" altLang="en-US" dirty="0"/>
+              <a:t>Maybe</a:t>
+            </a:r>
+          </a:p>
+        </p:txBody>
+      </p:sp>
+      <p:sp>
+        <p:nvSpPr>
+          <p:cNvPr id="35844" name="Slide Number Placeholder 3">
+            <a:extLst>
+              <a:ext uri="{FF2B5EF4-FFF2-40B4-BE49-F238E27FC236}">
+                <a16:creationId xmlns:a16="http://schemas.microsoft.com/office/drawing/2014/main" id="{57E8B4B4-1F76-2700-68DE-DCC42345C396}"/>
+              </a:ext>
+            </a:extLst>
+          </p:cNvPr>
+          <p:cNvSpPr>
+            <a:spLocks noGrp="1"/>
+          </p:cNvSpPr>
+          <p:nvPr>
+            <p:ph type="sldNum" sz="quarter" idx="12"/>
+          </p:nvPr>
+        </p:nvSpPr>
+        <p:spPr bwMode="auto">
+          <a:noFill/>
+          <a:extLst>
+            <a:ext uri="{909E8E84-426E-40DD-AFC4-6F175D3DCCD1}">
+              <a14:hiddenFill xmlns:a14="http://schemas.microsoft.com/office/drawing/2010/main">
+                <a:solidFill>
+                  <a:srgbClr val="FFFFFF"/>
+                </a:solidFill>
+              </a14:hiddenFill>
+            </a:ext>
+            <a:ext uri="{91240B29-F687-4F45-9708-019B960494DF}">
+              <a14:hiddenLine xmlns:a14="http://schemas.microsoft.com/office/drawing/2010/main" w="9525">
+                <a:solidFill>
+                  <a:srgbClr val="000000"/>
+                </a:solidFill>
+                <a:miter lim="800000"/>
+                <a:headEnd/>
+                <a:tailEnd/>
+              </a14:hiddenLine>
+            </a:ext>
+          </a:extLst>
+        </p:spPr>
+        <p:txBody>
+          <a:bodyPr/>
+          <a:lstStyle>
+            <a:lvl1pPr>
+              <a:spcBef>
+                <a:spcPct val="20000"/>
+              </a:spcBef>
+              <a:buChar char="•"/>
+              <a:defRPr sz="3200">
+                <a:solidFill>
+                  <a:schemeClr val="tx1"/>
+                </a:solidFill>
+                <a:latin typeface="Arial" panose="020B0604020202020204" pitchFamily="34" charset="0"/>
+              </a:defRPr>
+            </a:lvl1pPr>
+            <a:lvl2pPr marL="742950" indent="-285750">
+              <a:spcBef>
+                <a:spcPct val="20000"/>
+              </a:spcBef>
+              <a:buChar char="–"/>
+              <a:defRPr sz="2800">
+                <a:solidFill>
+                  <a:schemeClr val="tx1"/>
+                </a:solidFill>
+                <a:latin typeface="Arial" panose="020B0604020202020204" pitchFamily="34" charset="0"/>
+              </a:defRPr>
+            </a:lvl2pPr>
+            <a:lvl3pPr marL="1143000" indent="-228600">
+              <a:spcBef>
+                <a:spcPct val="20000"/>
+              </a:spcBef>
+              <a:buChar char="•"/>
+              <a:defRPr sz="2400">
+                <a:solidFill>
+                  <a:schemeClr val="tx1"/>
+                </a:solidFill>
+                <a:latin typeface="Arial" panose="020B0604020202020204" pitchFamily="34" charset="0"/>
+              </a:defRPr>
+            </a:lvl3pPr>
+            <a:lvl4pPr marL="1600200" indent="-228600">
+              <a:spcBef>
+                <a:spcPct val="20000"/>
+              </a:spcBef>
+              <a:buChar char="–"/>
+              <a:defRPr sz="2000">
+                <a:solidFill>
+                  <a:schemeClr val="tx1"/>
+                </a:solidFill>
+                <a:latin typeface="Arial" panose="020B0604020202020204" pitchFamily="34" charset="0"/>
+              </a:defRPr>
+            </a:lvl4pPr>
+            <a:lvl5pPr marL="2057400" indent="-228600">
+              <a:spcBef>
+                <a:spcPct val="20000"/>
+              </a:spcBef>
+              <a:buChar char="»"/>
+              <a:defRPr sz="2000">
+                <a:solidFill>
+                  <a:schemeClr val="tx1"/>
+                </a:solidFill>
+                <a:latin typeface="Arial" panose="020B0604020202020204" pitchFamily="34" charset="0"/>
+              </a:defRPr>
+            </a:lvl5pPr>
+            <a:lvl6pPr marL="2514600" indent="-228600" eaLnBrk="0" fontAlgn="base" hangingPunct="0">
+              <a:spcBef>
+                <a:spcPct val="20000"/>
+              </a:spcBef>
+              <a:spcAft>
+                <a:spcPct val="0"/>
+              </a:spcAft>
+              <a:buChar char="»"/>
+              <a:defRPr sz="2000">
+                <a:solidFill>
+                  <a:schemeClr val="tx1"/>
+                </a:solidFill>
+                <a:latin typeface="Arial" panose="020B0604020202020204" pitchFamily="34" charset="0"/>
+              </a:defRPr>
+            </a:lvl6pPr>
+            <a:lvl7pPr marL="2971800" indent="-228600" eaLnBrk="0" fontAlgn="base" hangingPunct="0">
+              <a:spcBef>
+                <a:spcPct val="20000"/>
+              </a:spcBef>
+              <a:spcAft>
+                <a:spcPct val="0"/>
+              </a:spcAft>
+              <a:buChar char="»"/>
+              <a:defRPr sz="2000">
+                <a:solidFill>
+                  <a:schemeClr val="tx1"/>
+                </a:solidFill>
+                <a:latin typeface="Arial" panose="020B0604020202020204" pitchFamily="34" charset="0"/>
+              </a:defRPr>
+            </a:lvl7pPr>
+            <a:lvl8pPr marL="3429000" indent="-228600" eaLnBrk="0" fontAlgn="base" hangingPunct="0">
+              <a:spcBef>
+                <a:spcPct val="20000"/>
+              </a:spcBef>
+              <a:spcAft>
+                <a:spcPct val="0"/>
+              </a:spcAft>
+              <a:buChar char="»"/>
+              <a:defRPr sz="2000">
+                <a:solidFill>
+                  <a:schemeClr val="tx1"/>
+                </a:solidFill>
+                <a:latin typeface="Arial" panose="020B0604020202020204" pitchFamily="34" charset="0"/>
+              </a:defRPr>
+            </a:lvl8pPr>
+            <a:lvl9pPr marL="3886200" indent="-228600" eaLnBrk="0" fontAlgn="base" hangingPunct="0">
+              <a:spcBef>
+                <a:spcPct val="20000"/>
+              </a:spcBef>
+              <a:spcAft>
+                <a:spcPct val="0"/>
+              </a:spcAft>
+              <a:buChar char="»"/>
+              <a:defRPr sz="2000">
+                <a:solidFill>
+                  <a:schemeClr val="tx1"/>
+                </a:solidFill>
+                <a:latin typeface="Arial" panose="020B0604020202020204" pitchFamily="34" charset="0"/>
+              </a:defRPr>
+            </a:lvl9pPr>
+          </a:lstStyle>
+          <a:p>
+            <a:pPr>
+              <a:spcBef>
+                <a:spcPct val="0"/>
+              </a:spcBef>
+              <a:buFontTx/>
+              <a:buNone/>
+            </a:pPr>
+            <a:fld id="{6DC6CAC7-B115-4CA8-825E-3F1ADFC365D7}" type="slidenum">
+              <a:rPr lang="en-US" altLang="en-US" sz="1800"/>
+              <a:pPr>
+                <a:spcBef>
+                  <a:spcPct val="0"/>
+                </a:spcBef>
+                <a:buFontTx/>
+                <a:buNone/>
+              </a:pPr>
+              <a:t>2</a:t>
+            </a:fld>
+            <a:endParaRPr lang="en-US" altLang="en-US" sz="1800"/>
+          </a:p>
+        </p:txBody>
+      </p:sp>
+    </p:spTree>
+  </p:cSld>
+  <p:clrMapOvr>
+    <a:masterClrMapping/>
+  </p:clrMapOvr>
+</p:sld>
+</file>
+
+<file path=ppt/slides/slide3.xml><?xml version="1.0" encoding="utf-8"?>
+<p:sld xmlns:a="http://schemas.openxmlformats.org/drawingml/2006/main" xmlns:r="http://schemas.openxmlformats.org/officeDocument/2006/relationships" xmlns:p="http://schemas.openxmlformats.org/presentationml/2006/main">
+  <p:cSld>
+    <p:spTree>
+      <p:nvGrpSpPr>
+        <p:cNvPr id="1" name=""/>
+        <p:cNvGrpSpPr/>
+        <p:nvPr/>
+      </p:nvGrpSpPr>
+      <p:grpSpPr>
+        <a:xfrm>
+          <a:off x="0" y="0"/>
+          <a:ext cx="0" cy="0"/>
+          <a:chOff x="0" y="0"/>
+          <a:chExt cx="0" cy="0"/>
+        </a:xfrm>
+      </p:grpSpPr>
       <p:pic>
         <p:nvPicPr>
           <p:cNvPr id="5" name="Picture 4">
@@ -3513,7 +3826,7 @@
 </p:sld>
 </file>
 
-<file path=ppt/slides/slide3.xml><?xml version="1.0" encoding="utf-8"?>
+<file path=ppt/slides/slide4.xml><?xml version="1.0" encoding="utf-8"?>
 <p:sld xmlns:a="http://schemas.openxmlformats.org/drawingml/2006/main" xmlns:r="http://schemas.openxmlformats.org/officeDocument/2006/relationships" xmlns:p="http://schemas.openxmlformats.org/presentationml/2006/main">
   <p:cSld>
     <p:spTree>
@@ -3609,7 +3922,7 @@
 </p:sld>
 </file>
 
-<file path=ppt/slides/slide4.xml><?xml version="1.0" encoding="utf-8"?>
+<file path=ppt/slides/slide5.xml><?xml version="1.0" encoding="utf-8"?>
 <p:sld xmlns:a="http://schemas.openxmlformats.org/drawingml/2006/main" xmlns:r="http://schemas.openxmlformats.org/officeDocument/2006/relationships" xmlns:p="http://schemas.openxmlformats.org/presentationml/2006/main">
   <p:cSld>
     <p:spTree>
@@ -4158,7 +4471,7 @@
 </p:sld>
 </file>
 
-<file path=ppt/slides/slide5.xml><?xml version="1.0" encoding="utf-8"?>
+<file path=ppt/slides/slide6.xml><?xml version="1.0" encoding="utf-8"?>
 <p:sld xmlns:a="http://schemas.openxmlformats.org/drawingml/2006/main" xmlns:r="http://schemas.openxmlformats.org/officeDocument/2006/relationships" xmlns:p="http://schemas.openxmlformats.org/presentationml/2006/main">
   <p:cSld>
     <p:spTree>
@@ -4254,7 +4567,7 @@
 </p:sld>
 </file>
 
-<file path=ppt/slides/slide6.xml><?xml version="1.0" encoding="utf-8"?>
+<file path=ppt/slides/slide7.xml><?xml version="1.0" encoding="utf-8"?>
 <p:sld xmlns:a="http://schemas.openxmlformats.org/drawingml/2006/main" xmlns:r="http://schemas.openxmlformats.org/officeDocument/2006/relationships" xmlns:p="http://schemas.openxmlformats.org/presentationml/2006/main">
   <p:cSld>
     <p:spTree>
@@ -4291,7 +4604,7 @@
             <a:fld id="{C2812B8D-E844-4807-B20D-B92C141DEBC2}" type="slidenum">
               <a:rPr lang="en-US" smtClean="0"/>
               <a:pPr/>
-              <a:t>6</a:t>
+              <a:t>7</a:t>
             </a:fld>
             <a:endParaRPr lang="en-US"/>
           </a:p>
@@ -4638,7 +4951,7 @@
 </p:sld>
 </file>
 
-<file path=ppt/slides/slide7.xml><?xml version="1.0" encoding="utf-8"?>
+<file path=ppt/slides/slide8.xml><?xml version="1.0" encoding="utf-8"?>
 <p:sld xmlns:a="http://schemas.openxmlformats.org/drawingml/2006/main" xmlns:r="http://schemas.openxmlformats.org/officeDocument/2006/relationships" xmlns:p="http://schemas.openxmlformats.org/presentationml/2006/main">
   <p:cSld>
     <p:spTree>

</xml_diff>

<commit_message>
changes to lecture 37 and 39 the heat engine lectures
</commit_message>
<xml_diff>
--- a/Lecture_Slides/PH 123 Lecture 36.pptx
+++ b/Lecture_Slides/PH 123 Lecture 36.pptx
@@ -7,12 +7,18 @@
   <p:sldIdLst>
     <p:sldId id="256" r:id="rId2"/>
     <p:sldId id="484" r:id="rId3"/>
-    <p:sldId id="341" r:id="rId4"/>
-    <p:sldId id="265" r:id="rId5"/>
-    <p:sldId id="285" r:id="rId6"/>
-    <p:sldId id="340" r:id="rId7"/>
-    <p:sldId id="283" r:id="rId8"/>
-    <p:sldId id="257" r:id="rId9"/>
+    <p:sldId id="485" r:id="rId4"/>
+    <p:sldId id="341" r:id="rId5"/>
+    <p:sldId id="487" r:id="rId6"/>
+    <p:sldId id="486" r:id="rId7"/>
+    <p:sldId id="488" r:id="rId8"/>
+    <p:sldId id="489" r:id="rId9"/>
+    <p:sldId id="490" r:id="rId10"/>
+    <p:sldId id="265" r:id="rId11"/>
+    <p:sldId id="285" r:id="rId12"/>
+    <p:sldId id="340" r:id="rId13"/>
+    <p:sldId id="283" r:id="rId14"/>
+    <p:sldId id="257" r:id="rId15"/>
   </p:sldIdLst>
   <p:sldSz cx="12192000" cy="6858000"/>
   <p:notesSz cx="6858000" cy="9144000"/>
@@ -122,7 +128,7 @@
 <file path=ppt/revisionInfo.xml><?xml version="1.0" encoding="utf-8"?>
 <p1510:revInfo xmlns:a="http://schemas.openxmlformats.org/drawingml/2006/main" xmlns:r="http://schemas.openxmlformats.org/officeDocument/2006/relationships" xmlns:p1510="http://schemas.microsoft.com/office/powerpoint/2015/10/main">
   <p1510:revLst>
-    <p1510:client id="{19433E2F-A7AC-4341-9FA4-5680B2C19CE3}" v="2" dt="2025-07-08T19:01:42.760"/>
+    <p1510:client id="{19433E2F-A7AC-4341-9FA4-5680B2C19CE3}" v="100" dt="2025-07-11T15:59:09.548"/>
   </p1510:revLst>
 </p1510:revInfo>
 </file>
@@ -131,8 +137,8 @@
 <pc:chgInfo xmlns:a="http://schemas.openxmlformats.org/drawingml/2006/main" xmlns:r="http://schemas.openxmlformats.org/officeDocument/2006/relationships" xmlns:ac="http://schemas.microsoft.com/office/drawing/2013/main/command" xmlns:pc="http://schemas.microsoft.com/office/powerpoint/2013/main/command">
   <pc:docChgLst>
     <pc:chgData name="Lines, Todd" userId="afaf7c3a-e8aa-4568-882a-02ad8f9e19b0" providerId="ADAL" clId="{19433E2F-A7AC-4341-9FA4-5680B2C19CE3}"/>
-    <pc:docChg chg="custSel addSld modSld">
-      <pc:chgData name="Lines, Todd" userId="afaf7c3a-e8aa-4568-882a-02ad8f9e19b0" providerId="ADAL" clId="{19433E2F-A7AC-4341-9FA4-5680B2C19CE3}" dt="2025-07-08T19:01:50.896" v="8" actId="20577"/>
+    <pc:docChg chg="custSel addSld delSld modSld">
+      <pc:chgData name="Lines, Todd" userId="afaf7c3a-e8aa-4568-882a-02ad8f9e19b0" providerId="ADAL" clId="{19433E2F-A7AC-4341-9FA4-5680B2C19CE3}" dt="2025-07-11T16:01:48.824" v="624" actId="20577"/>
       <pc:docMkLst>
         <pc:docMk/>
       </pc:docMkLst>
@@ -173,6 +179,126 @@
           </ac:spMkLst>
         </pc:spChg>
       </pc:sldChg>
+      <pc:sldChg chg="modSp add mod">
+        <pc:chgData name="Lines, Todd" userId="afaf7c3a-e8aa-4568-882a-02ad8f9e19b0" providerId="ADAL" clId="{19433E2F-A7AC-4341-9FA4-5680B2C19CE3}" dt="2025-07-10T19:08:35.353" v="84"/>
+        <pc:sldMkLst>
+          <pc:docMk/>
+          <pc:sldMk cId="3842804923" sldId="485"/>
+        </pc:sldMkLst>
+        <pc:spChg chg="mod">
+          <ac:chgData name="Lines, Todd" userId="afaf7c3a-e8aa-4568-882a-02ad8f9e19b0" providerId="ADAL" clId="{19433E2F-A7AC-4341-9FA4-5680B2C19CE3}" dt="2025-07-10T19:08:35.353" v="84"/>
+          <ac:spMkLst>
+            <pc:docMk/>
+            <pc:sldMk cId="3842804923" sldId="485"/>
+            <ac:spMk id="35843" creationId="{0880A836-F3E8-694F-BE88-C7B0C83B8377}"/>
+          </ac:spMkLst>
+        </pc:spChg>
+      </pc:sldChg>
+      <pc:sldChg chg="add">
+        <pc:chgData name="Lines, Todd" userId="afaf7c3a-e8aa-4568-882a-02ad8f9e19b0" providerId="ADAL" clId="{19433E2F-A7AC-4341-9FA4-5680B2C19CE3}" dt="2025-07-11T15:52:07.899" v="85"/>
+        <pc:sldMkLst>
+          <pc:docMk/>
+          <pc:sldMk cId="3465067879" sldId="486"/>
+        </pc:sldMkLst>
+      </pc:sldChg>
+      <pc:sldChg chg="modSp new mod">
+        <pc:chgData name="Lines, Todd" userId="afaf7c3a-e8aa-4568-882a-02ad8f9e19b0" providerId="ADAL" clId="{19433E2F-A7AC-4341-9FA4-5680B2C19CE3}" dt="2025-07-11T15:55:05.868" v="219" actId="20577"/>
+        <pc:sldMkLst>
+          <pc:docMk/>
+          <pc:sldMk cId="1446333334" sldId="487"/>
+        </pc:sldMkLst>
+        <pc:spChg chg="mod">
+          <ac:chgData name="Lines, Todd" userId="afaf7c3a-e8aa-4568-882a-02ad8f9e19b0" providerId="ADAL" clId="{19433E2F-A7AC-4341-9FA4-5680B2C19CE3}" dt="2025-07-11T15:52:13.279" v="94" actId="20577"/>
+          <ac:spMkLst>
+            <pc:docMk/>
+            <pc:sldMk cId="1446333334" sldId="487"/>
+            <ac:spMk id="2" creationId="{54610E40-E486-E84C-682C-6002987BB624}"/>
+          </ac:spMkLst>
+        </pc:spChg>
+        <pc:spChg chg="mod">
+          <ac:chgData name="Lines, Todd" userId="afaf7c3a-e8aa-4568-882a-02ad8f9e19b0" providerId="ADAL" clId="{19433E2F-A7AC-4341-9FA4-5680B2C19CE3}" dt="2025-07-11T15:55:05.868" v="219" actId="20577"/>
+          <ac:spMkLst>
+            <pc:docMk/>
+            <pc:sldMk cId="1446333334" sldId="487"/>
+            <ac:spMk id="3" creationId="{08537D8D-6AC6-1433-021B-54F0CF486FA0}"/>
+          </ac:spMkLst>
+        </pc:spChg>
+      </pc:sldChg>
+      <pc:sldChg chg="modSp add mod">
+        <pc:chgData name="Lines, Todd" userId="afaf7c3a-e8aa-4568-882a-02ad8f9e19b0" providerId="ADAL" clId="{19433E2F-A7AC-4341-9FA4-5680B2C19CE3}" dt="2025-07-11T15:59:20.973" v="355" actId="20577"/>
+        <pc:sldMkLst>
+          <pc:docMk/>
+          <pc:sldMk cId="2389341818" sldId="488"/>
+        </pc:sldMkLst>
+        <pc:spChg chg="mod">
+          <ac:chgData name="Lines, Todd" userId="afaf7c3a-e8aa-4568-882a-02ad8f9e19b0" providerId="ADAL" clId="{19433E2F-A7AC-4341-9FA4-5680B2C19CE3}" dt="2025-07-11T15:59:20.973" v="355" actId="20577"/>
+          <ac:spMkLst>
+            <pc:docMk/>
+            <pc:sldMk cId="2389341818" sldId="488"/>
+            <ac:spMk id="3" creationId="{6F64307E-3582-259B-6FFF-E34800D93684}"/>
+          </ac:spMkLst>
+        </pc:spChg>
+      </pc:sldChg>
+      <pc:sldChg chg="add del">
+        <pc:chgData name="Lines, Todd" userId="afaf7c3a-e8aa-4568-882a-02ad8f9e19b0" providerId="ADAL" clId="{19433E2F-A7AC-4341-9FA4-5680B2C19CE3}" dt="2025-07-11T15:55:56.334" v="221" actId="47"/>
+        <pc:sldMkLst>
+          <pc:docMk/>
+          <pc:sldMk cId="3237716521" sldId="488"/>
+        </pc:sldMkLst>
+      </pc:sldChg>
+      <pc:sldChg chg="add del">
+        <pc:chgData name="Lines, Todd" userId="afaf7c3a-e8aa-4568-882a-02ad8f9e19b0" providerId="ADAL" clId="{19433E2F-A7AC-4341-9FA4-5680B2C19CE3}" dt="2025-07-11T15:57:59.888" v="269"/>
+        <pc:sldMkLst>
+          <pc:docMk/>
+          <pc:sldMk cId="1831025676" sldId="489"/>
+        </pc:sldMkLst>
+      </pc:sldChg>
+      <pc:sldChg chg="modSp new mod">
+        <pc:chgData name="Lines, Todd" userId="afaf7c3a-e8aa-4568-882a-02ad8f9e19b0" providerId="ADAL" clId="{19433E2F-A7AC-4341-9FA4-5680B2C19CE3}" dt="2025-07-11T16:00:13.225" v="435" actId="20577"/>
+        <pc:sldMkLst>
+          <pc:docMk/>
+          <pc:sldMk cId="2851887090" sldId="489"/>
+        </pc:sldMkLst>
+        <pc:spChg chg="mod">
+          <ac:chgData name="Lines, Todd" userId="afaf7c3a-e8aa-4568-882a-02ad8f9e19b0" providerId="ADAL" clId="{19433E2F-A7AC-4341-9FA4-5680B2C19CE3}" dt="2025-07-11T15:59:42.281" v="364" actId="20577"/>
+          <ac:spMkLst>
+            <pc:docMk/>
+            <pc:sldMk cId="2851887090" sldId="489"/>
+            <ac:spMk id="2" creationId="{7D432002-FF55-F810-0DAE-FAE499C324E4}"/>
+          </ac:spMkLst>
+        </pc:spChg>
+        <pc:spChg chg="mod">
+          <ac:chgData name="Lines, Todd" userId="afaf7c3a-e8aa-4568-882a-02ad8f9e19b0" providerId="ADAL" clId="{19433E2F-A7AC-4341-9FA4-5680B2C19CE3}" dt="2025-07-11T16:00:13.225" v="435" actId="20577"/>
+          <ac:spMkLst>
+            <pc:docMk/>
+            <pc:sldMk cId="2851887090" sldId="489"/>
+            <ac:spMk id="3" creationId="{029605CA-880A-29C8-6C74-7E7688FE48C5}"/>
+          </ac:spMkLst>
+        </pc:spChg>
+      </pc:sldChg>
+      <pc:sldChg chg="modSp new mod">
+        <pc:chgData name="Lines, Todd" userId="afaf7c3a-e8aa-4568-882a-02ad8f9e19b0" providerId="ADAL" clId="{19433E2F-A7AC-4341-9FA4-5680B2C19CE3}" dt="2025-07-11T16:01:48.824" v="624" actId="20577"/>
+        <pc:sldMkLst>
+          <pc:docMk/>
+          <pc:sldMk cId="3378814276" sldId="490"/>
+        </pc:sldMkLst>
+        <pc:spChg chg="mod">
+          <ac:chgData name="Lines, Todd" userId="afaf7c3a-e8aa-4568-882a-02ad8f9e19b0" providerId="ADAL" clId="{19433E2F-A7AC-4341-9FA4-5680B2C19CE3}" dt="2025-07-11T16:00:45.529" v="444" actId="20577"/>
+          <ac:spMkLst>
+            <pc:docMk/>
+            <pc:sldMk cId="3378814276" sldId="490"/>
+            <ac:spMk id="2" creationId="{36C05A08-BBAD-733F-9214-FFCA080F07AC}"/>
+          </ac:spMkLst>
+        </pc:spChg>
+        <pc:spChg chg="mod">
+          <ac:chgData name="Lines, Todd" userId="afaf7c3a-e8aa-4568-882a-02ad8f9e19b0" providerId="ADAL" clId="{19433E2F-A7AC-4341-9FA4-5680B2C19CE3}" dt="2025-07-11T16:01:48.824" v="624" actId="20577"/>
+          <ac:spMkLst>
+            <pc:docMk/>
+            <pc:sldMk cId="3378814276" sldId="490"/>
+            <ac:spMk id="3" creationId="{857BFD40-4C1B-BCE6-1015-757E5ACBD398}"/>
+          </ac:spMkLst>
+        </pc:spChg>
+      </pc:sldChg>
     </pc:docChg>
   </pc:docChgLst>
 </pc:chgInfo>
@@ -325,7 +451,7 @@
           <a:p>
             <a:fld id="{5D14FE54-3E4B-43AC-AC6A-78E009FC7A62}" type="datetimeFigureOut">
               <a:rPr lang="en-US" smtClean="0"/>
-              <a:t>7/8/2025</a:t>
+              <a:t>7/11/2025</a:t>
             </a:fld>
             <a:endParaRPr lang="en-US"/>
           </a:p>
@@ -523,7 +649,7 @@
           <a:p>
             <a:fld id="{5D14FE54-3E4B-43AC-AC6A-78E009FC7A62}" type="datetimeFigureOut">
               <a:rPr lang="en-US" smtClean="0"/>
-              <a:t>7/8/2025</a:t>
+              <a:t>7/11/2025</a:t>
             </a:fld>
             <a:endParaRPr lang="en-US"/>
           </a:p>
@@ -731,7 +857,7 @@
           <a:p>
             <a:fld id="{5D14FE54-3E4B-43AC-AC6A-78E009FC7A62}" type="datetimeFigureOut">
               <a:rPr lang="en-US" smtClean="0"/>
-              <a:t>7/8/2025</a:t>
+              <a:t>7/11/2025</a:t>
             </a:fld>
             <a:endParaRPr lang="en-US"/>
           </a:p>
@@ -929,7 +1055,7 @@
           <a:p>
             <a:fld id="{5D14FE54-3E4B-43AC-AC6A-78E009FC7A62}" type="datetimeFigureOut">
               <a:rPr lang="en-US" smtClean="0"/>
-              <a:t>7/8/2025</a:t>
+              <a:t>7/11/2025</a:t>
             </a:fld>
             <a:endParaRPr lang="en-US"/>
           </a:p>
@@ -1204,7 +1330,7 @@
           <a:p>
             <a:fld id="{5D14FE54-3E4B-43AC-AC6A-78E009FC7A62}" type="datetimeFigureOut">
               <a:rPr lang="en-US" smtClean="0"/>
-              <a:t>7/8/2025</a:t>
+              <a:t>7/11/2025</a:t>
             </a:fld>
             <a:endParaRPr lang="en-US"/>
           </a:p>
@@ -1469,7 +1595,7 @@
           <a:p>
             <a:fld id="{5D14FE54-3E4B-43AC-AC6A-78E009FC7A62}" type="datetimeFigureOut">
               <a:rPr lang="en-US" smtClean="0"/>
-              <a:t>7/8/2025</a:t>
+              <a:t>7/11/2025</a:t>
             </a:fld>
             <a:endParaRPr lang="en-US"/>
           </a:p>
@@ -1881,7 +2007,7 @@
           <a:p>
             <a:fld id="{5D14FE54-3E4B-43AC-AC6A-78E009FC7A62}" type="datetimeFigureOut">
               <a:rPr lang="en-US" smtClean="0"/>
-              <a:t>7/8/2025</a:t>
+              <a:t>7/11/2025</a:t>
             </a:fld>
             <a:endParaRPr lang="en-US"/>
           </a:p>
@@ -2022,7 +2148,7 @@
           <a:p>
             <a:fld id="{5D14FE54-3E4B-43AC-AC6A-78E009FC7A62}" type="datetimeFigureOut">
               <a:rPr lang="en-US" smtClean="0"/>
-              <a:t>7/8/2025</a:t>
+              <a:t>7/11/2025</a:t>
             </a:fld>
             <a:endParaRPr lang="en-US"/>
           </a:p>
@@ -2135,7 +2261,7 @@
           <a:p>
             <a:fld id="{5D14FE54-3E4B-43AC-AC6A-78E009FC7A62}" type="datetimeFigureOut">
               <a:rPr lang="en-US" smtClean="0"/>
-              <a:t>7/8/2025</a:t>
+              <a:t>7/11/2025</a:t>
             </a:fld>
             <a:endParaRPr lang="en-US"/>
           </a:p>
@@ -2446,7 +2572,7 @@
           <a:p>
             <a:fld id="{5D14FE54-3E4B-43AC-AC6A-78E009FC7A62}" type="datetimeFigureOut">
               <a:rPr lang="en-US" smtClean="0"/>
-              <a:t>7/8/2025</a:t>
+              <a:t>7/11/2025</a:t>
             </a:fld>
             <a:endParaRPr lang="en-US"/>
           </a:p>
@@ -2734,7 +2860,7 @@
           <a:p>
             <a:fld id="{5D14FE54-3E4B-43AC-AC6A-78E009FC7A62}" type="datetimeFigureOut">
               <a:rPr lang="en-US" smtClean="0"/>
-              <a:t>7/8/2025</a:t>
+              <a:t>7/11/2025</a:t>
             </a:fld>
             <a:endParaRPr lang="en-US"/>
           </a:p>
@@ -2975,7 +3101,7 @@
           <a:p>
             <a:fld id="{5D14FE54-3E4B-43AC-AC6A-78E009FC7A62}" type="datetimeFigureOut">
               <a:rPr lang="en-US" smtClean="0"/>
-              <a:t>7/8/2025</a:t>
+              <a:t>7/11/2025</a:t>
             </a:fld>
             <a:endParaRPr lang="en-US"/>
           </a:p>
@@ -3458,6 +3584,1214 @@
 </p:sld>
 </file>
 
+<file path=ppt/slides/slide10.xml><?xml version="1.0" encoding="utf-8"?>
+<p:sld xmlns:a="http://schemas.openxmlformats.org/drawingml/2006/main" xmlns:r="http://schemas.openxmlformats.org/officeDocument/2006/relationships" xmlns:p="http://schemas.openxmlformats.org/presentationml/2006/main">
+  <p:cSld>
+    <p:spTree>
+      <p:nvGrpSpPr>
+        <p:cNvPr id="1" name=""/>
+        <p:cNvGrpSpPr/>
+        <p:nvPr/>
+      </p:nvGrpSpPr>
+      <p:grpSpPr>
+        <a:xfrm>
+          <a:off x="0" y="0"/>
+          <a:ext cx="0" cy="0"/>
+          <a:chOff x="0" y="0"/>
+          <a:chExt cx="0" cy="0"/>
+        </a:xfrm>
+      </p:grpSpPr>
+      <p:sp>
+        <p:nvSpPr>
+          <p:cNvPr id="2" name="Title 1"/>
+          <p:cNvSpPr>
+            <a:spLocks noGrp="1"/>
+          </p:cNvSpPr>
+          <p:nvPr>
+            <p:ph type="title"/>
+          </p:nvPr>
+        </p:nvSpPr>
+        <p:spPr/>
+        <p:txBody>
+          <a:bodyPr/>
+          <a:lstStyle/>
+          <a:p>
+            <a:endParaRPr lang="en-US"/>
+          </a:p>
+        </p:txBody>
+      </p:sp>
+      <p:sp>
+        <p:nvSpPr>
+          <p:cNvPr id="3" name="Content Placeholder 2"/>
+          <p:cNvSpPr>
+            <a:spLocks noGrp="1"/>
+          </p:cNvSpPr>
+          <p:nvPr>
+            <p:ph idx="1"/>
+          </p:nvPr>
+        </p:nvSpPr>
+        <p:spPr/>
+        <p:txBody>
+          <a:bodyPr/>
+          <a:lstStyle/>
+          <a:p>
+            <a:endParaRPr lang="en-US"/>
+          </a:p>
+        </p:txBody>
+      </p:sp>
+      <p:pic>
+        <p:nvPicPr>
+          <p:cNvPr id="7170" name="Picture 2"/>
+          <p:cNvPicPr>
+            <a:picLocks noChangeAspect="1" noChangeArrowheads="1"/>
+          </p:cNvPicPr>
+          <p:nvPr/>
+        </p:nvPicPr>
+        <p:blipFill>
+          <a:blip r:embed="rId2" cstate="print"/>
+          <a:srcRect/>
+          <a:stretch>
+            <a:fillRect/>
+          </a:stretch>
+        </p:blipFill>
+        <p:spPr bwMode="auto">
+          <a:xfrm>
+            <a:off x="1905000" y="642082"/>
+            <a:ext cx="8650174" cy="5758718"/>
+          </a:xfrm>
+          <a:prstGeom prst="rect">
+            <a:avLst/>
+          </a:prstGeom>
+          <a:noFill/>
+          <a:ln w="9525">
+            <a:noFill/>
+            <a:miter lim="800000"/>
+            <a:headEnd/>
+            <a:tailEnd/>
+          </a:ln>
+          <a:effectLst/>
+        </p:spPr>
+      </p:pic>
+    </p:spTree>
+  </p:cSld>
+  <p:clrMapOvr>
+    <a:masterClrMapping/>
+  </p:clrMapOvr>
+</p:sld>
+</file>
+
+<file path=ppt/slides/slide11.xml><?xml version="1.0" encoding="utf-8"?>
+<p:sld xmlns:a="http://schemas.openxmlformats.org/drawingml/2006/main" xmlns:r="http://schemas.openxmlformats.org/officeDocument/2006/relationships" xmlns:p="http://schemas.openxmlformats.org/presentationml/2006/main">
+  <p:cSld>
+    <p:spTree>
+      <p:nvGrpSpPr>
+        <p:cNvPr id="1" name=""/>
+        <p:cNvGrpSpPr/>
+        <p:nvPr/>
+      </p:nvGrpSpPr>
+      <p:grpSpPr>
+        <a:xfrm>
+          <a:off x="0" y="0"/>
+          <a:ext cx="0" cy="0"/>
+          <a:chOff x="0" y="0"/>
+          <a:chExt cx="0" cy="0"/>
+        </a:xfrm>
+      </p:grpSpPr>
+      <p:pic>
+        <p:nvPicPr>
+          <p:cNvPr id="1030" name="Picture 6"/>
+          <p:cNvPicPr>
+            <a:picLocks noChangeAspect="1" noChangeArrowheads="1"/>
+          </p:cNvPicPr>
+          <p:nvPr/>
+        </p:nvPicPr>
+        <p:blipFill>
+          <a:blip r:embed="rId2" cstate="print"/>
+          <a:srcRect/>
+          <a:stretch>
+            <a:fillRect/>
+          </a:stretch>
+        </p:blipFill>
+        <p:spPr bwMode="auto">
+          <a:xfrm>
+            <a:off x="7162801" y="1828800"/>
+            <a:ext cx="1869243" cy="1822450"/>
+          </a:xfrm>
+          <a:prstGeom prst="rect">
+            <a:avLst/>
+          </a:prstGeom>
+          <a:noFill/>
+          <a:ln w="9525">
+            <a:noFill/>
+            <a:miter lim="800000"/>
+            <a:headEnd/>
+            <a:tailEnd/>
+          </a:ln>
+          <a:effectLst/>
+        </p:spPr>
+      </p:pic>
+      <p:sp>
+        <p:nvSpPr>
+          <p:cNvPr id="2" name="Title 1"/>
+          <p:cNvSpPr>
+            <a:spLocks noGrp="1"/>
+          </p:cNvSpPr>
+          <p:nvPr>
+            <p:ph type="title"/>
+          </p:nvPr>
+        </p:nvSpPr>
+        <p:spPr/>
+        <p:txBody>
+          <a:bodyPr/>
+          <a:lstStyle/>
+          <a:p>
+            <a:endParaRPr lang="en-US" dirty="0"/>
+          </a:p>
+        </p:txBody>
+      </p:sp>
+      <p:sp>
+        <p:nvSpPr>
+          <p:cNvPr id="4" name="Rectangle 2"/>
+          <p:cNvSpPr>
+            <a:spLocks noChangeArrowheads="1"/>
+          </p:cNvSpPr>
+          <p:nvPr/>
+        </p:nvSpPr>
+        <p:spPr bwMode="auto">
+          <a:xfrm>
+            <a:off x="2743201" y="3519488"/>
+            <a:ext cx="2511425" cy="1871663"/>
+          </a:xfrm>
+          <a:prstGeom prst="rect">
+            <a:avLst/>
+          </a:prstGeom>
+          <a:gradFill rotWithShape="1">
+            <a:gsLst>
+              <a:gs pos="0">
+                <a:schemeClr val="bg1"/>
+              </a:gs>
+              <a:gs pos="100000">
+                <a:schemeClr val="accent1"/>
+              </a:gs>
+            </a:gsLst>
+            <a:path path="shape">
+              <a:fillToRect l="50000" t="50000" r="50000" b="50000"/>
+            </a:path>
+          </a:gradFill>
+          <a:ln w="9525" algn="ctr">
+            <a:solidFill>
+              <a:schemeClr val="tx1"/>
+            </a:solidFill>
+            <a:miter lim="800000"/>
+            <a:headEnd/>
+            <a:tailEnd/>
+          </a:ln>
+        </p:spPr>
+        <p:txBody>
+          <a:bodyPr wrap="none" anchor="ctr"/>
+          <a:lstStyle/>
+          <a:p>
+            <a:pPr algn="ctr"/>
+            <a:r>
+              <a:rPr lang="en-US"/>
+              <a:t>Gas at T</a:t>
+            </a:r>
+            <a:r>
+              <a:rPr lang="en-US" baseline="-25000"/>
+              <a:t>i</a:t>
+            </a:r>
+          </a:p>
+        </p:txBody>
+      </p:sp>
+      <p:sp>
+        <p:nvSpPr>
+          <p:cNvPr id="5" name="Rectangle 5"/>
+          <p:cNvSpPr>
+            <a:spLocks noChangeArrowheads="1"/>
+          </p:cNvSpPr>
+          <p:nvPr/>
+        </p:nvSpPr>
+        <p:spPr bwMode="auto">
+          <a:xfrm>
+            <a:off x="2743201" y="1676401"/>
+            <a:ext cx="2511425" cy="3730625"/>
+          </a:xfrm>
+          <a:prstGeom prst="rect">
+            <a:avLst/>
+          </a:prstGeom>
+          <a:noFill/>
+          <a:ln w="53975" algn="ctr">
+            <a:solidFill>
+              <a:srgbClr val="FF9900"/>
+            </a:solidFill>
+            <a:miter lim="800000"/>
+            <a:headEnd/>
+            <a:tailEnd/>
+          </a:ln>
+        </p:spPr>
+        <p:txBody>
+          <a:bodyPr wrap="none" anchor="ctr"/>
+          <a:lstStyle/>
+          <a:p>
+            <a:endParaRPr lang="en-US"/>
+          </a:p>
+        </p:txBody>
+      </p:sp>
+      <p:sp>
+        <p:nvSpPr>
+          <p:cNvPr id="6" name="Line 6"/>
+          <p:cNvSpPr>
+            <a:spLocks noChangeShapeType="1"/>
+          </p:cNvSpPr>
+          <p:nvPr/>
+        </p:nvSpPr>
+        <p:spPr bwMode="auto">
+          <a:xfrm>
+            <a:off x="2728913" y="3533775"/>
+            <a:ext cx="2525713" cy="0"/>
+          </a:xfrm>
+          <a:prstGeom prst="line">
+            <a:avLst/>
+          </a:prstGeom>
+          <a:noFill/>
+          <a:ln w="9525">
+            <a:solidFill>
+              <a:srgbClr val="FF0000"/>
+            </a:solidFill>
+            <a:round/>
+            <a:headEnd/>
+            <a:tailEnd/>
+          </a:ln>
+        </p:spPr>
+        <p:txBody>
+          <a:bodyPr wrap="none" anchor="ctr"/>
+          <a:lstStyle/>
+          <a:p>
+            <a:endParaRPr lang="en-US"/>
+          </a:p>
+        </p:txBody>
+      </p:sp>
+      <p:sp>
+        <p:nvSpPr>
+          <p:cNvPr id="7" name="Text Box 7"/>
+          <p:cNvSpPr txBox="1">
+            <a:spLocks noChangeArrowheads="1"/>
+          </p:cNvSpPr>
+          <p:nvPr/>
+        </p:nvSpPr>
+        <p:spPr bwMode="auto">
+          <a:xfrm>
+            <a:off x="3438525" y="2147888"/>
+            <a:ext cx="1136650" cy="366713"/>
+          </a:xfrm>
+          <a:prstGeom prst="rect">
+            <a:avLst/>
+          </a:prstGeom>
+          <a:noFill/>
+          <a:ln w="9525" algn="ctr">
+            <a:noFill/>
+            <a:miter lim="800000"/>
+            <a:headEnd/>
+            <a:tailEnd/>
+          </a:ln>
+        </p:spPr>
+        <p:txBody>
+          <a:bodyPr>
+            <a:spAutoFit/>
+          </a:bodyPr>
+          <a:lstStyle/>
+          <a:p>
+            <a:pPr algn="ctr"/>
+            <a:r>
+              <a:rPr lang="en-US"/>
+              <a:t>Vacuum</a:t>
+            </a:r>
+          </a:p>
+        </p:txBody>
+      </p:sp>
+      <p:sp>
+        <p:nvSpPr>
+          <p:cNvPr id="8" name="Text Box 8"/>
+          <p:cNvSpPr txBox="1">
+            <a:spLocks noChangeArrowheads="1"/>
+          </p:cNvSpPr>
+          <p:nvPr/>
+        </p:nvSpPr>
+        <p:spPr bwMode="auto">
+          <a:xfrm>
+            <a:off x="2619376" y="2954338"/>
+            <a:ext cx="1920875" cy="366713"/>
+          </a:xfrm>
+          <a:prstGeom prst="rect">
+            <a:avLst/>
+          </a:prstGeom>
+          <a:noFill/>
+          <a:ln w="9525" algn="ctr">
+            <a:noFill/>
+            <a:miter lim="800000"/>
+            <a:headEnd/>
+            <a:tailEnd/>
+          </a:ln>
+        </p:spPr>
+        <p:txBody>
+          <a:bodyPr>
+            <a:spAutoFit/>
+          </a:bodyPr>
+          <a:lstStyle/>
+          <a:p>
+            <a:pPr algn="ctr"/>
+            <a:r>
+              <a:rPr lang="en-US"/>
+              <a:t>Membrane</a:t>
+            </a:r>
+          </a:p>
+        </p:txBody>
+      </p:sp>
+      <p:sp>
+        <p:nvSpPr>
+          <p:cNvPr id="9" name="Line 9"/>
+          <p:cNvSpPr>
+            <a:spLocks noChangeShapeType="1"/>
+          </p:cNvSpPr>
+          <p:nvPr/>
+        </p:nvSpPr>
+        <p:spPr bwMode="auto">
+          <a:xfrm flipH="1">
+            <a:off x="3367087" y="3243263"/>
+            <a:ext cx="115888" cy="276225"/>
+          </a:xfrm>
+          <a:prstGeom prst="line">
+            <a:avLst/>
+          </a:prstGeom>
+          <a:noFill/>
+          <a:ln w="9525">
+            <a:solidFill>
+              <a:schemeClr val="tx1"/>
+            </a:solidFill>
+            <a:round/>
+            <a:headEnd/>
+            <a:tailEnd type="triangle" w="med" len="med"/>
+          </a:ln>
+        </p:spPr>
+        <p:txBody>
+          <a:bodyPr wrap="none" anchor="ctr"/>
+          <a:lstStyle/>
+          <a:p>
+            <a:endParaRPr lang="en-US"/>
+          </a:p>
+        </p:txBody>
+      </p:sp>
+      <p:sp>
+        <p:nvSpPr>
+          <p:cNvPr id="11" name="Rectangle 5"/>
+          <p:cNvSpPr>
+            <a:spLocks noChangeArrowheads="1"/>
+          </p:cNvSpPr>
+          <p:nvPr/>
+        </p:nvSpPr>
+        <p:spPr bwMode="auto">
+          <a:xfrm>
+            <a:off x="6629401" y="1676401"/>
+            <a:ext cx="2511425" cy="3730625"/>
+          </a:xfrm>
+          <a:prstGeom prst="rect">
+            <a:avLst/>
+          </a:prstGeom>
+          <a:noFill/>
+          <a:ln w="53975" algn="ctr">
+            <a:solidFill>
+              <a:srgbClr val="FF9900"/>
+            </a:solidFill>
+            <a:miter lim="800000"/>
+            <a:headEnd/>
+            <a:tailEnd/>
+          </a:ln>
+        </p:spPr>
+        <p:txBody>
+          <a:bodyPr wrap="none" anchor="ctr"/>
+          <a:lstStyle/>
+          <a:p>
+            <a:endParaRPr lang="en-US"/>
+          </a:p>
+        </p:txBody>
+      </p:sp>
+      <p:sp>
+        <p:nvSpPr>
+          <p:cNvPr id="12" name="Line 6"/>
+          <p:cNvSpPr>
+            <a:spLocks noChangeShapeType="1"/>
+          </p:cNvSpPr>
+          <p:nvPr/>
+        </p:nvSpPr>
+        <p:spPr bwMode="auto">
+          <a:xfrm>
+            <a:off x="6615113" y="3533775"/>
+            <a:ext cx="2525713" cy="0"/>
+          </a:xfrm>
+          <a:prstGeom prst="line">
+            <a:avLst/>
+          </a:prstGeom>
+          <a:noFill/>
+          <a:ln w="9525">
+            <a:solidFill>
+              <a:srgbClr val="FF0000"/>
+            </a:solidFill>
+            <a:round/>
+            <a:headEnd/>
+            <a:tailEnd/>
+          </a:ln>
+        </p:spPr>
+        <p:txBody>
+          <a:bodyPr wrap="none" anchor="ctr"/>
+          <a:lstStyle/>
+          <a:p>
+            <a:endParaRPr lang="en-US"/>
+          </a:p>
+        </p:txBody>
+      </p:sp>
+      <p:sp>
+        <p:nvSpPr>
+          <p:cNvPr id="14" name="Text Box 8"/>
+          <p:cNvSpPr txBox="1">
+            <a:spLocks noChangeArrowheads="1"/>
+          </p:cNvSpPr>
+          <p:nvPr/>
+        </p:nvSpPr>
+        <p:spPr bwMode="auto">
+          <a:xfrm>
+            <a:off x="6505576" y="2954338"/>
+            <a:ext cx="1920875" cy="366713"/>
+          </a:xfrm>
+          <a:prstGeom prst="rect">
+            <a:avLst/>
+          </a:prstGeom>
+          <a:noFill/>
+          <a:ln w="9525" algn="ctr">
+            <a:noFill/>
+            <a:miter lim="800000"/>
+            <a:headEnd/>
+            <a:tailEnd/>
+          </a:ln>
+        </p:spPr>
+        <p:txBody>
+          <a:bodyPr>
+            <a:spAutoFit/>
+          </a:bodyPr>
+          <a:lstStyle/>
+          <a:p>
+            <a:pPr algn="ctr"/>
+            <a:r>
+              <a:rPr lang="en-US"/>
+              <a:t>Membrane</a:t>
+            </a:r>
+          </a:p>
+        </p:txBody>
+      </p:sp>
+      <p:sp>
+        <p:nvSpPr>
+          <p:cNvPr id="15" name="Line 9"/>
+          <p:cNvSpPr>
+            <a:spLocks noChangeShapeType="1"/>
+          </p:cNvSpPr>
+          <p:nvPr/>
+        </p:nvSpPr>
+        <p:spPr bwMode="auto">
+          <a:xfrm flipH="1">
+            <a:off x="7253287" y="3243263"/>
+            <a:ext cx="115888" cy="276225"/>
+          </a:xfrm>
+          <a:prstGeom prst="line">
+            <a:avLst/>
+          </a:prstGeom>
+          <a:noFill/>
+          <a:ln w="9525">
+            <a:solidFill>
+              <a:schemeClr val="tx1"/>
+            </a:solidFill>
+            <a:round/>
+            <a:headEnd/>
+            <a:tailEnd type="triangle" w="med" len="med"/>
+          </a:ln>
+        </p:spPr>
+        <p:txBody>
+          <a:bodyPr wrap="none" anchor="ctr"/>
+          <a:lstStyle/>
+          <a:p>
+            <a:endParaRPr lang="en-US"/>
+          </a:p>
+        </p:txBody>
+      </p:sp>
+      <p:sp>
+        <p:nvSpPr>
+          <p:cNvPr id="10" name="Rectangle 2"/>
+          <p:cNvSpPr>
+            <a:spLocks noChangeArrowheads="1"/>
+          </p:cNvSpPr>
+          <p:nvPr/>
+        </p:nvSpPr>
+        <p:spPr bwMode="auto">
+          <a:xfrm>
+            <a:off x="6629401" y="3519488"/>
+            <a:ext cx="2511425" cy="1871663"/>
+          </a:xfrm>
+          <a:prstGeom prst="rect">
+            <a:avLst/>
+          </a:prstGeom>
+          <a:gradFill rotWithShape="1">
+            <a:gsLst>
+              <a:gs pos="0">
+                <a:schemeClr val="bg1"/>
+              </a:gs>
+              <a:gs pos="100000">
+                <a:schemeClr val="accent1"/>
+              </a:gs>
+            </a:gsLst>
+            <a:path path="shape">
+              <a:fillToRect l="50000" t="50000" r="50000" b="50000"/>
+            </a:path>
+          </a:gradFill>
+          <a:ln w="9525" algn="ctr">
+            <a:solidFill>
+              <a:schemeClr val="tx1"/>
+            </a:solidFill>
+            <a:miter lim="800000"/>
+            <a:headEnd/>
+            <a:tailEnd/>
+          </a:ln>
+        </p:spPr>
+        <p:txBody>
+          <a:bodyPr wrap="none" anchor="ctr"/>
+          <a:lstStyle/>
+          <a:p>
+            <a:pPr algn="ctr"/>
+            <a:r>
+              <a:rPr lang="en-US"/>
+              <a:t>Gas at T</a:t>
+            </a:r>
+            <a:r>
+              <a:rPr lang="en-US" baseline="-25000"/>
+              <a:t>i</a:t>
+            </a:r>
+          </a:p>
+        </p:txBody>
+      </p:sp>
+      <p:sp>
+        <p:nvSpPr>
+          <p:cNvPr id="16" name="Rectangle 15"/>
+          <p:cNvSpPr/>
+          <p:nvPr/>
+        </p:nvSpPr>
+        <p:spPr>
+          <a:xfrm>
+            <a:off x="8382000" y="3505200"/>
+            <a:ext cx="152400" cy="76200"/>
+          </a:xfrm>
+          <a:prstGeom prst="rect">
+            <a:avLst/>
+          </a:prstGeom>
+          <a:solidFill>
+            <a:schemeClr val="accent1"/>
+          </a:solidFill>
+          <a:ln>
+            <a:noFill/>
+          </a:ln>
+        </p:spPr>
+        <p:style>
+          <a:lnRef idx="2">
+            <a:schemeClr val="accent1">
+              <a:shade val="50000"/>
+            </a:schemeClr>
+          </a:lnRef>
+          <a:fillRef idx="1">
+            <a:schemeClr val="accent1"/>
+          </a:fillRef>
+          <a:effectRef idx="0">
+            <a:schemeClr val="accent1"/>
+          </a:effectRef>
+          <a:fontRef idx="minor">
+            <a:schemeClr val="lt1"/>
+          </a:fontRef>
+        </p:style>
+        <p:txBody>
+          <a:bodyPr rtlCol="0" anchor="ctr"/>
+          <a:lstStyle/>
+          <a:p>
+            <a:pPr algn="ctr"/>
+            <a:endParaRPr lang="en-US"/>
+          </a:p>
+        </p:txBody>
+      </p:sp>
+    </p:spTree>
+  </p:cSld>
+  <p:clrMapOvr>
+    <a:masterClrMapping/>
+  </p:clrMapOvr>
+</p:sld>
+</file>
+
+<file path=ppt/slides/slide12.xml><?xml version="1.0" encoding="utf-8"?>
+<p:sld xmlns:a="http://schemas.openxmlformats.org/drawingml/2006/main" xmlns:r="http://schemas.openxmlformats.org/officeDocument/2006/relationships" xmlns:p="http://schemas.openxmlformats.org/presentationml/2006/main">
+  <p:cSld>
+    <p:spTree>
+      <p:nvGrpSpPr>
+        <p:cNvPr id="1" name=""/>
+        <p:cNvGrpSpPr/>
+        <p:nvPr/>
+      </p:nvGrpSpPr>
+      <p:grpSpPr>
+        <a:xfrm>
+          <a:off x="0" y="0"/>
+          <a:ext cx="0" cy="0"/>
+          <a:chOff x="0" y="0"/>
+          <a:chExt cx="0" cy="0"/>
+        </a:xfrm>
+      </p:grpSpPr>
+      <p:sp>
+        <p:nvSpPr>
+          <p:cNvPr id="2" name="Title 1"/>
+          <p:cNvSpPr>
+            <a:spLocks noGrp="1"/>
+          </p:cNvSpPr>
+          <p:nvPr>
+            <p:ph type="title"/>
+          </p:nvPr>
+        </p:nvSpPr>
+        <p:spPr/>
+        <p:txBody>
+          <a:bodyPr/>
+          <a:lstStyle/>
+          <a:p>
+            <a:endParaRPr lang="en-US"/>
+          </a:p>
+        </p:txBody>
+      </p:sp>
+      <p:sp>
+        <p:nvSpPr>
+          <p:cNvPr id="3" name="Content Placeholder 2"/>
+          <p:cNvSpPr>
+            <a:spLocks noGrp="1"/>
+          </p:cNvSpPr>
+          <p:nvPr>
+            <p:ph idx="1"/>
+          </p:nvPr>
+        </p:nvSpPr>
+        <p:spPr/>
+        <p:txBody>
+          <a:bodyPr/>
+          <a:lstStyle/>
+          <a:p>
+            <a:endParaRPr lang="en-US"/>
+          </a:p>
+        </p:txBody>
+      </p:sp>
+      <p:pic>
+        <p:nvPicPr>
+          <p:cNvPr id="6146" name="Picture 2"/>
+          <p:cNvPicPr>
+            <a:picLocks noChangeAspect="1" noChangeArrowheads="1"/>
+          </p:cNvPicPr>
+          <p:nvPr/>
+        </p:nvPicPr>
+        <p:blipFill>
+          <a:blip r:embed="rId2" cstate="print"/>
+          <a:srcRect/>
+          <a:stretch>
+            <a:fillRect/>
+          </a:stretch>
+        </p:blipFill>
+        <p:spPr bwMode="auto">
+          <a:xfrm>
+            <a:off x="2971800" y="533401"/>
+            <a:ext cx="5181600" cy="5252339"/>
+          </a:xfrm>
+          <a:prstGeom prst="rect">
+            <a:avLst/>
+          </a:prstGeom>
+          <a:noFill/>
+          <a:ln w="9525">
+            <a:noFill/>
+            <a:miter lim="800000"/>
+            <a:headEnd/>
+            <a:tailEnd/>
+          </a:ln>
+          <a:effectLst/>
+        </p:spPr>
+      </p:pic>
+    </p:spTree>
+  </p:cSld>
+  <p:clrMapOvr>
+    <a:masterClrMapping/>
+  </p:clrMapOvr>
+</p:sld>
+</file>
+
+<file path=ppt/slides/slide13.xml><?xml version="1.0" encoding="utf-8"?>
+<p:sld xmlns:a="http://schemas.openxmlformats.org/drawingml/2006/main" xmlns:r="http://schemas.openxmlformats.org/officeDocument/2006/relationships" xmlns:p="http://schemas.openxmlformats.org/presentationml/2006/main">
+  <p:cSld>
+    <p:spTree>
+      <p:nvGrpSpPr>
+        <p:cNvPr id="1" name=""/>
+        <p:cNvGrpSpPr/>
+        <p:nvPr/>
+      </p:nvGrpSpPr>
+      <p:grpSpPr>
+        <a:xfrm>
+          <a:off x="0" y="0"/>
+          <a:ext cx="0" cy="0"/>
+          <a:chOff x="0" y="0"/>
+          <a:chExt cx="0" cy="0"/>
+        </a:xfrm>
+      </p:grpSpPr>
+      <p:sp>
+        <p:nvSpPr>
+          <p:cNvPr id="183298" name="Slide Number Placeholder 5"/>
+          <p:cNvSpPr>
+            <a:spLocks noGrp="1"/>
+          </p:cNvSpPr>
+          <p:nvPr>
+            <p:ph type="sldNum" sz="quarter" idx="12"/>
+          </p:nvPr>
+        </p:nvSpPr>
+        <p:spPr>
+          <a:noFill/>
+        </p:spPr>
+        <p:txBody>
+          <a:bodyPr/>
+          <a:lstStyle/>
+          <a:p>
+            <a:fld id="{C2812B8D-E844-4807-B20D-B92C141DEBC2}" type="slidenum">
+              <a:rPr lang="en-US" smtClean="0"/>
+              <a:pPr/>
+              <a:t>13</a:t>
+            </a:fld>
+            <a:endParaRPr lang="en-US"/>
+          </a:p>
+        </p:txBody>
+      </p:sp>
+      <p:sp>
+        <p:nvSpPr>
+          <p:cNvPr id="183299" name="Rectangle 2"/>
+          <p:cNvSpPr>
+            <a:spLocks noChangeArrowheads="1"/>
+          </p:cNvSpPr>
+          <p:nvPr/>
+        </p:nvSpPr>
+        <p:spPr bwMode="auto">
+          <a:xfrm>
+            <a:off x="7402514" y="3657601"/>
+            <a:ext cx="2511425" cy="1871663"/>
+          </a:xfrm>
+          <a:prstGeom prst="rect">
+            <a:avLst/>
+          </a:prstGeom>
+          <a:gradFill rotWithShape="1">
+            <a:gsLst>
+              <a:gs pos="0">
+                <a:schemeClr val="bg1"/>
+              </a:gs>
+              <a:gs pos="100000">
+                <a:schemeClr val="accent1"/>
+              </a:gs>
+            </a:gsLst>
+            <a:path path="shape">
+              <a:fillToRect l="50000" t="50000" r="50000" b="50000"/>
+            </a:path>
+          </a:gradFill>
+          <a:ln w="9525" algn="ctr">
+            <a:solidFill>
+              <a:schemeClr val="tx1"/>
+            </a:solidFill>
+            <a:miter lim="800000"/>
+            <a:headEnd/>
+            <a:tailEnd/>
+          </a:ln>
+        </p:spPr>
+        <p:txBody>
+          <a:bodyPr wrap="none" anchor="ctr"/>
+          <a:lstStyle/>
+          <a:p>
+            <a:pPr algn="ctr"/>
+            <a:r>
+              <a:rPr lang="en-US"/>
+              <a:t>Gas at T</a:t>
+            </a:r>
+            <a:r>
+              <a:rPr lang="en-US" baseline="-25000"/>
+              <a:t>i</a:t>
+            </a:r>
+          </a:p>
+        </p:txBody>
+      </p:sp>
+      <p:sp>
+        <p:nvSpPr>
+          <p:cNvPr id="183300" name="Rectangle 3"/>
+          <p:cNvSpPr>
+            <a:spLocks noGrp="1" noChangeArrowheads="1"/>
+          </p:cNvSpPr>
+          <p:nvPr>
+            <p:ph type="title"/>
+          </p:nvPr>
+        </p:nvSpPr>
+        <p:spPr/>
+        <p:txBody>
+          <a:bodyPr/>
+          <a:lstStyle/>
+          <a:p>
+            <a:pPr eaLnBrk="1" hangingPunct="1"/>
+            <a:r>
+              <a:rPr lang="en-US"/>
+              <a:t>Question 123.10.7</a:t>
+            </a:r>
+            <a:endParaRPr lang="en-US" dirty="0"/>
+          </a:p>
+        </p:txBody>
+      </p:sp>
+      <p:sp>
+        <p:nvSpPr>
+          <p:cNvPr id="183301" name="Rectangle 4"/>
+          <p:cNvSpPr>
+            <a:spLocks noGrp="1" noChangeArrowheads="1"/>
+          </p:cNvSpPr>
+          <p:nvPr>
+            <p:ph type="body" idx="1"/>
+          </p:nvPr>
+        </p:nvSpPr>
+        <p:spPr>
+          <a:xfrm>
+            <a:off x="1981201" y="1600201"/>
+            <a:ext cx="3978275" cy="4525963"/>
+          </a:xfrm>
+        </p:spPr>
+        <p:txBody>
+          <a:bodyPr/>
+          <a:lstStyle/>
+          <a:p>
+            <a:pPr marL="609600" indent="-609600">
+              <a:lnSpc>
+                <a:spcPct val="80000"/>
+              </a:lnSpc>
+              <a:buNone/>
+            </a:pPr>
+            <a:r>
+              <a:rPr lang="en-US"/>
+              <a:t>The initial state of a system is shown, if the membrane is broken, the gas fills the entire container. Is there work done by the gas in filling the container?</a:t>
+            </a:r>
+          </a:p>
+          <a:p>
+            <a:pPr marL="609600" indent="-609600">
+              <a:lnSpc>
+                <a:spcPct val="80000"/>
+              </a:lnSpc>
+              <a:buFontTx/>
+              <a:buAutoNum type="alphaLcParenR"/>
+            </a:pPr>
+            <a:r>
+              <a:rPr lang="en-US"/>
+              <a:t>Yes</a:t>
+            </a:r>
+          </a:p>
+          <a:p>
+            <a:pPr marL="609600" indent="-609600">
+              <a:lnSpc>
+                <a:spcPct val="80000"/>
+              </a:lnSpc>
+              <a:buFontTx/>
+              <a:buAutoNum type="alphaLcParenR"/>
+            </a:pPr>
+            <a:r>
+              <a:rPr lang="en-US"/>
+              <a:t>No</a:t>
+            </a:r>
+          </a:p>
+          <a:p>
+            <a:pPr marL="609600" indent="-609600">
+              <a:lnSpc>
+                <a:spcPct val="80000"/>
+              </a:lnSpc>
+              <a:buFontTx/>
+              <a:buAutoNum type="alphaLcParenR"/>
+            </a:pPr>
+            <a:r>
+              <a:rPr lang="en-US"/>
+              <a:t>Can’t Tell</a:t>
+            </a:r>
+          </a:p>
+        </p:txBody>
+      </p:sp>
+      <p:sp>
+        <p:nvSpPr>
+          <p:cNvPr id="183302" name="Rectangle 5"/>
+          <p:cNvSpPr>
+            <a:spLocks noChangeArrowheads="1"/>
+          </p:cNvSpPr>
+          <p:nvPr/>
+        </p:nvSpPr>
+        <p:spPr bwMode="auto">
+          <a:xfrm>
+            <a:off x="7402514" y="1814514"/>
+            <a:ext cx="2511425" cy="3730625"/>
+          </a:xfrm>
+          <a:prstGeom prst="rect">
+            <a:avLst/>
+          </a:prstGeom>
+          <a:noFill/>
+          <a:ln w="53975" algn="ctr">
+            <a:solidFill>
+              <a:srgbClr val="FF9900"/>
+            </a:solidFill>
+            <a:miter lim="800000"/>
+            <a:headEnd/>
+            <a:tailEnd/>
+          </a:ln>
+        </p:spPr>
+        <p:txBody>
+          <a:bodyPr wrap="none" anchor="ctr"/>
+          <a:lstStyle/>
+          <a:p>
+            <a:endParaRPr lang="en-US"/>
+          </a:p>
+        </p:txBody>
+      </p:sp>
+      <p:sp>
+        <p:nvSpPr>
+          <p:cNvPr id="183303" name="Line 6"/>
+          <p:cNvSpPr>
+            <a:spLocks noChangeShapeType="1"/>
+          </p:cNvSpPr>
+          <p:nvPr/>
+        </p:nvSpPr>
+        <p:spPr bwMode="auto">
+          <a:xfrm>
+            <a:off x="7388226" y="3671888"/>
+            <a:ext cx="2525713" cy="0"/>
+          </a:xfrm>
+          <a:prstGeom prst="line">
+            <a:avLst/>
+          </a:prstGeom>
+          <a:noFill/>
+          <a:ln w="9525">
+            <a:solidFill>
+              <a:srgbClr val="FF0000"/>
+            </a:solidFill>
+            <a:round/>
+            <a:headEnd/>
+            <a:tailEnd/>
+          </a:ln>
+        </p:spPr>
+        <p:txBody>
+          <a:bodyPr wrap="none" anchor="ctr"/>
+          <a:lstStyle/>
+          <a:p>
+            <a:endParaRPr lang="en-US"/>
+          </a:p>
+        </p:txBody>
+      </p:sp>
+      <p:sp>
+        <p:nvSpPr>
+          <p:cNvPr id="183304" name="Text Box 7"/>
+          <p:cNvSpPr txBox="1">
+            <a:spLocks noChangeArrowheads="1"/>
+          </p:cNvSpPr>
+          <p:nvPr/>
+        </p:nvSpPr>
+        <p:spPr bwMode="auto">
+          <a:xfrm>
+            <a:off x="8097838" y="2286001"/>
+            <a:ext cx="1136650" cy="366713"/>
+          </a:xfrm>
+          <a:prstGeom prst="rect">
+            <a:avLst/>
+          </a:prstGeom>
+          <a:noFill/>
+          <a:ln w="9525" algn="ctr">
+            <a:noFill/>
+            <a:miter lim="800000"/>
+            <a:headEnd/>
+            <a:tailEnd/>
+          </a:ln>
+        </p:spPr>
+        <p:txBody>
+          <a:bodyPr>
+            <a:spAutoFit/>
+          </a:bodyPr>
+          <a:lstStyle/>
+          <a:p>
+            <a:pPr algn="ctr"/>
+            <a:r>
+              <a:rPr lang="en-US"/>
+              <a:t>Vacuum</a:t>
+            </a:r>
+          </a:p>
+        </p:txBody>
+      </p:sp>
+      <p:sp>
+        <p:nvSpPr>
+          <p:cNvPr id="183305" name="Text Box 8"/>
+          <p:cNvSpPr txBox="1">
+            <a:spLocks noChangeArrowheads="1"/>
+          </p:cNvSpPr>
+          <p:nvPr/>
+        </p:nvSpPr>
+        <p:spPr bwMode="auto">
+          <a:xfrm>
+            <a:off x="7278689" y="3092451"/>
+            <a:ext cx="1920875" cy="366713"/>
+          </a:xfrm>
+          <a:prstGeom prst="rect">
+            <a:avLst/>
+          </a:prstGeom>
+          <a:noFill/>
+          <a:ln w="9525" algn="ctr">
+            <a:noFill/>
+            <a:miter lim="800000"/>
+            <a:headEnd/>
+            <a:tailEnd/>
+          </a:ln>
+        </p:spPr>
+        <p:txBody>
+          <a:bodyPr>
+            <a:spAutoFit/>
+          </a:bodyPr>
+          <a:lstStyle/>
+          <a:p>
+            <a:pPr algn="ctr"/>
+            <a:r>
+              <a:rPr lang="en-US"/>
+              <a:t>Membrane</a:t>
+            </a:r>
+          </a:p>
+        </p:txBody>
+      </p:sp>
+      <p:sp>
+        <p:nvSpPr>
+          <p:cNvPr id="183306" name="Line 9"/>
+          <p:cNvSpPr>
+            <a:spLocks noChangeShapeType="1"/>
+          </p:cNvSpPr>
+          <p:nvPr/>
+        </p:nvSpPr>
+        <p:spPr bwMode="auto">
+          <a:xfrm flipH="1">
+            <a:off x="8026400" y="3381376"/>
+            <a:ext cx="115888" cy="276225"/>
+          </a:xfrm>
+          <a:prstGeom prst="line">
+            <a:avLst/>
+          </a:prstGeom>
+          <a:noFill/>
+          <a:ln w="9525">
+            <a:solidFill>
+              <a:schemeClr val="tx1"/>
+            </a:solidFill>
+            <a:round/>
+            <a:headEnd/>
+            <a:tailEnd type="triangle" w="med" len="med"/>
+          </a:ln>
+        </p:spPr>
+        <p:txBody>
+          <a:bodyPr wrap="none" anchor="ctr"/>
+          <a:lstStyle/>
+          <a:p>
+            <a:endParaRPr lang="en-US"/>
+          </a:p>
+        </p:txBody>
+      </p:sp>
+    </p:spTree>
+    <p:extLst>
+      <p:ext uri="{BB962C8B-B14F-4D97-AF65-F5344CB8AC3E}">
+        <p14:creationId xmlns:p14="http://schemas.microsoft.com/office/powerpoint/2010/main" val="3786188879"/>
+      </p:ext>
+    </p:extLst>
+  </p:cSld>
+  <p:clrMapOvr>
+    <a:masterClrMapping/>
+  </p:clrMapOvr>
+</p:sld>
+</file>
+
+<file path=ppt/slides/slide14.xml><?xml version="1.0" encoding="utf-8"?>
+<p:sld xmlns:a="http://schemas.openxmlformats.org/drawingml/2006/main" xmlns:r="http://schemas.openxmlformats.org/officeDocument/2006/relationships" xmlns:p="http://schemas.openxmlformats.org/presentationml/2006/main">
+  <p:cSld>
+    <p:spTree>
+      <p:nvGrpSpPr>
+        <p:cNvPr id="1" name=""/>
+        <p:cNvGrpSpPr/>
+        <p:nvPr/>
+      </p:nvGrpSpPr>
+      <p:grpSpPr>
+        <a:xfrm>
+          <a:off x="0" y="0"/>
+          <a:ext cx="0" cy="0"/>
+          <a:chOff x="0" y="0"/>
+          <a:chExt cx="0" cy="0"/>
+        </a:xfrm>
+      </p:grpSpPr>
+      <p:sp>
+        <p:nvSpPr>
+          <p:cNvPr id="4" name="Title 3">
+            <a:extLst>
+              <a:ext uri="{FF2B5EF4-FFF2-40B4-BE49-F238E27FC236}">
+                <a16:creationId xmlns:a16="http://schemas.microsoft.com/office/drawing/2014/main" id="{278E2971-ABB3-3665-9E07-6648A45C5EA1}"/>
+              </a:ext>
+            </a:extLst>
+          </p:cNvPr>
+          <p:cNvSpPr>
+            <a:spLocks noGrp="1"/>
+          </p:cNvSpPr>
+          <p:nvPr>
+            <p:ph type="ctrTitle"/>
+          </p:nvPr>
+        </p:nvSpPr>
+        <p:spPr/>
+        <p:txBody>
+          <a:bodyPr/>
+          <a:lstStyle/>
+          <a:p>
+            <a:r>
+              <a:rPr lang="en-US" dirty="0"/>
+              <a:t>END</a:t>
+            </a:r>
+          </a:p>
+        </p:txBody>
+      </p:sp>
+      <p:sp>
+        <p:nvSpPr>
+          <p:cNvPr id="5" name="Subtitle 4">
+            <a:extLst>
+              <a:ext uri="{FF2B5EF4-FFF2-40B4-BE49-F238E27FC236}">
+                <a16:creationId xmlns:a16="http://schemas.microsoft.com/office/drawing/2014/main" id="{0D541E2D-86A8-F412-3392-CC7332FB94CE}"/>
+              </a:ext>
+            </a:extLst>
+          </p:cNvPr>
+          <p:cNvSpPr>
+            <a:spLocks noGrp="1"/>
+          </p:cNvSpPr>
+          <p:nvPr>
+            <p:ph type="subTitle" idx="1"/>
+          </p:nvPr>
+        </p:nvSpPr>
+        <p:spPr/>
+        <p:txBody>
+          <a:bodyPr/>
+          <a:lstStyle/>
+          <a:p>
+            <a:endParaRPr lang="en-US"/>
+          </a:p>
+        </p:txBody>
+      </p:sp>
+    </p:spTree>
+    <p:extLst>
+      <p:ext uri="{BB962C8B-B14F-4D97-AF65-F5344CB8AC3E}">
+        <p14:creationId xmlns:p14="http://schemas.microsoft.com/office/powerpoint/2010/main" val="1532625996"/>
+      </p:ext>
+    </p:extLst>
+  </p:cSld>
+  <p:clrMapOvr>
+    <a:masterClrMapping/>
+  </p:clrMapOvr>
+</p:sld>
+</file>
+
 <file path=ppt/slides/slide2.xml><?xml version="1.0" encoding="utf-8"?>
 <p:sld xmlns:a="http://schemas.openxmlformats.org/drawingml/2006/main" xmlns:r="http://schemas.openxmlformats.org/officeDocument/2006/relationships" xmlns:p="http://schemas.openxmlformats.org/presentationml/2006/main">
   <p:cSld>
@@ -3771,6 +5105,327 @@
   <p:cSld>
     <p:spTree>
       <p:nvGrpSpPr>
+        <p:cNvPr id="1" name="">
+          <a:extLst>
+            <a:ext uri="{FF2B5EF4-FFF2-40B4-BE49-F238E27FC236}">
+              <a16:creationId xmlns:a16="http://schemas.microsoft.com/office/drawing/2014/main" id="{5915F1B2-C636-F26E-1AE6-A14E36C7BDCC}"/>
+            </a:ext>
+          </a:extLst>
+        </p:cNvPr>
+        <p:cNvGrpSpPr/>
+        <p:nvPr/>
+      </p:nvGrpSpPr>
+      <p:grpSpPr>
+        <a:xfrm>
+          <a:off x="0" y="0"/>
+          <a:ext cx="0" cy="0"/>
+          <a:chOff x="0" y="0"/>
+          <a:chExt cx="0" cy="0"/>
+        </a:xfrm>
+      </p:grpSpPr>
+      <p:sp>
+        <p:nvSpPr>
+          <p:cNvPr id="35842" name="Title 1">
+            <a:extLst>
+              <a:ext uri="{FF2B5EF4-FFF2-40B4-BE49-F238E27FC236}">
+                <a16:creationId xmlns:a16="http://schemas.microsoft.com/office/drawing/2014/main" id="{E5D43F17-A7AA-2648-7985-50828A29E95D}"/>
+              </a:ext>
+            </a:extLst>
+          </p:cNvPr>
+          <p:cNvSpPr>
+            <a:spLocks noGrp="1" noChangeArrowheads="1"/>
+          </p:cNvSpPr>
+          <p:nvPr>
+            <p:ph type="title"/>
+          </p:nvPr>
+        </p:nvSpPr>
+        <p:spPr/>
+        <p:txBody>
+          <a:bodyPr/>
+          <a:lstStyle/>
+          <a:p>
+            <a:r>
+              <a:rPr lang="en-US" altLang="en-US"/>
+              <a:t>Question 123.11.4</a:t>
+            </a:r>
+          </a:p>
+        </p:txBody>
+      </p:sp>
+      <p:sp>
+        <p:nvSpPr>
+          <p:cNvPr id="35843" name="Content Placeholder 2">
+            <a:extLst>
+              <a:ext uri="{FF2B5EF4-FFF2-40B4-BE49-F238E27FC236}">
+                <a16:creationId xmlns:a16="http://schemas.microsoft.com/office/drawing/2014/main" id="{0880A836-F3E8-694F-BE88-C7B0C83B8377}"/>
+              </a:ext>
+            </a:extLst>
+          </p:cNvPr>
+          <p:cNvSpPr>
+            <a:spLocks noGrp="1" noChangeArrowheads="1"/>
+          </p:cNvSpPr>
+          <p:nvPr>
+            <p:ph idx="1"/>
+          </p:nvPr>
+        </p:nvSpPr>
+        <p:spPr/>
+        <p:txBody>
+          <a:bodyPr/>
+          <a:lstStyle/>
+          <a:p>
+            <a:pPr>
+              <a:buFontTx/>
+              <a:buNone/>
+            </a:pPr>
+            <a:r>
+              <a:rPr lang="en-US" altLang="en-US" dirty="0"/>
+              <a:t>We can have a process where Q = 0? What do we call that process?</a:t>
+            </a:r>
+          </a:p>
+          <a:p>
+            <a:pPr marL="514350" indent="-514350">
+              <a:buFont typeface="+mj-lt"/>
+              <a:buAutoNum type="alphaLcParenR"/>
+            </a:pPr>
+            <a:r>
+              <a:rPr lang="en-US" dirty="0"/>
+              <a:t>Isobaric</a:t>
+            </a:r>
+          </a:p>
+          <a:p>
+            <a:pPr marL="514350" indent="-514350">
+              <a:buFont typeface="+mj-lt"/>
+              <a:buAutoNum type="alphaLcParenR"/>
+            </a:pPr>
+            <a:r>
+              <a:rPr lang="en-US" dirty="0"/>
+              <a:t>Isochoric</a:t>
+            </a:r>
+          </a:p>
+          <a:p>
+            <a:pPr marL="514350" indent="-514350">
+              <a:buFont typeface="+mj-lt"/>
+              <a:buAutoNum type="alphaLcParenR"/>
+            </a:pPr>
+            <a:r>
+              <a:rPr lang="en-US" dirty="0"/>
+              <a:t>Adiabatic</a:t>
+            </a:r>
+          </a:p>
+          <a:p>
+            <a:pPr marL="514350" indent="-514350">
+              <a:buFont typeface="+mj-lt"/>
+              <a:buAutoNum type="alphaLcParenR"/>
+            </a:pPr>
+            <a:r>
+              <a:rPr lang="en-US" dirty="0"/>
+              <a:t>Isothermal</a:t>
+            </a:r>
+          </a:p>
+        </p:txBody>
+      </p:sp>
+      <p:sp>
+        <p:nvSpPr>
+          <p:cNvPr id="35844" name="Slide Number Placeholder 3">
+            <a:extLst>
+              <a:ext uri="{FF2B5EF4-FFF2-40B4-BE49-F238E27FC236}">
+                <a16:creationId xmlns:a16="http://schemas.microsoft.com/office/drawing/2014/main" id="{1F23F20B-1AE1-D064-E6B6-EA8701D98B9F}"/>
+              </a:ext>
+            </a:extLst>
+          </p:cNvPr>
+          <p:cNvSpPr>
+            <a:spLocks noGrp="1"/>
+          </p:cNvSpPr>
+          <p:nvPr>
+            <p:ph type="sldNum" sz="quarter" idx="12"/>
+          </p:nvPr>
+        </p:nvSpPr>
+        <p:spPr bwMode="auto">
+          <a:noFill/>
+          <a:extLst>
+            <a:ext uri="{909E8E84-426E-40DD-AFC4-6F175D3DCCD1}">
+              <a14:hiddenFill xmlns:a14="http://schemas.microsoft.com/office/drawing/2010/main">
+                <a:solidFill>
+                  <a:srgbClr val="FFFFFF"/>
+                </a:solidFill>
+              </a14:hiddenFill>
+            </a:ext>
+            <a:ext uri="{91240B29-F687-4F45-9708-019B960494DF}">
+              <a14:hiddenLine xmlns:a14="http://schemas.microsoft.com/office/drawing/2010/main" w="9525">
+                <a:solidFill>
+                  <a:srgbClr val="000000"/>
+                </a:solidFill>
+                <a:miter lim="800000"/>
+                <a:headEnd/>
+                <a:tailEnd/>
+              </a14:hiddenLine>
+            </a:ext>
+          </a:extLst>
+        </p:spPr>
+        <p:txBody>
+          <a:bodyPr/>
+          <a:lstStyle>
+            <a:lvl1pPr>
+              <a:spcBef>
+                <a:spcPct val="20000"/>
+              </a:spcBef>
+              <a:buChar char="•"/>
+              <a:defRPr sz="3200">
+                <a:solidFill>
+                  <a:schemeClr val="tx1"/>
+                </a:solidFill>
+                <a:latin typeface="Arial" panose="020B0604020202020204" pitchFamily="34" charset="0"/>
+              </a:defRPr>
+            </a:lvl1pPr>
+            <a:lvl2pPr marL="742950" indent="-285750">
+              <a:spcBef>
+                <a:spcPct val="20000"/>
+              </a:spcBef>
+              <a:buChar char="–"/>
+              <a:defRPr sz="2800">
+                <a:solidFill>
+                  <a:schemeClr val="tx1"/>
+                </a:solidFill>
+                <a:latin typeface="Arial" panose="020B0604020202020204" pitchFamily="34" charset="0"/>
+              </a:defRPr>
+            </a:lvl2pPr>
+            <a:lvl3pPr marL="1143000" indent="-228600">
+              <a:spcBef>
+                <a:spcPct val="20000"/>
+              </a:spcBef>
+              <a:buChar char="•"/>
+              <a:defRPr sz="2400">
+                <a:solidFill>
+                  <a:schemeClr val="tx1"/>
+                </a:solidFill>
+                <a:latin typeface="Arial" panose="020B0604020202020204" pitchFamily="34" charset="0"/>
+              </a:defRPr>
+            </a:lvl3pPr>
+            <a:lvl4pPr marL="1600200" indent="-228600">
+              <a:spcBef>
+                <a:spcPct val="20000"/>
+              </a:spcBef>
+              <a:buChar char="–"/>
+              <a:defRPr sz="2000">
+                <a:solidFill>
+                  <a:schemeClr val="tx1"/>
+                </a:solidFill>
+                <a:latin typeface="Arial" panose="020B0604020202020204" pitchFamily="34" charset="0"/>
+              </a:defRPr>
+            </a:lvl4pPr>
+            <a:lvl5pPr marL="2057400" indent="-228600">
+              <a:spcBef>
+                <a:spcPct val="20000"/>
+              </a:spcBef>
+              <a:buChar char="»"/>
+              <a:defRPr sz="2000">
+                <a:solidFill>
+                  <a:schemeClr val="tx1"/>
+                </a:solidFill>
+                <a:latin typeface="Arial" panose="020B0604020202020204" pitchFamily="34" charset="0"/>
+              </a:defRPr>
+            </a:lvl5pPr>
+            <a:lvl6pPr marL="2514600" indent="-228600" eaLnBrk="0" fontAlgn="base" hangingPunct="0">
+              <a:spcBef>
+                <a:spcPct val="20000"/>
+              </a:spcBef>
+              <a:spcAft>
+                <a:spcPct val="0"/>
+              </a:spcAft>
+              <a:buChar char="»"/>
+              <a:defRPr sz="2000">
+                <a:solidFill>
+                  <a:schemeClr val="tx1"/>
+                </a:solidFill>
+                <a:latin typeface="Arial" panose="020B0604020202020204" pitchFamily="34" charset="0"/>
+              </a:defRPr>
+            </a:lvl6pPr>
+            <a:lvl7pPr marL="2971800" indent="-228600" eaLnBrk="0" fontAlgn="base" hangingPunct="0">
+              <a:spcBef>
+                <a:spcPct val="20000"/>
+              </a:spcBef>
+              <a:spcAft>
+                <a:spcPct val="0"/>
+              </a:spcAft>
+              <a:buChar char="»"/>
+              <a:defRPr sz="2000">
+                <a:solidFill>
+                  <a:schemeClr val="tx1"/>
+                </a:solidFill>
+                <a:latin typeface="Arial" panose="020B0604020202020204" pitchFamily="34" charset="0"/>
+              </a:defRPr>
+            </a:lvl7pPr>
+            <a:lvl8pPr marL="3429000" indent="-228600" eaLnBrk="0" fontAlgn="base" hangingPunct="0">
+              <a:spcBef>
+                <a:spcPct val="20000"/>
+              </a:spcBef>
+              <a:spcAft>
+                <a:spcPct val="0"/>
+              </a:spcAft>
+              <a:buChar char="»"/>
+              <a:defRPr sz="2000">
+                <a:solidFill>
+                  <a:schemeClr val="tx1"/>
+                </a:solidFill>
+                <a:latin typeface="Arial" panose="020B0604020202020204" pitchFamily="34" charset="0"/>
+              </a:defRPr>
+            </a:lvl8pPr>
+            <a:lvl9pPr marL="3886200" indent="-228600" eaLnBrk="0" fontAlgn="base" hangingPunct="0">
+              <a:spcBef>
+                <a:spcPct val="20000"/>
+              </a:spcBef>
+              <a:spcAft>
+                <a:spcPct val="0"/>
+              </a:spcAft>
+              <a:buChar char="»"/>
+              <a:defRPr sz="2000">
+                <a:solidFill>
+                  <a:schemeClr val="tx1"/>
+                </a:solidFill>
+                <a:latin typeface="Arial" panose="020B0604020202020204" pitchFamily="34" charset="0"/>
+              </a:defRPr>
+            </a:lvl9pPr>
+          </a:lstStyle>
+          <a:p>
+            <a:pPr>
+              <a:spcBef>
+                <a:spcPct val="0"/>
+              </a:spcBef>
+              <a:buFontTx/>
+              <a:buNone/>
+            </a:pPr>
+            <a:fld id="{6DC6CAC7-B115-4CA8-825E-3F1ADFC365D7}" type="slidenum">
+              <a:rPr lang="en-US" altLang="en-US" sz="1800"/>
+              <a:pPr>
+                <a:spcBef>
+                  <a:spcPct val="0"/>
+                </a:spcBef>
+                <a:buFontTx/>
+                <a:buNone/>
+              </a:pPr>
+              <a:t>3</a:t>
+            </a:fld>
+            <a:endParaRPr lang="en-US" altLang="en-US" sz="1800"/>
+          </a:p>
+        </p:txBody>
+      </p:sp>
+    </p:spTree>
+    <p:extLst>
+      <p:ext uri="{BB962C8B-B14F-4D97-AF65-F5344CB8AC3E}">
+        <p14:creationId xmlns:p14="http://schemas.microsoft.com/office/powerpoint/2010/main" val="3842804923"/>
+      </p:ext>
+    </p:extLst>
+  </p:cSld>
+  <p:clrMapOvr>
+    <a:masterClrMapping/>
+  </p:clrMapOvr>
+</p:sld>
+</file>
+
+<file path=ppt/slides/slide4.xml><?xml version="1.0" encoding="utf-8"?>
+<p:sld xmlns:a="http://schemas.openxmlformats.org/drawingml/2006/main" xmlns:r="http://schemas.openxmlformats.org/officeDocument/2006/relationships" xmlns:p="http://schemas.openxmlformats.org/presentationml/2006/main">
+  <p:cSld>
+    <p:spTree>
+      <p:nvGrpSpPr>
         <p:cNvPr id="1" name=""/>
         <p:cNvGrpSpPr/>
         <p:nvPr/>
@@ -3826,102 +5481,6 @@
 </p:sld>
 </file>
 
-<file path=ppt/slides/slide4.xml><?xml version="1.0" encoding="utf-8"?>
-<p:sld xmlns:a="http://schemas.openxmlformats.org/drawingml/2006/main" xmlns:r="http://schemas.openxmlformats.org/officeDocument/2006/relationships" xmlns:p="http://schemas.openxmlformats.org/presentationml/2006/main">
-  <p:cSld>
-    <p:spTree>
-      <p:nvGrpSpPr>
-        <p:cNvPr id="1" name=""/>
-        <p:cNvGrpSpPr/>
-        <p:nvPr/>
-      </p:nvGrpSpPr>
-      <p:grpSpPr>
-        <a:xfrm>
-          <a:off x="0" y="0"/>
-          <a:ext cx="0" cy="0"/>
-          <a:chOff x="0" y="0"/>
-          <a:chExt cx="0" cy="0"/>
-        </a:xfrm>
-      </p:grpSpPr>
-      <p:sp>
-        <p:nvSpPr>
-          <p:cNvPr id="2" name="Title 1"/>
-          <p:cNvSpPr>
-            <a:spLocks noGrp="1"/>
-          </p:cNvSpPr>
-          <p:nvPr>
-            <p:ph type="title"/>
-          </p:nvPr>
-        </p:nvSpPr>
-        <p:spPr/>
-        <p:txBody>
-          <a:bodyPr/>
-          <a:lstStyle/>
-          <a:p>
-            <a:endParaRPr lang="en-US"/>
-          </a:p>
-        </p:txBody>
-      </p:sp>
-      <p:sp>
-        <p:nvSpPr>
-          <p:cNvPr id="3" name="Content Placeholder 2"/>
-          <p:cNvSpPr>
-            <a:spLocks noGrp="1"/>
-          </p:cNvSpPr>
-          <p:nvPr>
-            <p:ph idx="1"/>
-          </p:nvPr>
-        </p:nvSpPr>
-        <p:spPr/>
-        <p:txBody>
-          <a:bodyPr/>
-          <a:lstStyle/>
-          <a:p>
-            <a:endParaRPr lang="en-US"/>
-          </a:p>
-        </p:txBody>
-      </p:sp>
-      <p:pic>
-        <p:nvPicPr>
-          <p:cNvPr id="7170" name="Picture 2"/>
-          <p:cNvPicPr>
-            <a:picLocks noChangeAspect="1" noChangeArrowheads="1"/>
-          </p:cNvPicPr>
-          <p:nvPr/>
-        </p:nvPicPr>
-        <p:blipFill>
-          <a:blip r:embed="rId2" cstate="print"/>
-          <a:srcRect/>
-          <a:stretch>
-            <a:fillRect/>
-          </a:stretch>
-        </p:blipFill>
-        <p:spPr bwMode="auto">
-          <a:xfrm>
-            <a:off x="1905000" y="642082"/>
-            <a:ext cx="8650174" cy="5758718"/>
-          </a:xfrm>
-          <a:prstGeom prst="rect">
-            <a:avLst/>
-          </a:prstGeom>
-          <a:noFill/>
-          <a:ln w="9525">
-            <a:noFill/>
-            <a:miter lim="800000"/>
-            <a:headEnd/>
-            <a:tailEnd/>
-          </a:ln>
-          <a:effectLst/>
-        </p:spPr>
-      </p:pic>
-    </p:spTree>
-  </p:cSld>
-  <p:clrMapOvr>
-    <a:masterClrMapping/>
-  </p:clrMapOvr>
-</p:sld>
-</file>
-
 <file path=ppt/slides/slide5.xml><?xml version="1.0" encoding="utf-8"?>
 <p:sld xmlns:a="http://schemas.openxmlformats.org/drawingml/2006/main" xmlns:r="http://schemas.openxmlformats.org/officeDocument/2006/relationships" xmlns:p="http://schemas.openxmlformats.org/presentationml/2006/main">
   <p:cSld>
@@ -3939,42 +5498,15 @@
           <a:chExt cx="0" cy="0"/>
         </a:xfrm>
       </p:grpSpPr>
-      <p:pic>
-        <p:nvPicPr>
-          <p:cNvPr id="1030" name="Picture 6"/>
-          <p:cNvPicPr>
-            <a:picLocks noChangeAspect="1" noChangeArrowheads="1"/>
-          </p:cNvPicPr>
-          <p:nvPr/>
-        </p:nvPicPr>
-        <p:blipFill>
-          <a:blip r:embed="rId2" cstate="print"/>
-          <a:srcRect/>
-          <a:stretch>
-            <a:fillRect/>
-          </a:stretch>
-        </p:blipFill>
-        <p:spPr bwMode="auto">
-          <a:xfrm>
-            <a:off x="7162801" y="1828800"/>
-            <a:ext cx="1869243" cy="1822450"/>
-          </a:xfrm>
-          <a:prstGeom prst="rect">
-            <a:avLst/>
-          </a:prstGeom>
-          <a:noFill/>
-          <a:ln w="9525">
-            <a:noFill/>
-            <a:miter lim="800000"/>
-            <a:headEnd/>
-            <a:tailEnd/>
-          </a:ln>
-          <a:effectLst/>
-        </p:spPr>
-      </p:pic>
-      <p:sp>
-        <p:nvSpPr>
-          <p:cNvPr id="2" name="Title 1"/>
+      <p:sp>
+        <p:nvSpPr>
+          <p:cNvPr id="2" name="Title 1">
+            <a:extLst>
+              <a:ext uri="{FF2B5EF4-FFF2-40B4-BE49-F238E27FC236}">
+                <a16:creationId xmlns:a16="http://schemas.microsoft.com/office/drawing/2014/main" id="{54610E40-E486-E84C-682C-6002987BB624}"/>
+              </a:ext>
+            </a:extLst>
+          </p:cNvPr>
           <p:cNvSpPr>
             <a:spLocks noGrp="1"/>
           </p:cNvSpPr>
@@ -3987,483 +5519,279 @@
           <a:bodyPr/>
           <a:lstStyle/>
           <a:p>
-            <a:endParaRPr lang="en-US" dirty="0"/>
-          </a:p>
-        </p:txBody>
-      </p:sp>
-      <p:sp>
-        <p:nvSpPr>
-          <p:cNvPr id="4" name="Rectangle 2"/>
-          <p:cNvSpPr>
-            <a:spLocks noChangeArrowheads="1"/>
-          </p:cNvSpPr>
-          <p:nvPr/>
-        </p:nvSpPr>
-        <p:spPr bwMode="auto">
-          <a:xfrm>
-            <a:off x="2743201" y="3519488"/>
-            <a:ext cx="2511425" cy="1871663"/>
-          </a:xfrm>
-          <a:prstGeom prst="rect">
-            <a:avLst/>
-          </a:prstGeom>
-          <a:gradFill rotWithShape="1">
-            <a:gsLst>
-              <a:gs pos="0">
-                <a:schemeClr val="bg1"/>
-              </a:gs>
-              <a:gs pos="100000">
-                <a:schemeClr val="accent1"/>
-              </a:gs>
-            </a:gsLst>
-            <a:path path="shape">
-              <a:fillToRect l="50000" t="50000" r="50000" b="50000"/>
-            </a:path>
-          </a:gradFill>
-          <a:ln w="9525" algn="ctr">
-            <a:solidFill>
-              <a:schemeClr val="tx1"/>
-            </a:solidFill>
-            <a:miter lim="800000"/>
-            <a:headEnd/>
-            <a:tailEnd/>
-          </a:ln>
-        </p:spPr>
-        <p:txBody>
-          <a:bodyPr wrap="none" anchor="ctr"/>
-          <a:lstStyle/>
-          <a:p>
-            <a:pPr algn="ctr"/>
-            <a:r>
-              <a:rPr lang="en-US"/>
-              <a:t>Gas at T</a:t>
-            </a:r>
-            <a:r>
-              <a:rPr lang="en-US" baseline="-25000"/>
-              <a:t>i</a:t>
-            </a:r>
-          </a:p>
-        </p:txBody>
-      </p:sp>
-      <p:sp>
-        <p:nvSpPr>
-          <p:cNvPr id="5" name="Rectangle 5"/>
-          <p:cNvSpPr>
-            <a:spLocks noChangeArrowheads="1"/>
-          </p:cNvSpPr>
-          <p:nvPr/>
-        </p:nvSpPr>
-        <p:spPr bwMode="auto">
-          <a:xfrm>
-            <a:off x="2743201" y="1676401"/>
-            <a:ext cx="2511425" cy="3730625"/>
-          </a:xfrm>
-          <a:prstGeom prst="rect">
-            <a:avLst/>
-          </a:prstGeom>
-          <a:noFill/>
-          <a:ln w="53975" algn="ctr">
-            <a:solidFill>
-              <a:srgbClr val="FF9900"/>
-            </a:solidFill>
-            <a:miter lim="800000"/>
-            <a:headEnd/>
-            <a:tailEnd/>
-          </a:ln>
-        </p:spPr>
-        <p:txBody>
-          <a:bodyPr wrap="none" anchor="ctr"/>
-          <a:lstStyle/>
-          <a:p>
-            <a:endParaRPr lang="en-US"/>
-          </a:p>
-        </p:txBody>
-      </p:sp>
-      <p:sp>
-        <p:nvSpPr>
-          <p:cNvPr id="6" name="Line 6"/>
-          <p:cNvSpPr>
-            <a:spLocks noChangeShapeType="1"/>
-          </p:cNvSpPr>
-          <p:nvPr/>
-        </p:nvSpPr>
-        <p:spPr bwMode="auto">
-          <a:xfrm>
-            <a:off x="2728913" y="3533775"/>
-            <a:ext cx="2525713" cy="0"/>
-          </a:xfrm>
-          <a:prstGeom prst="line">
-            <a:avLst/>
-          </a:prstGeom>
-          <a:noFill/>
-          <a:ln w="9525">
-            <a:solidFill>
-              <a:srgbClr val="FF0000"/>
-            </a:solidFill>
-            <a:round/>
-            <a:headEnd/>
-            <a:tailEnd/>
-          </a:ln>
-        </p:spPr>
-        <p:txBody>
-          <a:bodyPr wrap="none" anchor="ctr"/>
-          <a:lstStyle/>
-          <a:p>
-            <a:endParaRPr lang="en-US"/>
-          </a:p>
-        </p:txBody>
-      </p:sp>
-      <p:sp>
-        <p:nvSpPr>
-          <p:cNvPr id="7" name="Text Box 7"/>
-          <p:cNvSpPr txBox="1">
-            <a:spLocks noChangeArrowheads="1"/>
-          </p:cNvSpPr>
-          <p:nvPr/>
-        </p:nvSpPr>
-        <p:spPr bwMode="auto">
-          <a:xfrm>
-            <a:off x="3438525" y="2147888"/>
-            <a:ext cx="1136650" cy="366713"/>
-          </a:xfrm>
-          <a:prstGeom prst="rect">
-            <a:avLst/>
-          </a:prstGeom>
-          <a:noFill/>
-          <a:ln w="9525" algn="ctr">
-            <a:noFill/>
-            <a:miter lim="800000"/>
-            <a:headEnd/>
-            <a:tailEnd/>
-          </a:ln>
-        </p:spPr>
-        <p:txBody>
-          <a:bodyPr>
-            <a:spAutoFit/>
-          </a:bodyPr>
-          <a:lstStyle/>
-          <a:p>
-            <a:pPr algn="ctr"/>
-            <a:r>
-              <a:rPr lang="en-US"/>
-              <a:t>Vacuum</a:t>
-            </a:r>
-          </a:p>
-        </p:txBody>
-      </p:sp>
-      <p:sp>
-        <p:nvSpPr>
-          <p:cNvPr id="8" name="Text Box 8"/>
-          <p:cNvSpPr txBox="1">
-            <a:spLocks noChangeArrowheads="1"/>
-          </p:cNvSpPr>
-          <p:nvPr/>
-        </p:nvSpPr>
-        <p:spPr bwMode="auto">
-          <a:xfrm>
-            <a:off x="2619376" y="2954338"/>
-            <a:ext cx="1920875" cy="366713"/>
-          </a:xfrm>
-          <a:prstGeom prst="rect">
-            <a:avLst/>
-          </a:prstGeom>
-          <a:noFill/>
-          <a:ln w="9525" algn="ctr">
-            <a:noFill/>
-            <a:miter lim="800000"/>
-            <a:headEnd/>
-            <a:tailEnd/>
-          </a:ln>
-        </p:spPr>
-        <p:txBody>
-          <a:bodyPr>
-            <a:spAutoFit/>
-          </a:bodyPr>
-          <a:lstStyle/>
-          <a:p>
-            <a:pPr algn="ctr"/>
-            <a:r>
-              <a:rPr lang="en-US"/>
-              <a:t>Membrane</a:t>
-            </a:r>
-          </a:p>
-        </p:txBody>
-      </p:sp>
-      <p:sp>
-        <p:nvSpPr>
-          <p:cNvPr id="9" name="Line 9"/>
-          <p:cNvSpPr>
-            <a:spLocks noChangeShapeType="1"/>
-          </p:cNvSpPr>
-          <p:nvPr/>
-        </p:nvSpPr>
-        <p:spPr bwMode="auto">
-          <a:xfrm flipH="1">
-            <a:off x="3367087" y="3243263"/>
-            <a:ext cx="115888" cy="276225"/>
-          </a:xfrm>
-          <a:prstGeom prst="line">
-            <a:avLst/>
-          </a:prstGeom>
-          <a:noFill/>
-          <a:ln w="9525">
-            <a:solidFill>
-              <a:schemeClr val="tx1"/>
-            </a:solidFill>
-            <a:round/>
-            <a:headEnd/>
-            <a:tailEnd type="triangle" w="med" len="med"/>
-          </a:ln>
-        </p:spPr>
-        <p:txBody>
-          <a:bodyPr wrap="none" anchor="ctr"/>
-          <a:lstStyle/>
-          <a:p>
-            <a:endParaRPr lang="en-US"/>
-          </a:p>
-        </p:txBody>
-      </p:sp>
-      <p:sp>
-        <p:nvSpPr>
-          <p:cNvPr id="11" name="Rectangle 5"/>
-          <p:cNvSpPr>
-            <a:spLocks noChangeArrowheads="1"/>
-          </p:cNvSpPr>
-          <p:nvPr/>
-        </p:nvSpPr>
-        <p:spPr bwMode="auto">
-          <a:xfrm>
-            <a:off x="6629401" y="1676401"/>
-            <a:ext cx="2511425" cy="3730625"/>
-          </a:xfrm>
-          <a:prstGeom prst="rect">
-            <a:avLst/>
-          </a:prstGeom>
-          <a:noFill/>
-          <a:ln w="53975" algn="ctr">
-            <a:solidFill>
-              <a:srgbClr val="FF9900"/>
-            </a:solidFill>
-            <a:miter lim="800000"/>
-            <a:headEnd/>
-            <a:tailEnd/>
-          </a:ln>
-        </p:spPr>
-        <p:txBody>
-          <a:bodyPr wrap="none" anchor="ctr"/>
-          <a:lstStyle/>
-          <a:p>
-            <a:endParaRPr lang="en-US"/>
-          </a:p>
-        </p:txBody>
-      </p:sp>
-      <p:sp>
-        <p:nvSpPr>
-          <p:cNvPr id="12" name="Line 6"/>
-          <p:cNvSpPr>
-            <a:spLocks noChangeShapeType="1"/>
-          </p:cNvSpPr>
-          <p:nvPr/>
-        </p:nvSpPr>
-        <p:spPr bwMode="auto">
-          <a:xfrm>
-            <a:off x="6615113" y="3533775"/>
-            <a:ext cx="2525713" cy="0"/>
-          </a:xfrm>
-          <a:prstGeom prst="line">
-            <a:avLst/>
-          </a:prstGeom>
-          <a:noFill/>
-          <a:ln w="9525">
-            <a:solidFill>
-              <a:srgbClr val="FF0000"/>
-            </a:solidFill>
-            <a:round/>
-            <a:headEnd/>
-            <a:tailEnd/>
-          </a:ln>
-        </p:spPr>
-        <p:txBody>
-          <a:bodyPr wrap="none" anchor="ctr"/>
-          <a:lstStyle/>
-          <a:p>
-            <a:endParaRPr lang="en-US"/>
-          </a:p>
-        </p:txBody>
-      </p:sp>
-      <p:sp>
-        <p:nvSpPr>
-          <p:cNvPr id="14" name="Text Box 8"/>
-          <p:cNvSpPr txBox="1">
-            <a:spLocks noChangeArrowheads="1"/>
-          </p:cNvSpPr>
-          <p:nvPr/>
-        </p:nvSpPr>
-        <p:spPr bwMode="auto">
-          <a:xfrm>
-            <a:off x="6505576" y="2954338"/>
-            <a:ext cx="1920875" cy="366713"/>
-          </a:xfrm>
-          <a:prstGeom prst="rect">
-            <a:avLst/>
-          </a:prstGeom>
-          <a:noFill/>
-          <a:ln w="9525" algn="ctr">
-            <a:noFill/>
-            <a:miter lim="800000"/>
-            <a:headEnd/>
-            <a:tailEnd/>
-          </a:ln>
-        </p:spPr>
-        <p:txBody>
-          <a:bodyPr>
-            <a:spAutoFit/>
-          </a:bodyPr>
-          <a:lstStyle/>
-          <a:p>
-            <a:pPr algn="ctr"/>
-            <a:r>
-              <a:rPr lang="en-US"/>
-              <a:t>Membrane</a:t>
-            </a:r>
-          </a:p>
-        </p:txBody>
-      </p:sp>
-      <p:sp>
-        <p:nvSpPr>
-          <p:cNvPr id="15" name="Line 9"/>
-          <p:cNvSpPr>
-            <a:spLocks noChangeShapeType="1"/>
-          </p:cNvSpPr>
-          <p:nvPr/>
-        </p:nvSpPr>
-        <p:spPr bwMode="auto">
-          <a:xfrm flipH="1">
-            <a:off x="7253287" y="3243263"/>
-            <a:ext cx="115888" cy="276225"/>
-          </a:xfrm>
-          <a:prstGeom prst="line">
-            <a:avLst/>
-          </a:prstGeom>
-          <a:noFill/>
-          <a:ln w="9525">
-            <a:solidFill>
-              <a:schemeClr val="tx1"/>
-            </a:solidFill>
-            <a:round/>
-            <a:headEnd/>
-            <a:tailEnd type="triangle" w="med" len="med"/>
-          </a:ln>
-        </p:spPr>
-        <p:txBody>
-          <a:bodyPr wrap="none" anchor="ctr"/>
-          <a:lstStyle/>
-          <a:p>
-            <a:endParaRPr lang="en-US"/>
-          </a:p>
-        </p:txBody>
-      </p:sp>
-      <p:sp>
-        <p:nvSpPr>
-          <p:cNvPr id="10" name="Rectangle 2"/>
-          <p:cNvSpPr>
-            <a:spLocks noChangeArrowheads="1"/>
-          </p:cNvSpPr>
-          <p:nvPr/>
-        </p:nvSpPr>
-        <p:spPr bwMode="auto">
-          <a:xfrm>
-            <a:off x="6629401" y="3519488"/>
-            <a:ext cx="2511425" cy="1871663"/>
-          </a:xfrm>
-          <a:prstGeom prst="rect">
-            <a:avLst/>
-          </a:prstGeom>
-          <a:gradFill rotWithShape="1">
-            <a:gsLst>
-              <a:gs pos="0">
-                <a:schemeClr val="bg1"/>
-              </a:gs>
-              <a:gs pos="100000">
-                <a:schemeClr val="accent1"/>
-              </a:gs>
-            </a:gsLst>
-            <a:path path="shape">
-              <a:fillToRect l="50000" t="50000" r="50000" b="50000"/>
-            </a:path>
-          </a:gradFill>
-          <a:ln w="9525" algn="ctr">
-            <a:solidFill>
-              <a:schemeClr val="tx1"/>
-            </a:solidFill>
-            <a:miter lim="800000"/>
-            <a:headEnd/>
-            <a:tailEnd/>
-          </a:ln>
-        </p:spPr>
-        <p:txBody>
-          <a:bodyPr wrap="none" anchor="ctr"/>
-          <a:lstStyle/>
-          <a:p>
-            <a:pPr algn="ctr"/>
-            <a:r>
-              <a:rPr lang="en-US"/>
-              <a:t>Gas at T</a:t>
-            </a:r>
-            <a:r>
-              <a:rPr lang="en-US" baseline="-25000"/>
-              <a:t>i</a:t>
-            </a:r>
-          </a:p>
-        </p:txBody>
-      </p:sp>
-      <p:sp>
-        <p:nvSpPr>
-          <p:cNvPr id="16" name="Rectangle 15"/>
-          <p:cNvSpPr/>
-          <p:nvPr/>
-        </p:nvSpPr>
-        <p:spPr>
-          <a:xfrm>
-            <a:off x="8382000" y="3505200"/>
-            <a:ext cx="152400" cy="76200"/>
-          </a:xfrm>
-          <a:prstGeom prst="rect">
-            <a:avLst/>
-          </a:prstGeom>
-          <a:solidFill>
-            <a:schemeClr val="accent1"/>
-          </a:solidFill>
-          <a:ln>
-            <a:noFill/>
-          </a:ln>
-        </p:spPr>
-        <p:style>
-          <a:lnRef idx="2">
-            <a:schemeClr val="accent1">
-              <a:shade val="50000"/>
-            </a:schemeClr>
-          </a:lnRef>
-          <a:fillRef idx="1">
-            <a:schemeClr val="accent1"/>
-          </a:fillRef>
-          <a:effectRef idx="0">
-            <a:schemeClr val="accent1"/>
-          </a:effectRef>
-          <a:fontRef idx="minor">
-            <a:schemeClr val="lt1"/>
-          </a:fontRef>
-        </p:style>
-        <p:txBody>
-          <a:bodyPr rtlCol="0" anchor="ctr"/>
-          <a:lstStyle/>
-          <a:p>
-            <a:pPr algn="ctr"/>
-            <a:endParaRPr lang="en-US"/>
-          </a:p>
-        </p:txBody>
-      </p:sp>
+            <a:r>
+              <a:rPr lang="en-US" dirty="0"/>
+              <a:t>Question</a:t>
+            </a:r>
+          </a:p>
+        </p:txBody>
+      </p:sp>
+      <mc:AlternateContent xmlns:mc="http://schemas.openxmlformats.org/markup-compatibility/2006">
+        <mc:Choice xmlns:a14="http://schemas.microsoft.com/office/drawing/2010/main" Requires="a14">
+          <p:sp>
+            <p:nvSpPr>
+              <p:cNvPr id="3" name="Content Placeholder 2">
+                <a:extLst>
+                  <a:ext uri="{FF2B5EF4-FFF2-40B4-BE49-F238E27FC236}">
+                    <a16:creationId xmlns:a16="http://schemas.microsoft.com/office/drawing/2014/main" id="{08537D8D-6AC6-1433-021B-54F0CF486FA0}"/>
+                  </a:ext>
+                </a:extLst>
+              </p:cNvPr>
+              <p:cNvSpPr>
+                <a:spLocks noGrp="1"/>
+              </p:cNvSpPr>
+              <p:nvPr>
+                <p:ph idx="1"/>
+              </p:nvPr>
+            </p:nvSpPr>
+            <p:spPr/>
+            <p:txBody>
+              <a:bodyPr/>
+              <a:lstStyle/>
+              <a:p>
+                <a:pPr marL="0" indent="0">
+                  <a:buNone/>
+                </a:pPr>
+                <a:r>
+                  <a:rPr lang="en-US" dirty="0"/>
+                  <a:t>For an adiabatic path, how does P depend on V?</a:t>
+                </a:r>
+              </a:p>
+              <a:p>
+                <a:pPr marL="514350" indent="-514350">
+                  <a:buFont typeface="+mj-lt"/>
+                  <a:buAutoNum type="alphaLcParenR"/>
+                </a:pPr>
+                <a:r>
+                  <a:rPr lang="en-US" dirty="0"/>
+                  <a:t> </a:t>
+                </a:r>
+                <a14:m>
+                  <m:oMath xmlns:m="http://schemas.openxmlformats.org/officeDocument/2006/math">
+                    <m:r>
+                      <a:rPr lang="en-US" b="0" i="1" smtClean="0">
+                        <a:latin typeface="Cambria Math" panose="02040503050406030204" pitchFamily="18" charset="0"/>
+                      </a:rPr>
+                      <m:t>𝑃</m:t>
+                    </m:r>
+                    <m:r>
+                      <a:rPr lang="en-US" b="0" i="1" smtClean="0">
+                        <a:latin typeface="Cambria Math" panose="02040503050406030204" pitchFamily="18" charset="0"/>
+                      </a:rPr>
+                      <m:t>=</m:t>
+                    </m:r>
+                    <m:f>
+                      <m:fPr>
+                        <m:ctrlPr>
+                          <a:rPr lang="en-US" b="0" i="1" smtClean="0">
+                            <a:latin typeface="Cambria Math" panose="02040503050406030204" pitchFamily="18" charset="0"/>
+                          </a:rPr>
+                        </m:ctrlPr>
+                      </m:fPr>
+                      <m:num>
+                        <m:r>
+                          <a:rPr lang="en-US" b="0" i="1" smtClean="0">
+                            <a:latin typeface="Cambria Math" panose="02040503050406030204" pitchFamily="18" charset="0"/>
+                          </a:rPr>
+                          <m:t>𝑛𝑅𝑇</m:t>
+                        </m:r>
+                      </m:num>
+                      <m:den>
+                        <m:r>
+                          <a:rPr lang="en-US" b="0" i="1" smtClean="0">
+                            <a:latin typeface="Cambria Math" panose="02040503050406030204" pitchFamily="18" charset="0"/>
+                          </a:rPr>
+                          <m:t>𝑉</m:t>
+                        </m:r>
+                      </m:den>
+                    </m:f>
+                  </m:oMath>
+                </a14:m>
+                <a:endParaRPr lang="en-US" dirty="0"/>
+              </a:p>
+              <a:p>
+                <a:pPr marL="514350" indent="-514350">
+                  <a:buFont typeface="+mj-lt"/>
+                  <a:buAutoNum type="alphaLcParenR"/>
+                </a:pPr>
+                <a:r>
+                  <a:rPr lang="en-US" dirty="0"/>
+                  <a:t> </a:t>
+                </a:r>
+                <a14:m>
+                  <m:oMath xmlns:m="http://schemas.openxmlformats.org/officeDocument/2006/math">
+                    <m:r>
+                      <a:rPr lang="en-US" i="1">
+                        <a:latin typeface="Cambria Math" panose="02040503050406030204" pitchFamily="18" charset="0"/>
+                      </a:rPr>
+                      <m:t>𝑃</m:t>
+                    </m:r>
+                    <m:r>
+                      <a:rPr lang="en-US" i="1">
+                        <a:latin typeface="Cambria Math" panose="02040503050406030204" pitchFamily="18" charset="0"/>
+                      </a:rPr>
+                      <m:t>=</m:t>
+                    </m:r>
+                    <m:f>
+                      <m:fPr>
+                        <m:ctrlPr>
+                          <a:rPr lang="en-US" i="1">
+                            <a:latin typeface="Cambria Math" panose="02040503050406030204" pitchFamily="18" charset="0"/>
+                          </a:rPr>
+                        </m:ctrlPr>
+                      </m:fPr>
+                      <m:num>
+                        <m:r>
+                          <a:rPr lang="en-US" b="0" i="1" smtClean="0">
+                            <a:latin typeface="Cambria Math" panose="02040503050406030204" pitchFamily="18" charset="0"/>
+                          </a:rPr>
+                          <m:t>𝑉</m:t>
+                        </m:r>
+                      </m:num>
+                      <m:den>
+                        <m:r>
+                          <a:rPr lang="en-US" b="0" i="1" smtClean="0">
+                            <a:latin typeface="Cambria Math" panose="02040503050406030204" pitchFamily="18" charset="0"/>
+                          </a:rPr>
+                          <m:t>𝑛𝑅𝑇</m:t>
+                        </m:r>
+                      </m:den>
+                    </m:f>
+                  </m:oMath>
+                </a14:m>
+                <a:endParaRPr lang="en-US" dirty="0"/>
+              </a:p>
+              <a:p>
+                <a:pPr marL="514350" indent="-514350">
+                  <a:buFont typeface="+mj-lt"/>
+                  <a:buAutoNum type="alphaLcParenR"/>
+                </a:pPr>
+                <a:r>
+                  <a:rPr lang="en-US" dirty="0"/>
+                  <a:t> </a:t>
+                </a:r>
+                <a14:m>
+                  <m:oMath xmlns:m="http://schemas.openxmlformats.org/officeDocument/2006/math">
+                    <m:r>
+                      <a:rPr lang="en-US" i="1">
+                        <a:latin typeface="Cambria Math" panose="02040503050406030204" pitchFamily="18" charset="0"/>
+                      </a:rPr>
+                      <m:t>𝑃</m:t>
+                    </m:r>
+                    <m:r>
+                      <a:rPr lang="en-US" i="1">
+                        <a:latin typeface="Cambria Math" panose="02040503050406030204" pitchFamily="18" charset="0"/>
+                      </a:rPr>
+                      <m:t>=</m:t>
+                    </m:r>
+                    <m:f>
+                      <m:fPr>
+                        <m:ctrlPr>
+                          <a:rPr lang="en-US" i="1">
+                            <a:latin typeface="Cambria Math" panose="02040503050406030204" pitchFamily="18" charset="0"/>
+                          </a:rPr>
+                        </m:ctrlPr>
+                      </m:fPr>
+                      <m:num>
+                        <m:r>
+                          <a:rPr lang="en-US" b="0" i="1" smtClean="0">
+                            <a:latin typeface="Cambria Math" panose="02040503050406030204" pitchFamily="18" charset="0"/>
+                          </a:rPr>
+                          <m:t>𝐶</m:t>
+                        </m:r>
+                      </m:num>
+                      <m:den>
+                        <m:sSup>
+                          <m:sSupPr>
+                            <m:ctrlPr>
+                              <a:rPr lang="en-US" i="1" smtClean="0">
+                                <a:latin typeface="Cambria Math" panose="02040503050406030204" pitchFamily="18" charset="0"/>
+                              </a:rPr>
+                            </m:ctrlPr>
+                          </m:sSupPr>
+                          <m:e>
+                            <m:r>
+                              <a:rPr lang="en-US" b="0" i="1" smtClean="0">
+                                <a:latin typeface="Cambria Math" panose="02040503050406030204" pitchFamily="18" charset="0"/>
+                              </a:rPr>
+                              <m:t>𝑉</m:t>
+                            </m:r>
+                          </m:e>
+                          <m:sup>
+                            <m:r>
+                              <a:rPr lang="en-US" i="1" smtClean="0">
+                                <a:latin typeface="Cambria Math" panose="02040503050406030204" pitchFamily="18" charset="0"/>
+                                <a:ea typeface="Cambria Math" panose="02040503050406030204" pitchFamily="18" charset="0"/>
+                              </a:rPr>
+                              <m:t>𝛾</m:t>
+                            </m:r>
+                          </m:sup>
+                        </m:sSup>
+                      </m:den>
+                    </m:f>
+                  </m:oMath>
+                </a14:m>
+                <a:endParaRPr lang="en-US" dirty="0"/>
+              </a:p>
+              <a:p>
+                <a:pPr marL="514350" indent="-514350">
+                  <a:buFont typeface="+mj-lt"/>
+                  <a:buAutoNum type="alphaLcParenR"/>
+                </a:pPr>
+                <a:r>
+                  <a:rPr lang="en-US" dirty="0"/>
+                  <a:t>P is a constant</a:t>
+                </a:r>
+              </a:p>
+            </p:txBody>
+          </p:sp>
+        </mc:Choice>
+        <mc:Fallback>
+          <p:sp>
+            <p:nvSpPr>
+              <p:cNvPr id="3" name="Content Placeholder 2">
+                <a:extLst>
+                  <a:ext uri="{FF2B5EF4-FFF2-40B4-BE49-F238E27FC236}">
+                    <a16:creationId xmlns:a16="http://schemas.microsoft.com/office/drawing/2014/main" id="{08537D8D-6AC6-1433-021B-54F0CF486FA0}"/>
+                  </a:ext>
+                </a:extLst>
+              </p:cNvPr>
+              <p:cNvSpPr>
+                <a:spLocks noGrp="1" noRot="1" noChangeAspect="1" noMove="1" noResize="1" noEditPoints="1" noAdjustHandles="1" noChangeArrowheads="1" noChangeShapeType="1" noTextEdit="1"/>
+              </p:cNvSpPr>
+              <p:nvPr>
+                <p:ph idx="1"/>
+              </p:nvPr>
+            </p:nvSpPr>
+            <p:spPr>
+              <a:blipFill>
+                <a:blip r:embed="rId2"/>
+                <a:stretch>
+                  <a:fillRect l="-1217" t="-2381"/>
+                </a:stretch>
+              </a:blipFill>
+            </p:spPr>
+            <p:txBody>
+              <a:bodyPr/>
+              <a:lstStyle/>
+              <a:p>
+                <a:r>
+                  <a:rPr lang="en-US">
+                    <a:noFill/>
+                  </a:rPr>
+                  <a:t> </a:t>
+                </a:r>
+              </a:p>
+            </p:txBody>
+          </p:sp>
+        </mc:Fallback>
+      </mc:AlternateContent>
     </p:spTree>
+    <p:extLst>
+      <p:ext uri="{BB962C8B-B14F-4D97-AF65-F5344CB8AC3E}">
+        <p14:creationId xmlns:p14="http://schemas.microsoft.com/office/powerpoint/2010/main" val="1446333334"/>
+      </p:ext>
+    </p:extLst>
   </p:cSld>
   <p:clrMapOvr>
     <a:masterClrMapping/>
@@ -4476,7 +5804,13 @@
   <p:cSld>
     <p:spTree>
       <p:nvGrpSpPr>
-        <p:cNvPr id="1" name=""/>
+        <p:cNvPr id="1" name="">
+          <a:extLst>
+            <a:ext uri="{FF2B5EF4-FFF2-40B4-BE49-F238E27FC236}">
+              <a16:creationId xmlns:a16="http://schemas.microsoft.com/office/drawing/2014/main" id="{977CBB96-8612-AF3D-29E1-BC5BEC30954E}"/>
+            </a:ext>
+          </a:extLst>
+        </p:cNvPr>
         <p:cNvGrpSpPr/>
         <p:nvPr/>
       </p:nvGrpSpPr>
@@ -4488,78 +5822,42 @@
           <a:chExt cx="0" cy="0"/>
         </a:xfrm>
       </p:grpSpPr>
-      <p:sp>
-        <p:nvSpPr>
-          <p:cNvPr id="2" name="Title 1"/>
-          <p:cNvSpPr>
-            <a:spLocks noGrp="1"/>
-          </p:cNvSpPr>
-          <p:nvPr>
-            <p:ph type="title"/>
-          </p:nvPr>
-        </p:nvSpPr>
-        <p:spPr/>
-        <p:txBody>
-          <a:bodyPr/>
-          <a:lstStyle/>
-          <a:p>
-            <a:endParaRPr lang="en-US"/>
-          </a:p>
-        </p:txBody>
-      </p:sp>
-      <p:sp>
-        <p:nvSpPr>
-          <p:cNvPr id="3" name="Content Placeholder 2"/>
-          <p:cNvSpPr>
-            <a:spLocks noGrp="1"/>
-          </p:cNvSpPr>
-          <p:nvPr>
-            <p:ph idx="1"/>
-          </p:nvPr>
-        </p:nvSpPr>
-        <p:spPr/>
-        <p:txBody>
-          <a:bodyPr/>
-          <a:lstStyle/>
-          <a:p>
-            <a:endParaRPr lang="en-US"/>
-          </a:p>
-        </p:txBody>
-      </p:sp>
       <p:pic>
         <p:nvPicPr>
-          <p:cNvPr id="6146" name="Picture 2"/>
+          <p:cNvPr id="5" name="Picture 4">
+            <a:extLst>
+              <a:ext uri="{FF2B5EF4-FFF2-40B4-BE49-F238E27FC236}">
+                <a16:creationId xmlns:a16="http://schemas.microsoft.com/office/drawing/2014/main" id="{AE903580-2AB8-B212-8019-F97B758FEAEF}"/>
+              </a:ext>
+            </a:extLst>
+          </p:cNvPr>
           <p:cNvPicPr>
-            <a:picLocks noChangeAspect="1" noChangeArrowheads="1"/>
+            <a:picLocks noChangeAspect="1"/>
           </p:cNvPicPr>
           <p:nvPr/>
         </p:nvPicPr>
         <p:blipFill>
-          <a:blip r:embed="rId2" cstate="print"/>
-          <a:srcRect/>
+          <a:blip r:embed="rId2"/>
           <a:stretch>
             <a:fillRect/>
           </a:stretch>
         </p:blipFill>
-        <p:spPr bwMode="auto">
+        <p:spPr>
           <a:xfrm>
-            <a:off x="2971800" y="533401"/>
-            <a:ext cx="5181600" cy="5252339"/>
+            <a:off x="2147772" y="809625"/>
+            <a:ext cx="7224827" cy="4793170"/>
           </a:xfrm>
           <a:prstGeom prst="rect">
             <a:avLst/>
           </a:prstGeom>
-          <a:noFill/>
-          <a:ln w="9525">
-            <a:noFill/>
-            <a:miter lim="800000"/>
-            <a:headEnd/>
-            <a:tailEnd/>
-          </a:ln>
-          <a:effectLst/>
         </p:spPr>
       </p:pic>
     </p:spTree>
+    <p:extLst>
+      <p:ext uri="{BB962C8B-B14F-4D97-AF65-F5344CB8AC3E}">
+        <p14:creationId xmlns:p14="http://schemas.microsoft.com/office/powerpoint/2010/main" val="3465067879"/>
+      </p:ext>
+    </p:extLst>
   </p:cSld>
   <p:clrMapOvr>
     <a:masterClrMapping/>
@@ -4572,7 +5870,13 @@
   <p:cSld>
     <p:spTree>
       <p:nvGrpSpPr>
-        <p:cNvPr id="1" name=""/>
+        <p:cNvPr id="1" name="">
+          <a:extLst>
+            <a:ext uri="{FF2B5EF4-FFF2-40B4-BE49-F238E27FC236}">
+              <a16:creationId xmlns:a16="http://schemas.microsoft.com/office/drawing/2014/main" id="{1EA6703A-134E-E542-D780-AF3EE16C5868}"/>
+            </a:ext>
+          </a:extLst>
+        </p:cNvPr>
         <p:cNvGrpSpPr/>
         <p:nvPr/>
       </p:nvGrpSpPr>
@@ -4586,89 +5890,15 @@
       </p:grpSpPr>
       <p:sp>
         <p:nvSpPr>
-          <p:cNvPr id="183298" name="Slide Number Placeholder 5"/>
-          <p:cNvSpPr>
-            <a:spLocks noGrp="1"/>
-          </p:cNvSpPr>
-          <p:nvPr>
-            <p:ph type="sldNum" sz="quarter" idx="12"/>
-          </p:nvPr>
-        </p:nvSpPr>
-        <p:spPr>
-          <a:noFill/>
-        </p:spPr>
-        <p:txBody>
-          <a:bodyPr/>
-          <a:lstStyle/>
-          <a:p>
-            <a:fld id="{C2812B8D-E844-4807-B20D-B92C141DEBC2}" type="slidenum">
-              <a:rPr lang="en-US" smtClean="0"/>
-              <a:pPr/>
-              <a:t>7</a:t>
-            </a:fld>
-            <a:endParaRPr lang="en-US"/>
-          </a:p>
-        </p:txBody>
-      </p:sp>
-      <p:sp>
-        <p:nvSpPr>
-          <p:cNvPr id="183299" name="Rectangle 2"/>
-          <p:cNvSpPr>
-            <a:spLocks noChangeArrowheads="1"/>
-          </p:cNvSpPr>
-          <p:nvPr/>
-        </p:nvSpPr>
-        <p:spPr bwMode="auto">
-          <a:xfrm>
-            <a:off x="7402514" y="3657601"/>
-            <a:ext cx="2511425" cy="1871663"/>
-          </a:xfrm>
-          <a:prstGeom prst="rect">
-            <a:avLst/>
-          </a:prstGeom>
-          <a:gradFill rotWithShape="1">
-            <a:gsLst>
-              <a:gs pos="0">
-                <a:schemeClr val="bg1"/>
-              </a:gs>
-              <a:gs pos="100000">
-                <a:schemeClr val="accent1"/>
-              </a:gs>
-            </a:gsLst>
-            <a:path path="shape">
-              <a:fillToRect l="50000" t="50000" r="50000" b="50000"/>
-            </a:path>
-          </a:gradFill>
-          <a:ln w="9525" algn="ctr">
-            <a:solidFill>
-              <a:schemeClr val="tx1"/>
-            </a:solidFill>
-            <a:miter lim="800000"/>
-            <a:headEnd/>
-            <a:tailEnd/>
-          </a:ln>
-        </p:spPr>
-        <p:txBody>
-          <a:bodyPr wrap="none" anchor="ctr"/>
-          <a:lstStyle/>
-          <a:p>
-            <a:pPr algn="ctr"/>
-            <a:r>
-              <a:rPr lang="en-US"/>
-              <a:t>Gas at T</a:t>
-            </a:r>
-            <a:r>
-              <a:rPr lang="en-US" baseline="-25000"/>
-              <a:t>i</a:t>
-            </a:r>
-          </a:p>
-        </p:txBody>
-      </p:sp>
-      <p:sp>
-        <p:nvSpPr>
-          <p:cNvPr id="183300" name="Rectangle 3"/>
-          <p:cNvSpPr>
-            <a:spLocks noGrp="1" noChangeArrowheads="1"/>
+          <p:cNvPr id="2" name="Title 1">
+            <a:extLst>
+              <a:ext uri="{FF2B5EF4-FFF2-40B4-BE49-F238E27FC236}">
+                <a16:creationId xmlns:a16="http://schemas.microsoft.com/office/drawing/2014/main" id="{C0882AB9-9123-611E-824E-4DB8A8649A54}"/>
+              </a:ext>
+            </a:extLst>
+          </p:cNvPr>
+          <p:cNvSpPr>
+            <a:spLocks noGrp="1"/>
           </p:cNvSpPr>
           <p:nvPr>
             <p:ph type="title"/>
@@ -4679,269 +5909,369 @@
           <a:bodyPr/>
           <a:lstStyle/>
           <a:p>
-            <a:pPr eaLnBrk="1" hangingPunct="1"/>
-            <a:r>
-              <a:rPr lang="en-US"/>
-              <a:t>Question 123.10.7</a:t>
-            </a:r>
-            <a:endParaRPr lang="en-US" dirty="0"/>
-          </a:p>
-        </p:txBody>
-      </p:sp>
-      <p:sp>
-        <p:nvSpPr>
-          <p:cNvPr id="183301" name="Rectangle 4"/>
-          <p:cNvSpPr>
-            <a:spLocks noGrp="1" noChangeArrowheads="1"/>
-          </p:cNvSpPr>
-          <p:nvPr>
-            <p:ph type="body" idx="1"/>
-          </p:nvPr>
-        </p:nvSpPr>
-        <p:spPr>
-          <a:xfrm>
-            <a:off x="1981201" y="1600201"/>
-            <a:ext cx="3978275" cy="4525963"/>
-          </a:xfrm>
-        </p:spPr>
-        <p:txBody>
-          <a:bodyPr/>
-          <a:lstStyle/>
-          <a:p>
-            <a:pPr marL="609600" indent="-609600">
-              <a:lnSpc>
-                <a:spcPct val="80000"/>
-              </a:lnSpc>
-              <a:buNone/>
-            </a:pPr>
-            <a:r>
-              <a:rPr lang="en-US"/>
-              <a:t>The initial state of a system is shown, if the membrane is broken, the gas fills the entire container. Is there work done by the gas in filling the container?</a:t>
-            </a:r>
-          </a:p>
-          <a:p>
-            <a:pPr marL="609600" indent="-609600">
-              <a:lnSpc>
-                <a:spcPct val="80000"/>
-              </a:lnSpc>
-              <a:buFontTx/>
-              <a:buAutoNum type="alphaLcParenR"/>
-            </a:pPr>
-            <a:r>
-              <a:rPr lang="en-US"/>
-              <a:t>Yes</a:t>
-            </a:r>
-          </a:p>
-          <a:p>
-            <a:pPr marL="609600" indent="-609600">
-              <a:lnSpc>
-                <a:spcPct val="80000"/>
-              </a:lnSpc>
-              <a:buFontTx/>
-              <a:buAutoNum type="alphaLcParenR"/>
-            </a:pPr>
-            <a:r>
-              <a:rPr lang="en-US"/>
-              <a:t>No</a:t>
-            </a:r>
-          </a:p>
-          <a:p>
-            <a:pPr marL="609600" indent="-609600">
-              <a:lnSpc>
-                <a:spcPct val="80000"/>
-              </a:lnSpc>
-              <a:buFontTx/>
-              <a:buAutoNum type="alphaLcParenR"/>
-            </a:pPr>
-            <a:r>
-              <a:rPr lang="en-US"/>
-              <a:t>Can’t Tell</a:t>
-            </a:r>
-          </a:p>
-        </p:txBody>
-      </p:sp>
-      <p:sp>
-        <p:nvSpPr>
-          <p:cNvPr id="183302" name="Rectangle 5"/>
-          <p:cNvSpPr>
-            <a:spLocks noChangeArrowheads="1"/>
-          </p:cNvSpPr>
-          <p:nvPr/>
-        </p:nvSpPr>
-        <p:spPr bwMode="auto">
-          <a:xfrm>
-            <a:off x="7402514" y="1814514"/>
-            <a:ext cx="2511425" cy="3730625"/>
-          </a:xfrm>
-          <a:prstGeom prst="rect">
-            <a:avLst/>
-          </a:prstGeom>
-          <a:noFill/>
-          <a:ln w="53975" algn="ctr">
-            <a:solidFill>
-              <a:srgbClr val="FF9900"/>
-            </a:solidFill>
-            <a:miter lim="800000"/>
-            <a:headEnd/>
-            <a:tailEnd/>
-          </a:ln>
-        </p:spPr>
-        <p:txBody>
-          <a:bodyPr wrap="none" anchor="ctr"/>
-          <a:lstStyle/>
-          <a:p>
-            <a:endParaRPr lang="en-US"/>
-          </a:p>
-        </p:txBody>
-      </p:sp>
-      <p:sp>
-        <p:nvSpPr>
-          <p:cNvPr id="183303" name="Line 6"/>
-          <p:cNvSpPr>
-            <a:spLocks noChangeShapeType="1"/>
-          </p:cNvSpPr>
-          <p:nvPr/>
-        </p:nvSpPr>
-        <p:spPr bwMode="auto">
-          <a:xfrm>
-            <a:off x="7388226" y="3671888"/>
-            <a:ext cx="2525713" cy="0"/>
-          </a:xfrm>
-          <a:prstGeom prst="line">
-            <a:avLst/>
-          </a:prstGeom>
-          <a:noFill/>
-          <a:ln w="9525">
-            <a:solidFill>
-              <a:srgbClr val="FF0000"/>
-            </a:solidFill>
-            <a:round/>
-            <a:headEnd/>
-            <a:tailEnd/>
-          </a:ln>
-        </p:spPr>
-        <p:txBody>
-          <a:bodyPr wrap="none" anchor="ctr"/>
-          <a:lstStyle/>
-          <a:p>
-            <a:endParaRPr lang="en-US"/>
-          </a:p>
-        </p:txBody>
-      </p:sp>
-      <p:sp>
-        <p:nvSpPr>
-          <p:cNvPr id="183304" name="Text Box 7"/>
-          <p:cNvSpPr txBox="1">
-            <a:spLocks noChangeArrowheads="1"/>
-          </p:cNvSpPr>
-          <p:nvPr/>
-        </p:nvSpPr>
-        <p:spPr bwMode="auto">
-          <a:xfrm>
-            <a:off x="8097838" y="2286001"/>
-            <a:ext cx="1136650" cy="366713"/>
-          </a:xfrm>
-          <a:prstGeom prst="rect">
-            <a:avLst/>
-          </a:prstGeom>
-          <a:noFill/>
-          <a:ln w="9525" algn="ctr">
-            <a:noFill/>
-            <a:miter lim="800000"/>
-            <a:headEnd/>
-            <a:tailEnd/>
-          </a:ln>
-        </p:spPr>
-        <p:txBody>
-          <a:bodyPr>
-            <a:spAutoFit/>
-          </a:bodyPr>
-          <a:lstStyle/>
-          <a:p>
-            <a:pPr algn="ctr"/>
-            <a:r>
-              <a:rPr lang="en-US"/>
-              <a:t>Vacuum</a:t>
-            </a:r>
-          </a:p>
-        </p:txBody>
-      </p:sp>
-      <p:sp>
-        <p:nvSpPr>
-          <p:cNvPr id="183305" name="Text Box 8"/>
-          <p:cNvSpPr txBox="1">
-            <a:spLocks noChangeArrowheads="1"/>
-          </p:cNvSpPr>
-          <p:nvPr/>
-        </p:nvSpPr>
-        <p:spPr bwMode="auto">
-          <a:xfrm>
-            <a:off x="7278689" y="3092451"/>
-            <a:ext cx="1920875" cy="366713"/>
-          </a:xfrm>
-          <a:prstGeom prst="rect">
-            <a:avLst/>
-          </a:prstGeom>
-          <a:noFill/>
-          <a:ln w="9525" algn="ctr">
-            <a:noFill/>
-            <a:miter lim="800000"/>
-            <a:headEnd/>
-            <a:tailEnd/>
-          </a:ln>
-        </p:spPr>
-        <p:txBody>
-          <a:bodyPr>
-            <a:spAutoFit/>
-          </a:bodyPr>
-          <a:lstStyle/>
-          <a:p>
-            <a:pPr algn="ctr"/>
-            <a:r>
-              <a:rPr lang="en-US"/>
-              <a:t>Membrane</a:t>
-            </a:r>
-          </a:p>
-        </p:txBody>
-      </p:sp>
-      <p:sp>
-        <p:nvSpPr>
-          <p:cNvPr id="183306" name="Line 9"/>
-          <p:cNvSpPr>
-            <a:spLocks noChangeShapeType="1"/>
-          </p:cNvSpPr>
-          <p:nvPr/>
-        </p:nvSpPr>
-        <p:spPr bwMode="auto">
-          <a:xfrm flipH="1">
-            <a:off x="8026400" y="3381376"/>
-            <a:ext cx="115888" cy="276225"/>
-          </a:xfrm>
-          <a:prstGeom prst="line">
-            <a:avLst/>
-          </a:prstGeom>
-          <a:noFill/>
-          <a:ln w="9525">
-            <a:solidFill>
-              <a:schemeClr val="tx1"/>
-            </a:solidFill>
-            <a:round/>
-            <a:headEnd/>
-            <a:tailEnd type="triangle" w="med" len="med"/>
-          </a:ln>
-        </p:spPr>
-        <p:txBody>
-          <a:bodyPr wrap="none" anchor="ctr"/>
-          <a:lstStyle/>
-          <a:p>
-            <a:endParaRPr lang="en-US"/>
-          </a:p>
-        </p:txBody>
-      </p:sp>
+            <a:r>
+              <a:rPr lang="en-US" dirty="0"/>
+              <a:t>Question</a:t>
+            </a:r>
+          </a:p>
+        </p:txBody>
+      </p:sp>
+      <mc:AlternateContent xmlns:mc="http://schemas.openxmlformats.org/markup-compatibility/2006">
+        <mc:Choice xmlns:a14="http://schemas.microsoft.com/office/drawing/2010/main" Requires="a14">
+          <p:sp>
+            <p:nvSpPr>
+              <p:cNvPr id="3" name="Content Placeholder 2">
+                <a:extLst>
+                  <a:ext uri="{FF2B5EF4-FFF2-40B4-BE49-F238E27FC236}">
+                    <a16:creationId xmlns:a16="http://schemas.microsoft.com/office/drawing/2014/main" id="{6F64307E-3582-259B-6FFF-E34800D93684}"/>
+                  </a:ext>
+                </a:extLst>
+              </p:cNvPr>
+              <p:cNvSpPr>
+                <a:spLocks noGrp="1"/>
+              </p:cNvSpPr>
+              <p:nvPr>
+                <p:ph idx="1"/>
+              </p:nvPr>
+            </p:nvSpPr>
+            <p:spPr/>
+            <p:txBody>
+              <a:bodyPr/>
+              <a:lstStyle/>
+              <a:p>
+                <a:pPr marL="0" indent="0">
+                  <a:buNone/>
+                </a:pPr>
+                <a:r>
+                  <a:rPr lang="en-US" dirty="0"/>
+                  <a:t>Which of the following is true?</a:t>
+                </a:r>
+              </a:p>
+              <a:p>
+                <a:pPr marL="514350" indent="-514350">
+                  <a:buFont typeface="+mj-lt"/>
+                  <a:buAutoNum type="alphaLcParenR"/>
+                </a:pPr>
+                <a:r>
+                  <a:rPr lang="en-US" dirty="0"/>
+                  <a:t> </a:t>
+                </a:r>
+                <a14:m>
+                  <m:oMath xmlns:m="http://schemas.openxmlformats.org/officeDocument/2006/math">
+                    <m:r>
+                      <a:rPr lang="en-US" b="0" i="1" smtClean="0">
+                        <a:latin typeface="Cambria Math" panose="02040503050406030204" pitchFamily="18" charset="0"/>
+                      </a:rPr>
+                      <m:t>𝑎</m:t>
+                    </m:r>
+                    <m:func>
+                      <m:funcPr>
+                        <m:ctrlPr>
+                          <a:rPr lang="en-US" b="0" i="1" smtClean="0">
+                            <a:latin typeface="Cambria Math" panose="02040503050406030204" pitchFamily="18" charset="0"/>
+                          </a:rPr>
+                        </m:ctrlPr>
+                      </m:funcPr>
+                      <m:fName>
+                        <m:r>
+                          <m:rPr>
+                            <m:sty m:val="p"/>
+                          </m:rPr>
+                          <a:rPr lang="en-US" b="0" i="0" smtClean="0">
+                            <a:latin typeface="Cambria Math" panose="02040503050406030204" pitchFamily="18" charset="0"/>
+                          </a:rPr>
+                          <m:t>ln</m:t>
+                        </m:r>
+                      </m:fName>
+                      <m:e>
+                        <m:r>
+                          <a:rPr lang="en-US" b="0" i="1" smtClean="0">
+                            <a:latin typeface="Cambria Math" panose="02040503050406030204" pitchFamily="18" charset="0"/>
+                          </a:rPr>
+                          <m:t>𝑏</m:t>
+                        </m:r>
+                        <m:r>
+                          <a:rPr lang="en-US" b="0" i="1" smtClean="0">
+                            <a:latin typeface="Cambria Math" panose="02040503050406030204" pitchFamily="18" charset="0"/>
+                          </a:rPr>
+                          <m:t>=</m:t>
+                        </m:r>
+                        <m:func>
+                          <m:funcPr>
+                            <m:ctrlPr>
+                              <a:rPr lang="en-US" b="0" i="1" smtClean="0">
+                                <a:latin typeface="Cambria Math" panose="02040503050406030204" pitchFamily="18" charset="0"/>
+                              </a:rPr>
+                            </m:ctrlPr>
+                          </m:funcPr>
+                          <m:fName>
+                            <m:r>
+                              <m:rPr>
+                                <m:sty m:val="p"/>
+                              </m:rPr>
+                              <a:rPr lang="en-US" b="0" i="0" smtClean="0">
+                                <a:latin typeface="Cambria Math" panose="02040503050406030204" pitchFamily="18" charset="0"/>
+                              </a:rPr>
+                              <m:t>ln</m:t>
+                            </m:r>
+                          </m:fName>
+                          <m:e>
+                            <m:sSup>
+                              <m:sSupPr>
+                                <m:ctrlPr>
+                                  <a:rPr lang="en-US" b="0" i="1" smtClean="0">
+                                    <a:latin typeface="Cambria Math" panose="02040503050406030204" pitchFamily="18" charset="0"/>
+                                  </a:rPr>
+                                </m:ctrlPr>
+                              </m:sSupPr>
+                              <m:e>
+                                <m:r>
+                                  <a:rPr lang="en-US" b="0" i="1" smtClean="0">
+                                    <a:latin typeface="Cambria Math" panose="02040503050406030204" pitchFamily="18" charset="0"/>
+                                  </a:rPr>
+                                  <m:t>𝑏</m:t>
+                                </m:r>
+                              </m:e>
+                              <m:sup>
+                                <m:r>
+                                  <a:rPr lang="en-US" b="0" i="1" smtClean="0">
+                                    <a:latin typeface="Cambria Math" panose="02040503050406030204" pitchFamily="18" charset="0"/>
+                                  </a:rPr>
+                                  <m:t>𝑎</m:t>
+                                </m:r>
+                              </m:sup>
+                            </m:sSup>
+                          </m:e>
+                        </m:func>
+                      </m:e>
+                    </m:func>
+                  </m:oMath>
+                </a14:m>
+                <a:endParaRPr lang="en-US" dirty="0"/>
+              </a:p>
+              <a:p>
+                <a:pPr marL="514350" indent="-514350">
+                  <a:buFont typeface="+mj-lt"/>
+                  <a:buAutoNum type="alphaLcParenR"/>
+                </a:pPr>
+                <a:r>
+                  <a:rPr lang="en-US" dirty="0"/>
+                  <a:t> </a:t>
+                </a:r>
+                <a14:m>
+                  <m:oMath xmlns:m="http://schemas.openxmlformats.org/officeDocument/2006/math">
+                    <m:func>
+                      <m:funcPr>
+                        <m:ctrlPr>
+                          <a:rPr lang="en-US" i="1" smtClean="0">
+                            <a:latin typeface="Cambria Math" panose="02040503050406030204" pitchFamily="18" charset="0"/>
+                          </a:rPr>
+                        </m:ctrlPr>
+                      </m:funcPr>
+                      <m:fName>
+                        <m:r>
+                          <m:rPr>
+                            <m:sty m:val="p"/>
+                          </m:rPr>
+                          <a:rPr lang="en-US" i="0" smtClean="0">
+                            <a:latin typeface="Cambria Math" panose="02040503050406030204" pitchFamily="18" charset="0"/>
+                          </a:rPr>
+                          <m:t>ln</m:t>
+                        </m:r>
+                      </m:fName>
+                      <m:e>
+                        <m:r>
+                          <a:rPr lang="en-US" b="0" i="1" smtClean="0">
+                            <a:latin typeface="Cambria Math" panose="02040503050406030204" pitchFamily="18" charset="0"/>
+                          </a:rPr>
+                          <m:t>𝑎</m:t>
+                        </m:r>
+                        <m:r>
+                          <a:rPr lang="en-US" b="0" i="1" smtClean="0">
+                            <a:latin typeface="Cambria Math" panose="02040503050406030204" pitchFamily="18" charset="0"/>
+                          </a:rPr>
+                          <m:t>+</m:t>
+                        </m:r>
+                        <m:func>
+                          <m:funcPr>
+                            <m:ctrlPr>
+                              <a:rPr lang="en-US" b="0" i="1" smtClean="0">
+                                <a:latin typeface="Cambria Math" panose="02040503050406030204" pitchFamily="18" charset="0"/>
+                              </a:rPr>
+                            </m:ctrlPr>
+                          </m:funcPr>
+                          <m:fName>
+                            <m:r>
+                              <m:rPr>
+                                <m:sty m:val="p"/>
+                              </m:rPr>
+                              <a:rPr lang="en-US" b="0" i="0" smtClean="0">
+                                <a:latin typeface="Cambria Math" panose="02040503050406030204" pitchFamily="18" charset="0"/>
+                              </a:rPr>
+                              <m:t>ln</m:t>
+                            </m:r>
+                          </m:fName>
+                          <m:e>
+                            <m:r>
+                              <a:rPr lang="en-US" b="0" i="1" smtClean="0">
+                                <a:latin typeface="Cambria Math" panose="02040503050406030204" pitchFamily="18" charset="0"/>
+                              </a:rPr>
+                              <m:t>𝑏</m:t>
+                            </m:r>
+                          </m:e>
+                        </m:func>
+                        <m:r>
+                          <a:rPr lang="en-US" b="0" i="1" smtClean="0">
+                            <a:latin typeface="Cambria Math" panose="02040503050406030204" pitchFamily="18" charset="0"/>
+                          </a:rPr>
+                          <m:t>=</m:t>
+                        </m:r>
+                        <m:func>
+                          <m:funcPr>
+                            <m:ctrlPr>
+                              <a:rPr lang="en-US" b="0" i="1" smtClean="0">
+                                <a:latin typeface="Cambria Math" panose="02040503050406030204" pitchFamily="18" charset="0"/>
+                              </a:rPr>
+                            </m:ctrlPr>
+                          </m:funcPr>
+                          <m:fName>
+                            <m:r>
+                              <m:rPr>
+                                <m:sty m:val="p"/>
+                              </m:rPr>
+                              <a:rPr lang="en-US" b="0" i="0" smtClean="0">
+                                <a:latin typeface="Cambria Math" panose="02040503050406030204" pitchFamily="18" charset="0"/>
+                              </a:rPr>
+                              <m:t>ln</m:t>
+                            </m:r>
+                          </m:fName>
+                          <m:e>
+                            <m:r>
+                              <a:rPr lang="en-US" b="0" i="1" smtClean="0">
+                                <a:latin typeface="Cambria Math" panose="02040503050406030204" pitchFamily="18" charset="0"/>
+                              </a:rPr>
+                              <m:t>𝑎𝑏</m:t>
+                            </m:r>
+                          </m:e>
+                        </m:func>
+                      </m:e>
+                    </m:func>
+                  </m:oMath>
+                </a14:m>
+                <a:endParaRPr lang="en-US" dirty="0"/>
+              </a:p>
+              <a:p>
+                <a:pPr marL="514350" indent="-514350">
+                  <a:buFont typeface="+mj-lt"/>
+                  <a:buAutoNum type="alphaLcParenR"/>
+                </a:pPr>
+                <a:r>
+                  <a:rPr lang="en-US" dirty="0"/>
+                  <a:t> </a:t>
+                </a:r>
+                <a14:m>
+                  <m:oMath xmlns:m="http://schemas.openxmlformats.org/officeDocument/2006/math">
+                    <m:func>
+                      <m:funcPr>
+                        <m:ctrlPr>
+                          <a:rPr lang="en-US" i="1" smtClean="0">
+                            <a:latin typeface="Cambria Math" panose="02040503050406030204" pitchFamily="18" charset="0"/>
+                          </a:rPr>
+                        </m:ctrlPr>
+                      </m:funcPr>
+                      <m:fName>
+                        <m:r>
+                          <m:rPr>
+                            <m:sty m:val="p"/>
+                          </m:rPr>
+                          <a:rPr lang="en-US" i="0" smtClean="0">
+                            <a:latin typeface="Cambria Math" panose="02040503050406030204" pitchFamily="18" charset="0"/>
+                          </a:rPr>
+                          <m:t>ln</m:t>
+                        </m:r>
+                      </m:fName>
+                      <m:e>
+                        <m:r>
+                          <a:rPr lang="en-US" b="0" i="1" smtClean="0">
+                            <a:latin typeface="Cambria Math" panose="02040503050406030204" pitchFamily="18" charset="0"/>
+                          </a:rPr>
+                          <m:t>h𝑜𝑢𝑠𝑒</m:t>
+                        </m:r>
+                        <m:r>
+                          <a:rPr lang="en-US" b="0" i="1" smtClean="0">
+                            <a:latin typeface="Cambria Math" panose="02040503050406030204" pitchFamily="18" charset="0"/>
+                          </a:rPr>
+                          <m:t>=</m:t>
+                        </m:r>
+                        <m:r>
+                          <a:rPr lang="en-US" b="0" i="1" smtClean="0">
+                            <a:latin typeface="Cambria Math" panose="02040503050406030204" pitchFamily="18" charset="0"/>
+                          </a:rPr>
+                          <m:t>𝑐𝑎𝑏𝑖𝑛</m:t>
+                        </m:r>
+                      </m:e>
+                    </m:func>
+                  </m:oMath>
+                </a14:m>
+                <a:endParaRPr lang="en-US" dirty="0"/>
+              </a:p>
+              <a:p>
+                <a:pPr marL="514350" indent="-514350">
+                  <a:buFont typeface="+mj-lt"/>
+                  <a:buAutoNum type="alphaLcParenR"/>
+                </a:pPr>
+                <a:r>
+                  <a:rPr lang="en-US" dirty="0"/>
+                  <a:t>I don’t remember anything about log functions</a:t>
+                </a:r>
+              </a:p>
+            </p:txBody>
+          </p:sp>
+        </mc:Choice>
+        <mc:Fallback>
+          <p:sp>
+            <p:nvSpPr>
+              <p:cNvPr id="3" name="Content Placeholder 2">
+                <a:extLst>
+                  <a:ext uri="{FF2B5EF4-FFF2-40B4-BE49-F238E27FC236}">
+                    <a16:creationId xmlns:a16="http://schemas.microsoft.com/office/drawing/2014/main" id="{6F64307E-3582-259B-6FFF-E34800D93684}"/>
+                  </a:ext>
+                </a:extLst>
+              </p:cNvPr>
+              <p:cNvSpPr>
+                <a:spLocks noGrp="1" noRot="1" noChangeAspect="1" noMove="1" noResize="1" noEditPoints="1" noAdjustHandles="1" noChangeArrowheads="1" noChangeShapeType="1" noTextEdit="1"/>
+              </p:cNvSpPr>
+              <p:nvPr>
+                <p:ph idx="1"/>
+              </p:nvPr>
+            </p:nvSpPr>
+            <p:spPr>
+              <a:blipFill>
+                <a:blip r:embed="rId2"/>
+                <a:stretch>
+                  <a:fillRect l="-1217" t="-2381"/>
+                </a:stretch>
+              </a:blipFill>
+            </p:spPr>
+            <p:txBody>
+              <a:bodyPr/>
+              <a:lstStyle/>
+              <a:p>
+                <a:r>
+                  <a:rPr lang="en-US">
+                    <a:noFill/>
+                  </a:rPr>
+                  <a:t> </a:t>
+                </a:r>
+              </a:p>
+            </p:txBody>
+          </p:sp>
+        </mc:Fallback>
+      </mc:AlternateContent>
     </p:spTree>
     <p:extLst>
       <p:ext uri="{BB962C8B-B14F-4D97-AF65-F5344CB8AC3E}">
-        <p14:creationId xmlns:p14="http://schemas.microsoft.com/office/powerpoint/2010/main" val="3786188879"/>
+        <p14:creationId xmlns:p14="http://schemas.microsoft.com/office/powerpoint/2010/main" val="2389341818"/>
       </p:ext>
     </p:extLst>
   </p:cSld>
@@ -4970,18 +6300,18 @@
       </p:grpSpPr>
       <p:sp>
         <p:nvSpPr>
-          <p:cNvPr id="4" name="Title 3">
-            <a:extLst>
-              <a:ext uri="{FF2B5EF4-FFF2-40B4-BE49-F238E27FC236}">
-                <a16:creationId xmlns:a16="http://schemas.microsoft.com/office/drawing/2014/main" id="{278E2971-ABB3-3665-9E07-6648A45C5EA1}"/>
-              </a:ext>
-            </a:extLst>
-          </p:cNvPr>
-          <p:cNvSpPr>
-            <a:spLocks noGrp="1"/>
-          </p:cNvSpPr>
-          <p:nvPr>
-            <p:ph type="ctrTitle"/>
+          <p:cNvPr id="2" name="Title 1">
+            <a:extLst>
+              <a:ext uri="{FF2B5EF4-FFF2-40B4-BE49-F238E27FC236}">
+                <a16:creationId xmlns:a16="http://schemas.microsoft.com/office/drawing/2014/main" id="{7D432002-FF55-F810-0DAE-FAE499C324E4}"/>
+              </a:ext>
+            </a:extLst>
+          </p:cNvPr>
+          <p:cNvSpPr>
+            <a:spLocks noGrp="1"/>
+          </p:cNvSpPr>
+          <p:nvPr>
+            <p:ph type="title"/>
           </p:nvPr>
         </p:nvSpPr>
         <p:spPr/>
@@ -4991,25 +6321,25 @@
           <a:p>
             <a:r>
               <a:rPr lang="en-US" dirty="0"/>
-              <a:t>END</a:t>
-            </a:r>
-          </a:p>
-        </p:txBody>
-      </p:sp>
-      <p:sp>
-        <p:nvSpPr>
-          <p:cNvPr id="5" name="Subtitle 4">
-            <a:extLst>
-              <a:ext uri="{FF2B5EF4-FFF2-40B4-BE49-F238E27FC236}">
-                <a16:creationId xmlns:a16="http://schemas.microsoft.com/office/drawing/2014/main" id="{0D541E2D-86A8-F412-3392-CC7332FB94CE}"/>
-              </a:ext>
-            </a:extLst>
-          </p:cNvPr>
-          <p:cNvSpPr>
-            <a:spLocks noGrp="1"/>
-          </p:cNvSpPr>
-          <p:nvPr>
-            <p:ph type="subTitle" idx="1"/>
+              <a:t>Question</a:t>
+            </a:r>
+          </a:p>
+        </p:txBody>
+      </p:sp>
+      <p:sp>
+        <p:nvSpPr>
+          <p:cNvPr id="3" name="Content Placeholder 2">
+            <a:extLst>
+              <a:ext uri="{FF2B5EF4-FFF2-40B4-BE49-F238E27FC236}">
+                <a16:creationId xmlns:a16="http://schemas.microsoft.com/office/drawing/2014/main" id="{029605CA-880A-29C8-6C74-7E7688FE48C5}"/>
+              </a:ext>
+            </a:extLst>
+          </p:cNvPr>
+          <p:cNvSpPr>
+            <a:spLocks noGrp="1"/>
+          </p:cNvSpPr>
+          <p:nvPr>
+            <p:ph idx="1"/>
           </p:nvPr>
         </p:nvSpPr>
         <p:spPr/>
@@ -5017,14 +6347,169 @@
           <a:bodyPr/>
           <a:lstStyle/>
           <a:p>
-            <a:endParaRPr lang="en-US"/>
+            <a:pPr marL="0" indent="0">
+              <a:buNone/>
+            </a:pPr>
+            <a:r>
+              <a:rPr lang="en-US" dirty="0"/>
+              <a:t>If I add two constants, is the result still constant?</a:t>
+            </a:r>
+          </a:p>
+          <a:p>
+            <a:pPr marL="514350" indent="-514350">
+              <a:buFont typeface="+mj-lt"/>
+              <a:buAutoNum type="alphaLcParenR"/>
+            </a:pPr>
+            <a:r>
+              <a:rPr lang="en-US" dirty="0"/>
+              <a:t>Yes</a:t>
+            </a:r>
+          </a:p>
+          <a:p>
+            <a:pPr marL="514350" indent="-514350">
+              <a:buFont typeface="+mj-lt"/>
+              <a:buAutoNum type="alphaLcParenR"/>
+            </a:pPr>
+            <a:r>
+              <a:rPr lang="en-US" dirty="0"/>
+              <a:t>No</a:t>
+            </a:r>
+          </a:p>
+          <a:p>
+            <a:pPr marL="514350" indent="-514350">
+              <a:buFont typeface="+mj-lt"/>
+              <a:buAutoNum type="alphaLcParenR"/>
+            </a:pPr>
+            <a:r>
+              <a:rPr lang="en-US" dirty="0"/>
+              <a:t>Maybe</a:t>
+            </a:r>
           </a:p>
         </p:txBody>
       </p:sp>
     </p:spTree>
     <p:extLst>
       <p:ext uri="{BB962C8B-B14F-4D97-AF65-F5344CB8AC3E}">
-        <p14:creationId xmlns:p14="http://schemas.microsoft.com/office/powerpoint/2010/main" val="1532625996"/>
+        <p14:creationId xmlns:p14="http://schemas.microsoft.com/office/powerpoint/2010/main" val="2851887090"/>
+      </p:ext>
+    </p:extLst>
+  </p:cSld>
+  <p:clrMapOvr>
+    <a:masterClrMapping/>
+  </p:clrMapOvr>
+</p:sld>
+</file>
+
+<file path=ppt/slides/slide9.xml><?xml version="1.0" encoding="utf-8"?>
+<p:sld xmlns:a="http://schemas.openxmlformats.org/drawingml/2006/main" xmlns:r="http://schemas.openxmlformats.org/officeDocument/2006/relationships" xmlns:p="http://schemas.openxmlformats.org/presentationml/2006/main">
+  <p:cSld>
+    <p:spTree>
+      <p:nvGrpSpPr>
+        <p:cNvPr id="1" name=""/>
+        <p:cNvGrpSpPr/>
+        <p:nvPr/>
+      </p:nvGrpSpPr>
+      <p:grpSpPr>
+        <a:xfrm>
+          <a:off x="0" y="0"/>
+          <a:ext cx="0" cy="0"/>
+          <a:chOff x="0" y="0"/>
+          <a:chExt cx="0" cy="0"/>
+        </a:xfrm>
+      </p:grpSpPr>
+      <p:sp>
+        <p:nvSpPr>
+          <p:cNvPr id="2" name="Title 1">
+            <a:extLst>
+              <a:ext uri="{FF2B5EF4-FFF2-40B4-BE49-F238E27FC236}">
+                <a16:creationId xmlns:a16="http://schemas.microsoft.com/office/drawing/2014/main" id="{36C05A08-BBAD-733F-9214-FFCA080F07AC}"/>
+              </a:ext>
+            </a:extLst>
+          </p:cNvPr>
+          <p:cNvSpPr>
+            <a:spLocks noGrp="1"/>
+          </p:cNvSpPr>
+          <p:nvPr>
+            <p:ph type="title"/>
+          </p:nvPr>
+        </p:nvSpPr>
+        <p:spPr/>
+        <p:txBody>
+          <a:bodyPr/>
+          <a:lstStyle/>
+          <a:p>
+            <a:r>
+              <a:rPr lang="en-US" dirty="0"/>
+              <a:t>Question</a:t>
+            </a:r>
+          </a:p>
+        </p:txBody>
+      </p:sp>
+      <p:sp>
+        <p:nvSpPr>
+          <p:cNvPr id="3" name="Content Placeholder 2">
+            <a:extLst>
+              <a:ext uri="{FF2B5EF4-FFF2-40B4-BE49-F238E27FC236}">
+                <a16:creationId xmlns:a16="http://schemas.microsoft.com/office/drawing/2014/main" id="{857BFD40-4C1B-BCE6-1015-757E5ACBD398}"/>
+              </a:ext>
+            </a:extLst>
+          </p:cNvPr>
+          <p:cNvSpPr>
+            <a:spLocks noGrp="1"/>
+          </p:cNvSpPr>
+          <p:nvPr>
+            <p:ph idx="1"/>
+          </p:nvPr>
+        </p:nvSpPr>
+        <p:spPr/>
+        <p:txBody>
+          <a:bodyPr/>
+          <a:lstStyle/>
+          <a:p>
+            <a:pPr marL="0" indent="0">
+              <a:buNone/>
+            </a:pPr>
+            <a:r>
+              <a:rPr lang="en-US" dirty="0"/>
+              <a:t>Why do we like conservation laws in physics?</a:t>
+            </a:r>
+          </a:p>
+          <a:p>
+            <a:pPr marL="514350" indent="-514350">
+              <a:buFont typeface="+mj-lt"/>
+              <a:buAutoNum type="alphaLcParenR"/>
+            </a:pPr>
+            <a:r>
+              <a:rPr lang="en-US" dirty="0"/>
+              <a:t>They tell us how the universe works</a:t>
+            </a:r>
+          </a:p>
+          <a:p>
+            <a:pPr marL="514350" indent="-514350">
+              <a:buFont typeface="+mj-lt"/>
+              <a:buAutoNum type="alphaLcParenR"/>
+            </a:pPr>
+            <a:r>
+              <a:rPr lang="en-US" dirty="0"/>
+              <a:t>They make everything easy to understand</a:t>
+            </a:r>
+          </a:p>
+          <a:p>
+            <a:pPr marL="514350" indent="-514350">
+              <a:buFont typeface="+mj-lt"/>
+              <a:buAutoNum type="alphaLcParenR"/>
+            </a:pPr>
+            <a:r>
+              <a:rPr lang="en-US" dirty="0"/>
+              <a:t>They make solving problems easier</a:t>
+            </a:r>
+          </a:p>
+        </p:txBody>
+      </p:sp>
+    </p:spTree>
+    <p:extLst>
+      <p:ext uri="{BB962C8B-B14F-4D97-AF65-F5344CB8AC3E}">
+        <p14:creationId xmlns:p14="http://schemas.microsoft.com/office/powerpoint/2010/main" val="3378814276"/>
       </p:ext>
     </p:extLst>
   </p:cSld>

</xml_diff>

<commit_message>
update thorugh chapter 14 or 15
</commit_message>
<xml_diff>
--- a/Lecture_Slides/PH 123 Lecture 36.pptx
+++ b/Lecture_Slides/PH 123 Lecture 36.pptx
@@ -18,7 +18,10 @@
     <p:sldId id="285" r:id="rId12"/>
     <p:sldId id="340" r:id="rId13"/>
     <p:sldId id="283" r:id="rId14"/>
-    <p:sldId id="257" r:id="rId15"/>
+    <p:sldId id="306" r:id="rId15"/>
+    <p:sldId id="307" r:id="rId16"/>
+    <p:sldId id="308" r:id="rId17"/>
+    <p:sldId id="257" r:id="rId18"/>
   </p:sldIdLst>
   <p:sldSz cx="12192000" cy="6858000"/>
   <p:notesSz cx="6858000" cy="9144000"/>
@@ -128,7 +131,7 @@
 <file path=ppt/revisionInfo.xml><?xml version="1.0" encoding="utf-8"?>
 <p1510:revInfo xmlns:a="http://schemas.openxmlformats.org/drawingml/2006/main" xmlns:r="http://schemas.openxmlformats.org/officeDocument/2006/relationships" xmlns:p1510="http://schemas.microsoft.com/office/powerpoint/2015/10/main">
   <p1510:revLst>
-    <p1510:client id="{19433E2F-A7AC-4341-9FA4-5680B2C19CE3}" v="102" dt="2025-07-18T17:55:15.880"/>
+    <p1510:client id="{C3A8F3B3-0951-41A8-9538-BC546DF3340D}" v="1" dt="2026-01-22T22:05:22.813"/>
   </p1510:revLst>
 </p1510:revInfo>
 </file>
@@ -136,184 +139,32 @@
 <file path=ppt/changesInfos/changesInfo1.xml><?xml version="1.0" encoding="utf-8"?>
 <pc:chgInfo xmlns:a="http://schemas.openxmlformats.org/drawingml/2006/main" xmlns:r="http://schemas.openxmlformats.org/officeDocument/2006/relationships" xmlns:ac="http://schemas.microsoft.com/office/drawing/2013/main/command" xmlns:pc="http://schemas.microsoft.com/office/powerpoint/2013/main/command">
   <pc:docChgLst>
-    <pc:chgData name="Lines, Todd" userId="afaf7c3a-e8aa-4568-882a-02ad8f9e19b0" providerId="ADAL" clId="{19433E2F-A7AC-4341-9FA4-5680B2C19CE3}"/>
-    <pc:docChg chg="custSel addSld delSld modSld">
-      <pc:chgData name="Lines, Todd" userId="afaf7c3a-e8aa-4568-882a-02ad8f9e19b0" providerId="ADAL" clId="{19433E2F-A7AC-4341-9FA4-5680B2C19CE3}" dt="2025-07-18T17:55:21.505" v="639" actId="21"/>
+    <pc:chgData name="Lines, Todd" userId="afaf7c3a-e8aa-4568-882a-02ad8f9e19b0" providerId="ADAL" clId="{5FF5AC1B-ABA9-43D7-A1E3-2D92732CD6E2}"/>
+    <pc:docChg chg="addSld modSld">
+      <pc:chgData name="Lines, Todd" userId="afaf7c3a-e8aa-4568-882a-02ad8f9e19b0" providerId="ADAL" clId="{5FF5AC1B-ABA9-43D7-A1E3-2D92732CD6E2}" dt="2026-01-22T22:05:22.797" v="0"/>
       <pc:docMkLst>
         <pc:docMk/>
       </pc:docMkLst>
       <pc:sldChg chg="add">
-        <pc:chgData name="Lines, Todd" userId="afaf7c3a-e8aa-4568-882a-02ad8f9e19b0" providerId="ADAL" clId="{19433E2F-A7AC-4341-9FA4-5680B2C19CE3}" dt="2025-07-03T22:45:43.067" v="5"/>
+        <pc:chgData name="Lines, Todd" userId="afaf7c3a-e8aa-4568-882a-02ad8f9e19b0" providerId="ADAL" clId="{5FF5AC1B-ABA9-43D7-A1E3-2D92732CD6E2}" dt="2026-01-22T22:05:22.797" v="0"/>
         <pc:sldMkLst>
           <pc:docMk/>
-          <pc:sldMk cId="0" sldId="265"/>
+          <pc:sldMk cId="1247448808" sldId="306"/>
         </pc:sldMkLst>
       </pc:sldChg>
-      <pc:sldChg chg="addSp delSp modSp new mod">
-        <pc:chgData name="Lines, Todd" userId="afaf7c3a-e8aa-4568-882a-02ad8f9e19b0" providerId="ADAL" clId="{19433E2F-A7AC-4341-9FA4-5680B2C19CE3}" dt="2025-07-03T22:44:15.552" v="4" actId="14100"/>
+      <pc:sldChg chg="add">
+        <pc:chgData name="Lines, Todd" userId="afaf7c3a-e8aa-4568-882a-02ad8f9e19b0" providerId="ADAL" clId="{5FF5AC1B-ABA9-43D7-A1E3-2D92732CD6E2}" dt="2026-01-22T22:05:22.797" v="0"/>
         <pc:sldMkLst>
           <pc:docMk/>
-          <pc:sldMk cId="3556862412" sldId="341"/>
+          <pc:sldMk cId="4168904192" sldId="307"/>
         </pc:sldMkLst>
-        <pc:picChg chg="add mod">
-          <ac:chgData name="Lines, Todd" userId="afaf7c3a-e8aa-4568-882a-02ad8f9e19b0" providerId="ADAL" clId="{19433E2F-A7AC-4341-9FA4-5680B2C19CE3}" dt="2025-07-03T22:44:15.552" v="4" actId="14100"/>
-          <ac:picMkLst>
-            <pc:docMk/>
-            <pc:sldMk cId="3556862412" sldId="341"/>
-            <ac:picMk id="5" creationId="{FE9C3FC7-9DC0-D72B-55CE-8DD1D7DED647}"/>
-          </ac:picMkLst>
-        </pc:picChg>
       </pc:sldChg>
-      <pc:sldChg chg="modSp add mod">
-        <pc:chgData name="Lines, Todd" userId="afaf7c3a-e8aa-4568-882a-02ad8f9e19b0" providerId="ADAL" clId="{19433E2F-A7AC-4341-9FA4-5680B2C19CE3}" dt="2025-07-08T19:01:50.896" v="8" actId="20577"/>
+      <pc:sldChg chg="add">
+        <pc:chgData name="Lines, Todd" userId="afaf7c3a-e8aa-4568-882a-02ad8f9e19b0" providerId="ADAL" clId="{5FF5AC1B-ABA9-43D7-A1E3-2D92732CD6E2}" dt="2026-01-22T22:05:22.797" v="0"/>
         <pc:sldMkLst>
           <pc:docMk/>
-          <pc:sldMk cId="0" sldId="484"/>
+          <pc:sldMk cId="1325716157" sldId="308"/>
         </pc:sldMkLst>
-        <pc:spChg chg="mod">
-          <ac:chgData name="Lines, Todd" userId="afaf7c3a-e8aa-4568-882a-02ad8f9e19b0" providerId="ADAL" clId="{19433E2F-A7AC-4341-9FA4-5680B2C19CE3}" dt="2025-07-08T19:01:50.896" v="8" actId="20577"/>
-          <ac:spMkLst>
-            <pc:docMk/>
-            <pc:sldMk cId="0" sldId="484"/>
-            <ac:spMk id="35843" creationId="{25E6F564-0ACC-BFA0-5D1C-098F0645008F}"/>
-          </ac:spMkLst>
-        </pc:spChg>
-      </pc:sldChg>
-      <pc:sldChg chg="modSp add mod">
-        <pc:chgData name="Lines, Todd" userId="afaf7c3a-e8aa-4568-882a-02ad8f9e19b0" providerId="ADAL" clId="{19433E2F-A7AC-4341-9FA4-5680B2C19CE3}" dt="2025-07-10T19:08:35.353" v="84"/>
-        <pc:sldMkLst>
-          <pc:docMk/>
-          <pc:sldMk cId="3842804923" sldId="485"/>
-        </pc:sldMkLst>
-        <pc:spChg chg="mod">
-          <ac:chgData name="Lines, Todd" userId="afaf7c3a-e8aa-4568-882a-02ad8f9e19b0" providerId="ADAL" clId="{19433E2F-A7AC-4341-9FA4-5680B2C19CE3}" dt="2025-07-10T19:08:35.353" v="84"/>
-          <ac:spMkLst>
-            <pc:docMk/>
-            <pc:sldMk cId="3842804923" sldId="485"/>
-            <ac:spMk id="35843" creationId="{0880A836-F3E8-694F-BE88-C7B0C83B8377}"/>
-          </ac:spMkLst>
-        </pc:spChg>
-      </pc:sldChg>
-      <pc:sldChg chg="addSp delSp modSp add mod">
-        <pc:chgData name="Lines, Todd" userId="afaf7c3a-e8aa-4568-882a-02ad8f9e19b0" providerId="ADAL" clId="{19433E2F-A7AC-4341-9FA4-5680B2C19CE3}" dt="2025-07-18T17:55:21.505" v="639" actId="21"/>
-        <pc:sldMkLst>
-          <pc:docMk/>
-          <pc:sldMk cId="3465067879" sldId="486"/>
-        </pc:sldMkLst>
-        <pc:picChg chg="del mod">
-          <ac:chgData name="Lines, Todd" userId="afaf7c3a-e8aa-4568-882a-02ad8f9e19b0" providerId="ADAL" clId="{19433E2F-A7AC-4341-9FA4-5680B2C19CE3}" dt="2025-07-18T17:55:21.505" v="639" actId="21"/>
-          <ac:picMkLst>
-            <pc:docMk/>
-            <pc:sldMk cId="3465067879" sldId="486"/>
-            <ac:picMk id="8" creationId="{80070FD3-532A-DBD5-B87B-3D7F14D37321}"/>
-          </ac:picMkLst>
-        </pc:picChg>
-        <pc:cxnChg chg="add mod">
-          <ac:chgData name="Lines, Todd" userId="afaf7c3a-e8aa-4568-882a-02ad8f9e19b0" providerId="ADAL" clId="{19433E2F-A7AC-4341-9FA4-5680B2C19CE3}" dt="2025-07-18T17:55:05.699" v="637" actId="14100"/>
-          <ac:cxnSpMkLst>
-            <pc:docMk/>
-            <pc:sldMk cId="3465067879" sldId="486"/>
-            <ac:cxnSpMk id="3" creationId="{AFC79ABE-F59B-9F93-9EFF-8D33E3DC38ED}"/>
-          </ac:cxnSpMkLst>
-        </pc:cxnChg>
-      </pc:sldChg>
-      <pc:sldChg chg="modSp new mod">
-        <pc:chgData name="Lines, Todd" userId="afaf7c3a-e8aa-4568-882a-02ad8f9e19b0" providerId="ADAL" clId="{19433E2F-A7AC-4341-9FA4-5680B2C19CE3}" dt="2025-07-11T15:55:05.868" v="219" actId="20577"/>
-        <pc:sldMkLst>
-          <pc:docMk/>
-          <pc:sldMk cId="1446333334" sldId="487"/>
-        </pc:sldMkLst>
-        <pc:spChg chg="mod">
-          <ac:chgData name="Lines, Todd" userId="afaf7c3a-e8aa-4568-882a-02ad8f9e19b0" providerId="ADAL" clId="{19433E2F-A7AC-4341-9FA4-5680B2C19CE3}" dt="2025-07-11T15:52:13.279" v="94" actId="20577"/>
-          <ac:spMkLst>
-            <pc:docMk/>
-            <pc:sldMk cId="1446333334" sldId="487"/>
-            <ac:spMk id="2" creationId="{54610E40-E486-E84C-682C-6002987BB624}"/>
-          </ac:spMkLst>
-        </pc:spChg>
-        <pc:spChg chg="mod">
-          <ac:chgData name="Lines, Todd" userId="afaf7c3a-e8aa-4568-882a-02ad8f9e19b0" providerId="ADAL" clId="{19433E2F-A7AC-4341-9FA4-5680B2C19CE3}" dt="2025-07-11T15:55:05.868" v="219" actId="20577"/>
-          <ac:spMkLst>
-            <pc:docMk/>
-            <pc:sldMk cId="1446333334" sldId="487"/>
-            <ac:spMk id="3" creationId="{08537D8D-6AC6-1433-021B-54F0CF486FA0}"/>
-          </ac:spMkLst>
-        </pc:spChg>
-      </pc:sldChg>
-      <pc:sldChg chg="modSp add mod">
-        <pc:chgData name="Lines, Todd" userId="afaf7c3a-e8aa-4568-882a-02ad8f9e19b0" providerId="ADAL" clId="{19433E2F-A7AC-4341-9FA4-5680B2C19CE3}" dt="2025-07-11T15:59:20.973" v="355" actId="20577"/>
-        <pc:sldMkLst>
-          <pc:docMk/>
-          <pc:sldMk cId="2389341818" sldId="488"/>
-        </pc:sldMkLst>
-        <pc:spChg chg="mod">
-          <ac:chgData name="Lines, Todd" userId="afaf7c3a-e8aa-4568-882a-02ad8f9e19b0" providerId="ADAL" clId="{19433E2F-A7AC-4341-9FA4-5680B2C19CE3}" dt="2025-07-11T15:59:20.973" v="355" actId="20577"/>
-          <ac:spMkLst>
-            <pc:docMk/>
-            <pc:sldMk cId="2389341818" sldId="488"/>
-            <ac:spMk id="3" creationId="{6F64307E-3582-259B-6FFF-E34800D93684}"/>
-          </ac:spMkLst>
-        </pc:spChg>
-      </pc:sldChg>
-      <pc:sldChg chg="add del">
-        <pc:chgData name="Lines, Todd" userId="afaf7c3a-e8aa-4568-882a-02ad8f9e19b0" providerId="ADAL" clId="{19433E2F-A7AC-4341-9FA4-5680B2C19CE3}" dt="2025-07-11T15:55:56.334" v="221" actId="47"/>
-        <pc:sldMkLst>
-          <pc:docMk/>
-          <pc:sldMk cId="3237716521" sldId="488"/>
-        </pc:sldMkLst>
-      </pc:sldChg>
-      <pc:sldChg chg="add del">
-        <pc:chgData name="Lines, Todd" userId="afaf7c3a-e8aa-4568-882a-02ad8f9e19b0" providerId="ADAL" clId="{19433E2F-A7AC-4341-9FA4-5680B2C19CE3}" dt="2025-07-11T15:57:59.888" v="269"/>
-        <pc:sldMkLst>
-          <pc:docMk/>
-          <pc:sldMk cId="1831025676" sldId="489"/>
-        </pc:sldMkLst>
-      </pc:sldChg>
-      <pc:sldChg chg="modSp new mod">
-        <pc:chgData name="Lines, Todd" userId="afaf7c3a-e8aa-4568-882a-02ad8f9e19b0" providerId="ADAL" clId="{19433E2F-A7AC-4341-9FA4-5680B2C19CE3}" dt="2025-07-11T16:00:13.225" v="435" actId="20577"/>
-        <pc:sldMkLst>
-          <pc:docMk/>
-          <pc:sldMk cId="2851887090" sldId="489"/>
-        </pc:sldMkLst>
-        <pc:spChg chg="mod">
-          <ac:chgData name="Lines, Todd" userId="afaf7c3a-e8aa-4568-882a-02ad8f9e19b0" providerId="ADAL" clId="{19433E2F-A7AC-4341-9FA4-5680B2C19CE3}" dt="2025-07-11T15:59:42.281" v="364" actId="20577"/>
-          <ac:spMkLst>
-            <pc:docMk/>
-            <pc:sldMk cId="2851887090" sldId="489"/>
-            <ac:spMk id="2" creationId="{7D432002-FF55-F810-0DAE-FAE499C324E4}"/>
-          </ac:spMkLst>
-        </pc:spChg>
-        <pc:spChg chg="mod">
-          <ac:chgData name="Lines, Todd" userId="afaf7c3a-e8aa-4568-882a-02ad8f9e19b0" providerId="ADAL" clId="{19433E2F-A7AC-4341-9FA4-5680B2C19CE3}" dt="2025-07-11T16:00:13.225" v="435" actId="20577"/>
-          <ac:spMkLst>
-            <pc:docMk/>
-            <pc:sldMk cId="2851887090" sldId="489"/>
-            <ac:spMk id="3" creationId="{029605CA-880A-29C8-6C74-7E7688FE48C5}"/>
-          </ac:spMkLst>
-        </pc:spChg>
-      </pc:sldChg>
-      <pc:sldChg chg="modSp new mod">
-        <pc:chgData name="Lines, Todd" userId="afaf7c3a-e8aa-4568-882a-02ad8f9e19b0" providerId="ADAL" clId="{19433E2F-A7AC-4341-9FA4-5680B2C19CE3}" dt="2025-07-11T16:01:48.824" v="624" actId="20577"/>
-        <pc:sldMkLst>
-          <pc:docMk/>
-          <pc:sldMk cId="3378814276" sldId="490"/>
-        </pc:sldMkLst>
-        <pc:spChg chg="mod">
-          <ac:chgData name="Lines, Todd" userId="afaf7c3a-e8aa-4568-882a-02ad8f9e19b0" providerId="ADAL" clId="{19433E2F-A7AC-4341-9FA4-5680B2C19CE3}" dt="2025-07-11T16:00:45.529" v="444" actId="20577"/>
-          <ac:spMkLst>
-            <pc:docMk/>
-            <pc:sldMk cId="3378814276" sldId="490"/>
-            <ac:spMk id="2" creationId="{36C05A08-BBAD-733F-9214-FFCA080F07AC}"/>
-          </ac:spMkLst>
-        </pc:spChg>
-        <pc:spChg chg="mod">
-          <ac:chgData name="Lines, Todd" userId="afaf7c3a-e8aa-4568-882a-02ad8f9e19b0" providerId="ADAL" clId="{19433E2F-A7AC-4341-9FA4-5680B2C19CE3}" dt="2025-07-11T16:01:48.824" v="624" actId="20577"/>
-          <ac:spMkLst>
-            <pc:docMk/>
-            <pc:sldMk cId="3378814276" sldId="490"/>
-            <ac:spMk id="3" creationId="{857BFD40-4C1B-BCE6-1015-757E5ACBD398}"/>
-          </ac:spMkLst>
-        </pc:spChg>
       </pc:sldChg>
     </pc:docChg>
   </pc:docChgLst>
@@ -467,7 +318,7 @@
           <a:p>
             <a:fld id="{5D14FE54-3E4B-43AC-AC6A-78E009FC7A62}" type="datetimeFigureOut">
               <a:rPr lang="en-US" smtClean="0"/>
-              <a:t>7/18/2025</a:t>
+              <a:t>1/22/2026</a:t>
             </a:fld>
             <a:endParaRPr lang="en-US"/>
           </a:p>
@@ -665,7 +516,7 @@
           <a:p>
             <a:fld id="{5D14FE54-3E4B-43AC-AC6A-78E009FC7A62}" type="datetimeFigureOut">
               <a:rPr lang="en-US" smtClean="0"/>
-              <a:t>7/18/2025</a:t>
+              <a:t>1/22/2026</a:t>
             </a:fld>
             <a:endParaRPr lang="en-US"/>
           </a:p>
@@ -873,7 +724,7 @@
           <a:p>
             <a:fld id="{5D14FE54-3E4B-43AC-AC6A-78E009FC7A62}" type="datetimeFigureOut">
               <a:rPr lang="en-US" smtClean="0"/>
-              <a:t>7/18/2025</a:t>
+              <a:t>1/22/2026</a:t>
             </a:fld>
             <a:endParaRPr lang="en-US"/>
           </a:p>
@@ -1071,7 +922,7 @@
           <a:p>
             <a:fld id="{5D14FE54-3E4B-43AC-AC6A-78E009FC7A62}" type="datetimeFigureOut">
               <a:rPr lang="en-US" smtClean="0"/>
-              <a:t>7/18/2025</a:t>
+              <a:t>1/22/2026</a:t>
             </a:fld>
             <a:endParaRPr lang="en-US"/>
           </a:p>
@@ -1346,7 +1197,7 @@
           <a:p>
             <a:fld id="{5D14FE54-3E4B-43AC-AC6A-78E009FC7A62}" type="datetimeFigureOut">
               <a:rPr lang="en-US" smtClean="0"/>
-              <a:t>7/18/2025</a:t>
+              <a:t>1/22/2026</a:t>
             </a:fld>
             <a:endParaRPr lang="en-US"/>
           </a:p>
@@ -1611,7 +1462,7 @@
           <a:p>
             <a:fld id="{5D14FE54-3E4B-43AC-AC6A-78E009FC7A62}" type="datetimeFigureOut">
               <a:rPr lang="en-US" smtClean="0"/>
-              <a:t>7/18/2025</a:t>
+              <a:t>1/22/2026</a:t>
             </a:fld>
             <a:endParaRPr lang="en-US"/>
           </a:p>
@@ -2023,7 +1874,7 @@
           <a:p>
             <a:fld id="{5D14FE54-3E4B-43AC-AC6A-78E009FC7A62}" type="datetimeFigureOut">
               <a:rPr lang="en-US" smtClean="0"/>
-              <a:t>7/18/2025</a:t>
+              <a:t>1/22/2026</a:t>
             </a:fld>
             <a:endParaRPr lang="en-US"/>
           </a:p>
@@ -2164,7 +2015,7 @@
           <a:p>
             <a:fld id="{5D14FE54-3E4B-43AC-AC6A-78E009FC7A62}" type="datetimeFigureOut">
               <a:rPr lang="en-US" smtClean="0"/>
-              <a:t>7/18/2025</a:t>
+              <a:t>1/22/2026</a:t>
             </a:fld>
             <a:endParaRPr lang="en-US"/>
           </a:p>
@@ -2277,7 +2128,7 @@
           <a:p>
             <a:fld id="{5D14FE54-3E4B-43AC-AC6A-78E009FC7A62}" type="datetimeFigureOut">
               <a:rPr lang="en-US" smtClean="0"/>
-              <a:t>7/18/2025</a:t>
+              <a:t>1/22/2026</a:t>
             </a:fld>
             <a:endParaRPr lang="en-US"/>
           </a:p>
@@ -2588,7 +2439,7 @@
           <a:p>
             <a:fld id="{5D14FE54-3E4B-43AC-AC6A-78E009FC7A62}" type="datetimeFigureOut">
               <a:rPr lang="en-US" smtClean="0"/>
-              <a:t>7/18/2025</a:t>
+              <a:t>1/22/2026</a:t>
             </a:fld>
             <a:endParaRPr lang="en-US"/>
           </a:p>
@@ -2876,7 +2727,7 @@
           <a:p>
             <a:fld id="{5D14FE54-3E4B-43AC-AC6A-78E009FC7A62}" type="datetimeFigureOut">
               <a:rPr lang="en-US" smtClean="0"/>
-              <a:t>7/18/2025</a:t>
+              <a:t>1/22/2026</a:t>
             </a:fld>
             <a:endParaRPr lang="en-US"/>
           </a:p>
@@ -3117,7 +2968,7 @@
           <a:p>
             <a:fld id="{5D14FE54-3E4B-43AC-AC6A-78E009FC7A62}" type="datetimeFigureOut">
               <a:rPr lang="en-US" smtClean="0"/>
-              <a:t>7/18/2025</a:t>
+              <a:t>1/22/2026</a:t>
             </a:fld>
             <a:endParaRPr lang="en-US"/>
           </a:p>
@@ -4726,6 +4577,2446 @@
 </file>
 
 <file path=ppt/slides/slide14.xml><?xml version="1.0" encoding="utf-8"?>
+<p:sld xmlns:a="http://schemas.openxmlformats.org/drawingml/2006/main" xmlns:r="http://schemas.openxmlformats.org/officeDocument/2006/relationships" xmlns:p="http://schemas.openxmlformats.org/presentationml/2006/main">
+  <p:cSld>
+    <p:spTree>
+      <p:nvGrpSpPr>
+        <p:cNvPr id="1" name=""/>
+        <p:cNvGrpSpPr/>
+        <p:nvPr/>
+      </p:nvGrpSpPr>
+      <p:grpSpPr>
+        <a:xfrm>
+          <a:off x="0" y="0"/>
+          <a:ext cx="0" cy="0"/>
+          <a:chOff x="0" y="0"/>
+          <a:chExt cx="0" cy="0"/>
+        </a:xfrm>
+      </p:grpSpPr>
+      <p:sp>
+        <p:nvSpPr>
+          <p:cNvPr id="4" name="Cylinder 3">
+            <a:extLst>
+              <a:ext uri="{FF2B5EF4-FFF2-40B4-BE49-F238E27FC236}">
+                <a16:creationId xmlns:a16="http://schemas.microsoft.com/office/drawing/2014/main" id="{C7CEA9B5-10E1-0690-20A5-E941D70EF6CE}"/>
+              </a:ext>
+            </a:extLst>
+          </p:cNvPr>
+          <p:cNvSpPr/>
+          <p:nvPr/>
+        </p:nvSpPr>
+        <p:spPr>
+          <a:xfrm rot="16200000">
+            <a:off x="5327904" y="329184"/>
+            <a:ext cx="932688" cy="4681728"/>
+          </a:xfrm>
+          <a:prstGeom prst="can">
+            <a:avLst>
+              <a:gd name="adj" fmla="val 52451"/>
+            </a:avLst>
+          </a:prstGeom>
+          <a:solidFill>
+            <a:schemeClr val="tx2">
+              <a:lumMod val="20000"/>
+              <a:lumOff val="80000"/>
+            </a:schemeClr>
+          </a:solidFill>
+        </p:spPr>
+        <p:style>
+          <a:lnRef idx="2">
+            <a:schemeClr val="accent1">
+              <a:shade val="15000"/>
+            </a:schemeClr>
+          </a:lnRef>
+          <a:fillRef idx="1">
+            <a:schemeClr val="accent1"/>
+          </a:fillRef>
+          <a:effectRef idx="0">
+            <a:schemeClr val="accent1"/>
+          </a:effectRef>
+          <a:fontRef idx="minor">
+            <a:schemeClr val="lt1"/>
+          </a:fontRef>
+        </p:style>
+        <p:txBody>
+          <a:bodyPr rtlCol="0" anchor="ctr"/>
+          <a:lstStyle/>
+          <a:p>
+            <a:pPr algn="ctr"/>
+            <a:endParaRPr lang="en-US"/>
+          </a:p>
+        </p:txBody>
+      </p:sp>
+      <p:sp>
+        <p:nvSpPr>
+          <p:cNvPr id="5" name="Cylinder 4">
+            <a:extLst>
+              <a:ext uri="{FF2B5EF4-FFF2-40B4-BE49-F238E27FC236}">
+                <a16:creationId xmlns:a16="http://schemas.microsoft.com/office/drawing/2014/main" id="{0117D1E6-05E3-328B-3F36-AFC8B477D456}"/>
+              </a:ext>
+            </a:extLst>
+          </p:cNvPr>
+          <p:cNvSpPr/>
+          <p:nvPr/>
+        </p:nvSpPr>
+        <p:spPr>
+          <a:xfrm rot="16200000">
+            <a:off x="5353812" y="1754125"/>
+            <a:ext cx="932688" cy="1831848"/>
+          </a:xfrm>
+          <a:prstGeom prst="can">
+            <a:avLst>
+              <a:gd name="adj" fmla="val 52451"/>
+            </a:avLst>
+          </a:prstGeom>
+          <a:solidFill>
+            <a:schemeClr val="tx2">
+              <a:lumMod val="60000"/>
+              <a:lumOff val="40000"/>
+            </a:schemeClr>
+          </a:solidFill>
+        </p:spPr>
+        <p:style>
+          <a:lnRef idx="2">
+            <a:schemeClr val="accent1">
+              <a:shade val="15000"/>
+            </a:schemeClr>
+          </a:lnRef>
+          <a:fillRef idx="1">
+            <a:schemeClr val="accent1"/>
+          </a:fillRef>
+          <a:effectRef idx="0">
+            <a:schemeClr val="accent1"/>
+          </a:effectRef>
+          <a:fontRef idx="minor">
+            <a:schemeClr val="lt1"/>
+          </a:fontRef>
+        </p:style>
+        <p:txBody>
+          <a:bodyPr rtlCol="0" anchor="ctr"/>
+          <a:lstStyle/>
+          <a:p>
+            <a:pPr algn="ctr"/>
+            <a:endParaRPr lang="en-US"/>
+          </a:p>
+        </p:txBody>
+      </p:sp>
+      <p:sp>
+        <p:nvSpPr>
+          <p:cNvPr id="6" name="TextBox 5">
+            <a:extLst>
+              <a:ext uri="{FF2B5EF4-FFF2-40B4-BE49-F238E27FC236}">
+                <a16:creationId xmlns:a16="http://schemas.microsoft.com/office/drawing/2014/main" id="{82B82AD0-A576-E02B-3403-FC95165C25E7}"/>
+              </a:ext>
+            </a:extLst>
+          </p:cNvPr>
+          <p:cNvSpPr txBox="1"/>
+          <p:nvPr/>
+        </p:nvSpPr>
+        <p:spPr>
+          <a:xfrm>
+            <a:off x="4992262" y="2485382"/>
+            <a:ext cx="320922" cy="369332"/>
+          </a:xfrm>
+          <a:prstGeom prst="rect">
+            <a:avLst/>
+          </a:prstGeom>
+          <a:noFill/>
+        </p:spPr>
+        <p:txBody>
+          <a:bodyPr wrap="none" rtlCol="0">
+            <a:spAutoFit/>
+          </a:bodyPr>
+          <a:lstStyle/>
+          <a:p>
+            <a:r>
+              <a:rPr lang="en-US" dirty="0"/>
+              <a:t>A</a:t>
+            </a:r>
+          </a:p>
+        </p:txBody>
+      </p:sp>
+      <p:cxnSp>
+        <p:nvCxnSpPr>
+          <p:cNvPr id="8" name="Straight Connector 7">
+            <a:extLst>
+              <a:ext uri="{FF2B5EF4-FFF2-40B4-BE49-F238E27FC236}">
+                <a16:creationId xmlns:a16="http://schemas.microsoft.com/office/drawing/2014/main" id="{0ACF803B-B61B-F4CF-3CBB-0086E5811D65}"/>
+              </a:ext>
+            </a:extLst>
+          </p:cNvPr>
+          <p:cNvCxnSpPr/>
+          <p:nvPr/>
+        </p:nvCxnSpPr>
+        <p:spPr>
+          <a:xfrm flipV="1">
+            <a:off x="5151120" y="1618488"/>
+            <a:ext cx="0" cy="521208"/>
+          </a:xfrm>
+          <a:prstGeom prst="line">
+            <a:avLst/>
+          </a:prstGeom>
+          <a:ln>
+            <a:solidFill>
+              <a:schemeClr val="tx1"/>
+            </a:solidFill>
+            <a:prstDash val="dash"/>
+          </a:ln>
+        </p:spPr>
+        <p:style>
+          <a:lnRef idx="1">
+            <a:schemeClr val="accent1"/>
+          </a:lnRef>
+          <a:fillRef idx="0">
+            <a:schemeClr val="accent1"/>
+          </a:fillRef>
+          <a:effectRef idx="0">
+            <a:schemeClr val="accent1"/>
+          </a:effectRef>
+          <a:fontRef idx="minor">
+            <a:schemeClr val="tx1"/>
+          </a:fontRef>
+        </p:style>
+      </p:cxnSp>
+      <p:cxnSp>
+        <p:nvCxnSpPr>
+          <p:cNvPr id="9" name="Straight Connector 8">
+            <a:extLst>
+              <a:ext uri="{FF2B5EF4-FFF2-40B4-BE49-F238E27FC236}">
+                <a16:creationId xmlns:a16="http://schemas.microsoft.com/office/drawing/2014/main" id="{603595B2-A95D-A8D4-51D7-931603F86545}"/>
+              </a:ext>
+            </a:extLst>
+          </p:cNvPr>
+          <p:cNvCxnSpPr/>
+          <p:nvPr/>
+        </p:nvCxnSpPr>
+        <p:spPr>
+          <a:xfrm flipV="1">
+            <a:off x="6556248" y="1618488"/>
+            <a:ext cx="0" cy="521208"/>
+          </a:xfrm>
+          <a:prstGeom prst="line">
+            <a:avLst/>
+          </a:prstGeom>
+          <a:ln>
+            <a:solidFill>
+              <a:schemeClr val="tx1"/>
+            </a:solidFill>
+            <a:prstDash val="dash"/>
+          </a:ln>
+        </p:spPr>
+        <p:style>
+          <a:lnRef idx="1">
+            <a:schemeClr val="accent1"/>
+          </a:lnRef>
+          <a:fillRef idx="0">
+            <a:schemeClr val="accent1"/>
+          </a:fillRef>
+          <a:effectRef idx="0">
+            <a:schemeClr val="accent1"/>
+          </a:effectRef>
+          <a:fontRef idx="minor">
+            <a:schemeClr val="tx1"/>
+          </a:fontRef>
+        </p:style>
+      </p:cxnSp>
+      <p:cxnSp>
+        <p:nvCxnSpPr>
+          <p:cNvPr id="11" name="Straight Arrow Connector 10">
+            <a:extLst>
+              <a:ext uri="{FF2B5EF4-FFF2-40B4-BE49-F238E27FC236}">
+                <a16:creationId xmlns:a16="http://schemas.microsoft.com/office/drawing/2014/main" id="{D1A9A135-2042-0657-03DA-4F1D50813C6D}"/>
+              </a:ext>
+            </a:extLst>
+          </p:cNvPr>
+          <p:cNvCxnSpPr/>
+          <p:nvPr/>
+        </p:nvCxnSpPr>
+        <p:spPr>
+          <a:xfrm>
+            <a:off x="5151120" y="1879092"/>
+            <a:ext cx="1392936" cy="0"/>
+          </a:xfrm>
+          <a:prstGeom prst="straightConnector1">
+            <a:avLst/>
+          </a:prstGeom>
+          <a:ln>
+            <a:solidFill>
+              <a:schemeClr val="tx1"/>
+            </a:solidFill>
+            <a:prstDash val="dash"/>
+            <a:headEnd type="triangle"/>
+            <a:tailEnd type="triangle"/>
+          </a:ln>
+        </p:spPr>
+        <p:style>
+          <a:lnRef idx="1">
+            <a:schemeClr val="accent1"/>
+          </a:lnRef>
+          <a:fillRef idx="0">
+            <a:schemeClr val="accent1"/>
+          </a:fillRef>
+          <a:effectRef idx="0">
+            <a:schemeClr val="accent1"/>
+          </a:effectRef>
+          <a:fontRef idx="minor">
+            <a:schemeClr val="tx1"/>
+          </a:fontRef>
+        </p:style>
+      </p:cxnSp>
+      <p:sp>
+        <p:nvSpPr>
+          <p:cNvPr id="12" name="TextBox 11">
+            <a:extLst>
+              <a:ext uri="{FF2B5EF4-FFF2-40B4-BE49-F238E27FC236}">
+                <a16:creationId xmlns:a16="http://schemas.microsoft.com/office/drawing/2014/main" id="{13C3B7EB-4075-93A1-F1D5-130146D4AB9C}"/>
+              </a:ext>
+            </a:extLst>
+          </p:cNvPr>
+          <p:cNvSpPr txBox="1"/>
+          <p:nvPr/>
+        </p:nvSpPr>
+        <p:spPr>
+          <a:xfrm>
+            <a:off x="5738796" y="1694426"/>
+            <a:ext cx="425116" cy="369332"/>
+          </a:xfrm>
+          <a:prstGeom prst="rect">
+            <a:avLst/>
+          </a:prstGeom>
+          <a:solidFill>
+            <a:schemeClr val="bg1"/>
+          </a:solidFill>
+        </p:spPr>
+        <p:txBody>
+          <a:bodyPr wrap="none" rtlCol="0">
+            <a:spAutoFit/>
+          </a:bodyPr>
+          <a:lstStyle/>
+          <a:p>
+            <a:r>
+              <a:rPr lang="en-US" dirty="0">
+                <a:sym typeface="Symbol" panose="05050102010706020507" pitchFamily="18" charset="2"/>
+              </a:rPr>
+              <a:t></a:t>
+            </a:r>
+            <a:r>
+              <a:rPr lang="en-US" dirty="0"/>
+              <a:t>x</a:t>
+            </a:r>
+          </a:p>
+        </p:txBody>
+      </p:sp>
+      <p:sp>
+        <p:nvSpPr>
+          <p:cNvPr id="13" name="Oval 12">
+            <a:extLst>
+              <a:ext uri="{FF2B5EF4-FFF2-40B4-BE49-F238E27FC236}">
+                <a16:creationId xmlns:a16="http://schemas.microsoft.com/office/drawing/2014/main" id="{F8877B15-2AAF-441A-8BB6-E91D4626B716}"/>
+              </a:ext>
+            </a:extLst>
+          </p:cNvPr>
+          <p:cNvSpPr/>
+          <p:nvPr/>
+        </p:nvSpPr>
+        <p:spPr>
+          <a:xfrm>
+            <a:off x="6251089" y="2203703"/>
+            <a:ext cx="487680" cy="932689"/>
+          </a:xfrm>
+          <a:prstGeom prst="ellipse">
+            <a:avLst/>
+          </a:prstGeom>
+          <a:solidFill>
+            <a:schemeClr val="tx2">
+              <a:lumMod val="60000"/>
+              <a:lumOff val="40000"/>
+            </a:schemeClr>
+          </a:solidFill>
+          <a:ln w="9525">
+            <a:solidFill>
+              <a:schemeClr val="tx1">
+                <a:lumMod val="95000"/>
+                <a:lumOff val="5000"/>
+              </a:schemeClr>
+            </a:solidFill>
+            <a:prstDash val="dash"/>
+          </a:ln>
+        </p:spPr>
+        <p:style>
+          <a:lnRef idx="2">
+            <a:schemeClr val="accent1">
+              <a:shade val="15000"/>
+            </a:schemeClr>
+          </a:lnRef>
+          <a:fillRef idx="1">
+            <a:schemeClr val="accent1"/>
+          </a:fillRef>
+          <a:effectRef idx="0">
+            <a:schemeClr val="accent1"/>
+          </a:effectRef>
+          <a:fontRef idx="minor">
+            <a:schemeClr val="lt1"/>
+          </a:fontRef>
+        </p:style>
+        <p:txBody>
+          <a:bodyPr rtlCol="0" anchor="ctr"/>
+          <a:lstStyle/>
+          <a:p>
+            <a:pPr algn="ctr"/>
+            <a:endParaRPr lang="en-US"/>
+          </a:p>
+        </p:txBody>
+      </p:sp>
+      <p:sp>
+        <p:nvSpPr>
+          <p:cNvPr id="14" name="Arc 13">
+            <a:extLst>
+              <a:ext uri="{FF2B5EF4-FFF2-40B4-BE49-F238E27FC236}">
+                <a16:creationId xmlns:a16="http://schemas.microsoft.com/office/drawing/2014/main" id="{C8CB2D2C-A259-ACC4-DFDD-B2C86AA527A1}"/>
+              </a:ext>
+            </a:extLst>
+          </p:cNvPr>
+          <p:cNvSpPr/>
+          <p:nvPr/>
+        </p:nvSpPr>
+        <p:spPr>
+          <a:xfrm>
+            <a:off x="6248040" y="2203704"/>
+            <a:ext cx="487680" cy="932689"/>
+          </a:xfrm>
+          <a:prstGeom prst="arc">
+            <a:avLst>
+              <a:gd name="adj1" fmla="val 16200000"/>
+              <a:gd name="adj2" fmla="val 5236651"/>
+            </a:avLst>
+          </a:prstGeom>
+          <a:ln w="28575">
+            <a:solidFill>
+              <a:schemeClr val="tx1"/>
+            </a:solidFill>
+          </a:ln>
+        </p:spPr>
+        <p:style>
+          <a:lnRef idx="1">
+            <a:schemeClr val="accent1"/>
+          </a:lnRef>
+          <a:fillRef idx="0">
+            <a:schemeClr val="accent1"/>
+          </a:fillRef>
+          <a:effectRef idx="0">
+            <a:schemeClr val="accent1"/>
+          </a:effectRef>
+          <a:fontRef idx="minor">
+            <a:schemeClr val="tx1"/>
+          </a:fontRef>
+        </p:style>
+        <p:txBody>
+          <a:bodyPr rtlCol="0" anchor="ctr"/>
+          <a:lstStyle/>
+          <a:p>
+            <a:pPr algn="ctr"/>
+            <a:endParaRPr lang="en-US"/>
+          </a:p>
+        </p:txBody>
+      </p:sp>
+      <p:sp>
+        <p:nvSpPr>
+          <p:cNvPr id="15" name="Oval 14">
+            <a:extLst>
+              <a:ext uri="{FF2B5EF4-FFF2-40B4-BE49-F238E27FC236}">
+                <a16:creationId xmlns:a16="http://schemas.microsoft.com/office/drawing/2014/main" id="{7FA60F47-8906-0C8E-78DA-8CF2FFEB52BC}"/>
+              </a:ext>
+            </a:extLst>
+          </p:cNvPr>
+          <p:cNvSpPr/>
+          <p:nvPr/>
+        </p:nvSpPr>
+        <p:spPr>
+          <a:xfrm>
+            <a:off x="7647432" y="2203703"/>
+            <a:ext cx="487680" cy="932689"/>
+          </a:xfrm>
+          <a:prstGeom prst="ellipse">
+            <a:avLst/>
+          </a:prstGeom>
+          <a:solidFill>
+            <a:schemeClr val="tx2">
+              <a:lumMod val="20000"/>
+              <a:lumOff val="80000"/>
+            </a:schemeClr>
+          </a:solidFill>
+          <a:ln w="9525">
+            <a:solidFill>
+              <a:schemeClr val="tx1">
+                <a:lumMod val="95000"/>
+                <a:lumOff val="5000"/>
+              </a:schemeClr>
+            </a:solidFill>
+            <a:prstDash val="dash"/>
+          </a:ln>
+        </p:spPr>
+        <p:style>
+          <a:lnRef idx="2">
+            <a:schemeClr val="accent1">
+              <a:shade val="15000"/>
+            </a:schemeClr>
+          </a:lnRef>
+          <a:fillRef idx="1">
+            <a:schemeClr val="accent1"/>
+          </a:fillRef>
+          <a:effectRef idx="0">
+            <a:schemeClr val="accent1"/>
+          </a:effectRef>
+          <a:fontRef idx="minor">
+            <a:schemeClr val="lt1"/>
+          </a:fontRef>
+        </p:style>
+        <p:txBody>
+          <a:bodyPr rtlCol="0" anchor="ctr"/>
+          <a:lstStyle/>
+          <a:p>
+            <a:pPr algn="ctr"/>
+            <a:endParaRPr lang="en-US"/>
+          </a:p>
+        </p:txBody>
+      </p:sp>
+      <p:cxnSp>
+        <p:nvCxnSpPr>
+          <p:cNvPr id="17" name="Straight Arrow Connector 16">
+            <a:extLst>
+              <a:ext uri="{FF2B5EF4-FFF2-40B4-BE49-F238E27FC236}">
+                <a16:creationId xmlns:a16="http://schemas.microsoft.com/office/drawing/2014/main" id="{9D2453E8-F171-5CE9-7C13-324E3A854047}"/>
+              </a:ext>
+            </a:extLst>
+          </p:cNvPr>
+          <p:cNvCxnSpPr>
+            <a:cxnSpLocks/>
+          </p:cNvCxnSpPr>
+          <p:nvPr/>
+        </p:nvCxnSpPr>
+        <p:spPr>
+          <a:xfrm>
+            <a:off x="6824472" y="2670046"/>
+            <a:ext cx="551688" cy="0"/>
+          </a:xfrm>
+          <a:prstGeom prst="straightConnector1">
+            <a:avLst/>
+          </a:prstGeom>
+          <a:ln w="38100">
+            <a:solidFill>
+              <a:srgbClr val="FF0000"/>
+            </a:solidFill>
+            <a:tailEnd type="triangle"/>
+          </a:ln>
+        </p:spPr>
+        <p:style>
+          <a:lnRef idx="1">
+            <a:schemeClr val="accent1"/>
+          </a:lnRef>
+          <a:fillRef idx="0">
+            <a:schemeClr val="accent1"/>
+          </a:fillRef>
+          <a:effectRef idx="0">
+            <a:schemeClr val="accent1"/>
+          </a:effectRef>
+          <a:fontRef idx="minor">
+            <a:schemeClr val="tx1"/>
+          </a:fontRef>
+        </p:style>
+      </p:cxnSp>
+      <p:sp>
+        <p:nvSpPr>
+          <p:cNvPr id="19" name="TextBox 18">
+            <a:extLst>
+              <a:ext uri="{FF2B5EF4-FFF2-40B4-BE49-F238E27FC236}">
+                <a16:creationId xmlns:a16="http://schemas.microsoft.com/office/drawing/2014/main" id="{A2FD0FCE-7FAC-FFE3-03DC-DD75ECB7FD13}"/>
+              </a:ext>
+            </a:extLst>
+          </p:cNvPr>
+          <p:cNvSpPr txBox="1"/>
+          <p:nvPr/>
+        </p:nvSpPr>
+        <p:spPr>
+          <a:xfrm>
+            <a:off x="6892398" y="2300713"/>
+            <a:ext cx="288862" cy="369332"/>
+          </a:xfrm>
+          <a:prstGeom prst="rect">
+            <a:avLst/>
+          </a:prstGeom>
+          <a:noFill/>
+        </p:spPr>
+        <p:txBody>
+          <a:bodyPr wrap="none" rtlCol="0">
+            <a:spAutoFit/>
+          </a:bodyPr>
+          <a:lstStyle/>
+          <a:p>
+            <a:r>
+              <a:rPr lang="en-US" dirty="0">
+                <a:solidFill>
+                  <a:srgbClr val="FF0000"/>
+                </a:solidFill>
+              </a:rPr>
+              <a:t>v</a:t>
+            </a:r>
+          </a:p>
+        </p:txBody>
+      </p:sp>
+    </p:spTree>
+    <p:extLst>
+      <p:ext uri="{BB962C8B-B14F-4D97-AF65-F5344CB8AC3E}">
+        <p14:creationId xmlns:p14="http://schemas.microsoft.com/office/powerpoint/2010/main" val="1247448808"/>
+      </p:ext>
+    </p:extLst>
+  </p:cSld>
+  <p:clrMapOvr>
+    <a:masterClrMapping/>
+  </p:clrMapOvr>
+</p:sld>
+</file>
+
+<file path=ppt/slides/slide15.xml><?xml version="1.0" encoding="utf-8"?>
+<p:sld xmlns:a="http://schemas.openxmlformats.org/drawingml/2006/main" xmlns:r="http://schemas.openxmlformats.org/officeDocument/2006/relationships" xmlns:p="http://schemas.openxmlformats.org/presentationml/2006/main">
+  <p:cSld>
+    <p:spTree>
+      <p:nvGrpSpPr>
+        <p:cNvPr id="1" name=""/>
+        <p:cNvGrpSpPr/>
+        <p:nvPr/>
+      </p:nvGrpSpPr>
+      <p:grpSpPr>
+        <a:xfrm>
+          <a:off x="0" y="0"/>
+          <a:ext cx="0" cy="0"/>
+          <a:chOff x="0" y="0"/>
+          <a:chExt cx="0" cy="0"/>
+        </a:xfrm>
+      </p:grpSpPr>
+      <p:sp>
+        <p:nvSpPr>
+          <p:cNvPr id="23" name="Rectangle 22">
+            <a:extLst>
+              <a:ext uri="{FF2B5EF4-FFF2-40B4-BE49-F238E27FC236}">
+                <a16:creationId xmlns:a16="http://schemas.microsoft.com/office/drawing/2014/main" id="{E9B3595E-FFD0-BA39-FCC8-3F4E86448FCA}"/>
+              </a:ext>
+            </a:extLst>
+          </p:cNvPr>
+          <p:cNvSpPr/>
+          <p:nvPr/>
+        </p:nvSpPr>
+        <p:spPr>
+          <a:xfrm>
+            <a:off x="2182368" y="1243584"/>
+            <a:ext cx="7488936" cy="3191256"/>
+          </a:xfrm>
+          <a:prstGeom prst="rect">
+            <a:avLst/>
+          </a:prstGeom>
+          <a:solidFill>
+            <a:schemeClr val="bg1"/>
+          </a:solidFill>
+          <a:ln>
+            <a:noFill/>
+          </a:ln>
+        </p:spPr>
+        <p:style>
+          <a:lnRef idx="2">
+            <a:schemeClr val="accent1">
+              <a:shade val="15000"/>
+            </a:schemeClr>
+          </a:lnRef>
+          <a:fillRef idx="1">
+            <a:schemeClr val="accent1"/>
+          </a:fillRef>
+          <a:effectRef idx="0">
+            <a:schemeClr val="accent1"/>
+          </a:effectRef>
+          <a:fontRef idx="minor">
+            <a:schemeClr val="lt1"/>
+          </a:fontRef>
+        </p:style>
+        <p:txBody>
+          <a:bodyPr rtlCol="0" anchor="ctr"/>
+          <a:lstStyle/>
+          <a:p>
+            <a:pPr algn="ctr"/>
+            <a:endParaRPr lang="en-US"/>
+          </a:p>
+        </p:txBody>
+      </p:sp>
+      <p:sp>
+        <p:nvSpPr>
+          <p:cNvPr id="4" name="Cube 3">
+            <a:extLst>
+              <a:ext uri="{FF2B5EF4-FFF2-40B4-BE49-F238E27FC236}">
+                <a16:creationId xmlns:a16="http://schemas.microsoft.com/office/drawing/2014/main" id="{6FF530C8-B8D8-CF2D-9FC9-D3F61AFF3C1E}"/>
+              </a:ext>
+            </a:extLst>
+          </p:cNvPr>
+          <p:cNvSpPr/>
+          <p:nvPr/>
+        </p:nvSpPr>
+        <p:spPr>
+          <a:xfrm>
+            <a:off x="4568952" y="1911096"/>
+            <a:ext cx="2212848" cy="1517904"/>
+          </a:xfrm>
+          <a:prstGeom prst="cube">
+            <a:avLst/>
+          </a:prstGeom>
+          <a:solidFill>
+            <a:schemeClr val="accent1">
+              <a:lumMod val="20000"/>
+              <a:lumOff val="80000"/>
+            </a:schemeClr>
+          </a:solidFill>
+        </p:spPr>
+        <p:style>
+          <a:lnRef idx="2">
+            <a:schemeClr val="accent1">
+              <a:shade val="15000"/>
+            </a:schemeClr>
+          </a:lnRef>
+          <a:fillRef idx="1">
+            <a:schemeClr val="accent1"/>
+          </a:fillRef>
+          <a:effectRef idx="0">
+            <a:schemeClr val="accent1"/>
+          </a:effectRef>
+          <a:fontRef idx="minor">
+            <a:schemeClr val="lt1"/>
+          </a:fontRef>
+        </p:style>
+        <p:txBody>
+          <a:bodyPr rtlCol="0" anchor="ctr"/>
+          <a:lstStyle/>
+          <a:p>
+            <a:pPr algn="ctr"/>
+            <a:endParaRPr lang="en-US"/>
+          </a:p>
+        </p:txBody>
+      </p:sp>
+      <p:sp>
+        <p:nvSpPr>
+          <p:cNvPr id="5" name="TextBox 4">
+            <a:extLst>
+              <a:ext uri="{FF2B5EF4-FFF2-40B4-BE49-F238E27FC236}">
+                <a16:creationId xmlns:a16="http://schemas.microsoft.com/office/drawing/2014/main" id="{9DB800A5-898B-76A1-23F2-09ED707F8D43}"/>
+              </a:ext>
+            </a:extLst>
+          </p:cNvPr>
+          <p:cNvSpPr txBox="1"/>
+          <p:nvPr/>
+        </p:nvSpPr>
+        <p:spPr>
+          <a:xfrm>
+            <a:off x="2612136" y="2105275"/>
+            <a:ext cx="1647374" cy="369332"/>
+          </a:xfrm>
+          <a:prstGeom prst="rect">
+            <a:avLst/>
+          </a:prstGeom>
+          <a:noFill/>
+        </p:spPr>
+        <p:txBody>
+          <a:bodyPr wrap="none" rtlCol="0">
+            <a:spAutoFit/>
+          </a:bodyPr>
+          <a:lstStyle/>
+          <a:p>
+            <a:r>
+              <a:rPr lang="en-US" dirty="0"/>
+              <a:t>Sound Wave In</a:t>
+            </a:r>
+          </a:p>
+        </p:txBody>
+      </p:sp>
+      <p:cxnSp>
+        <p:nvCxnSpPr>
+          <p:cNvPr id="7" name="Straight Arrow Connector 6">
+            <a:extLst>
+              <a:ext uri="{FF2B5EF4-FFF2-40B4-BE49-F238E27FC236}">
+                <a16:creationId xmlns:a16="http://schemas.microsoft.com/office/drawing/2014/main" id="{53B41E67-32F0-8666-BCC8-E8CBDD178FD5}"/>
+              </a:ext>
+            </a:extLst>
+          </p:cNvPr>
+          <p:cNvCxnSpPr>
+            <a:cxnSpLocks/>
+          </p:cNvCxnSpPr>
+          <p:nvPr/>
+        </p:nvCxnSpPr>
+        <p:spPr>
+          <a:xfrm>
+            <a:off x="2815800" y="2794599"/>
+            <a:ext cx="1380744" cy="0"/>
+          </a:xfrm>
+          <a:prstGeom prst="straightConnector1">
+            <a:avLst/>
+          </a:prstGeom>
+          <a:ln w="57150">
+            <a:solidFill>
+              <a:srgbClr val="FF0000"/>
+            </a:solidFill>
+            <a:tailEnd type="triangle"/>
+          </a:ln>
+        </p:spPr>
+        <p:style>
+          <a:lnRef idx="1">
+            <a:schemeClr val="accent1"/>
+          </a:lnRef>
+          <a:fillRef idx="0">
+            <a:schemeClr val="accent1"/>
+          </a:fillRef>
+          <a:effectRef idx="0">
+            <a:schemeClr val="accent1"/>
+          </a:effectRef>
+          <a:fontRef idx="minor">
+            <a:schemeClr val="tx1"/>
+          </a:fontRef>
+        </p:style>
+      </p:cxnSp>
+      <p:cxnSp>
+        <p:nvCxnSpPr>
+          <p:cNvPr id="8" name="Straight Arrow Connector 7">
+            <a:extLst>
+              <a:ext uri="{FF2B5EF4-FFF2-40B4-BE49-F238E27FC236}">
+                <a16:creationId xmlns:a16="http://schemas.microsoft.com/office/drawing/2014/main" id="{F9F6F487-2D99-7F36-5867-097A34B08853}"/>
+              </a:ext>
+            </a:extLst>
+          </p:cNvPr>
+          <p:cNvCxnSpPr>
+            <a:cxnSpLocks/>
+          </p:cNvCxnSpPr>
+          <p:nvPr/>
+        </p:nvCxnSpPr>
+        <p:spPr>
+          <a:xfrm>
+            <a:off x="7000098" y="2794599"/>
+            <a:ext cx="1380744" cy="0"/>
+          </a:xfrm>
+          <a:prstGeom prst="straightConnector1">
+            <a:avLst/>
+          </a:prstGeom>
+          <a:ln w="57150">
+            <a:solidFill>
+              <a:srgbClr val="FF0000"/>
+            </a:solidFill>
+            <a:tailEnd type="triangle"/>
+          </a:ln>
+        </p:spPr>
+        <p:style>
+          <a:lnRef idx="1">
+            <a:schemeClr val="accent1"/>
+          </a:lnRef>
+          <a:fillRef idx="0">
+            <a:schemeClr val="accent1"/>
+          </a:fillRef>
+          <a:effectRef idx="0">
+            <a:schemeClr val="accent1"/>
+          </a:effectRef>
+          <a:fontRef idx="minor">
+            <a:schemeClr val="tx1"/>
+          </a:fontRef>
+        </p:style>
+      </p:cxnSp>
+      <mc:AlternateContent xmlns:mc="http://schemas.openxmlformats.org/markup-compatibility/2006">
+        <mc:Choice xmlns:a14="http://schemas.microsoft.com/office/drawing/2010/main" Requires="a14">
+          <p:sp>
+            <p:nvSpPr>
+              <p:cNvPr id="9" name="TextBox 8">
+                <a:extLst>
+                  <a:ext uri="{FF2B5EF4-FFF2-40B4-BE49-F238E27FC236}">
+                    <a16:creationId xmlns:a16="http://schemas.microsoft.com/office/drawing/2014/main" id="{A2652880-E3BA-1526-C57B-FAF4325E25A5}"/>
+                  </a:ext>
+                </a:extLst>
+              </p:cNvPr>
+              <p:cNvSpPr txBox="1"/>
+              <p:nvPr/>
+            </p:nvSpPr>
+            <p:spPr>
+              <a:xfrm>
+                <a:off x="2612136" y="2996028"/>
+                <a:ext cx="1316130" cy="369332"/>
+              </a:xfrm>
+              <a:prstGeom prst="rect">
+                <a:avLst/>
+              </a:prstGeom>
+              <a:noFill/>
+            </p:spPr>
+            <p:txBody>
+              <a:bodyPr wrap="none" rtlCol="0">
+                <a:spAutoFit/>
+              </a:bodyPr>
+              <a:lstStyle/>
+              <a:p>
+                <a:r>
+                  <a:rPr lang="en-US" dirty="0">
+                    <a:sym typeface="Symbol" panose="05050102010706020507" pitchFamily="18" charset="2"/>
+                  </a:rPr>
+                  <a:t></a:t>
+                </a:r>
+                <a14:m>
+                  <m:oMath xmlns:m="http://schemas.openxmlformats.org/officeDocument/2006/math">
+                    <m:sSub>
+                      <m:sSubPr>
+                        <m:ctrlPr>
+                          <a:rPr lang="en-US" i="1">
+                            <a:latin typeface="Cambria Math" panose="02040503050406030204" pitchFamily="18" charset="0"/>
+                            <a:ea typeface="Cambria Math" panose="02040503050406030204" pitchFamily="18" charset="0"/>
+                            <a:sym typeface="Symbol" panose="05050102010706020507" pitchFamily="18" charset="2"/>
+                          </a:rPr>
+                        </m:ctrlPr>
+                      </m:sSubPr>
+                      <m:e>
+                        <m:r>
+                          <a:rPr lang="en-US" i="1">
+                            <a:latin typeface="Cambria Math" panose="02040503050406030204" pitchFamily="18" charset="0"/>
+                            <a:ea typeface="Cambria Math" panose="02040503050406030204" pitchFamily="18" charset="0"/>
+                            <a:sym typeface="Symbol" panose="05050102010706020507" pitchFamily="18" charset="2"/>
+                          </a:rPr>
+                          <m:t>𝜌</m:t>
+                        </m:r>
+                      </m:e>
+                      <m:sub>
+                        <m:r>
+                          <a:rPr lang="en-US" i="1">
+                            <a:latin typeface="Cambria Math" panose="02040503050406030204" pitchFamily="18" charset="0"/>
+                            <a:ea typeface="Cambria Math" panose="02040503050406030204" pitchFamily="18" charset="0"/>
+                            <a:sym typeface="Symbol" panose="05050102010706020507" pitchFamily="18" charset="2"/>
+                          </a:rPr>
+                          <m:t>𝑖𝑛</m:t>
+                        </m:r>
+                      </m:sub>
+                    </m:sSub>
+                    <m:r>
+                      <a:rPr lang="en-US" i="1">
+                        <a:latin typeface="Cambria Math" panose="02040503050406030204" pitchFamily="18" charset="0"/>
+                        <a:ea typeface="Cambria Math" panose="02040503050406030204" pitchFamily="18" charset="0"/>
+                        <a:sym typeface="Symbol" panose="05050102010706020507" pitchFamily="18" charset="2"/>
+                      </a:rPr>
+                      <m:t>,</m:t>
+                    </m:r>
+                    <m:sSub>
+                      <m:sSubPr>
+                        <m:ctrlPr>
+                          <a:rPr lang="en-US" i="1">
+                            <a:latin typeface="Cambria Math" panose="02040503050406030204" pitchFamily="18" charset="0"/>
+                            <a:ea typeface="Cambria Math" panose="02040503050406030204" pitchFamily="18" charset="0"/>
+                            <a:sym typeface="Symbol" panose="05050102010706020507" pitchFamily="18" charset="2"/>
+                          </a:rPr>
+                        </m:ctrlPr>
+                      </m:sSubPr>
+                      <m:e>
+                        <m:r>
+                          <a:rPr lang="en-US" i="1">
+                            <a:latin typeface="Cambria Math" panose="02040503050406030204" pitchFamily="18" charset="0"/>
+                            <a:ea typeface="Cambria Math" panose="02040503050406030204" pitchFamily="18" charset="0"/>
+                            <a:sym typeface="Symbol" panose="05050102010706020507" pitchFamily="18" charset="2"/>
+                          </a:rPr>
+                          <m:t>𝑣</m:t>
+                        </m:r>
+                      </m:e>
+                      <m:sub>
+                        <m:r>
+                          <a:rPr lang="en-US" i="1">
+                            <a:latin typeface="Cambria Math" panose="02040503050406030204" pitchFamily="18" charset="0"/>
+                            <a:ea typeface="Cambria Math" panose="02040503050406030204" pitchFamily="18" charset="0"/>
+                            <a:sym typeface="Symbol" panose="05050102010706020507" pitchFamily="18" charset="2"/>
+                          </a:rPr>
+                          <m:t>𝑖𝑛</m:t>
+                        </m:r>
+                      </m:sub>
+                    </m:sSub>
+                    <m:r>
+                      <a:rPr lang="en-US" i="1">
+                        <a:latin typeface="Cambria Math" panose="02040503050406030204" pitchFamily="18" charset="0"/>
+                        <a:ea typeface="Cambria Math" panose="02040503050406030204" pitchFamily="18" charset="0"/>
+                        <a:sym typeface="Symbol" panose="05050102010706020507" pitchFamily="18" charset="2"/>
+                      </a:rPr>
+                      <m:t>,</m:t>
+                    </m:r>
+                    <m:sSub>
+                      <m:sSubPr>
+                        <m:ctrlPr>
+                          <a:rPr lang="en-US" i="1">
+                            <a:latin typeface="Cambria Math" panose="02040503050406030204" pitchFamily="18" charset="0"/>
+                            <a:ea typeface="Cambria Math" panose="02040503050406030204" pitchFamily="18" charset="0"/>
+                            <a:sym typeface="Symbol" panose="05050102010706020507" pitchFamily="18" charset="2"/>
+                          </a:rPr>
+                        </m:ctrlPr>
+                      </m:sSubPr>
+                      <m:e>
+                        <m:r>
+                          <a:rPr lang="en-US" i="1">
+                            <a:latin typeface="Cambria Math" panose="02040503050406030204" pitchFamily="18" charset="0"/>
+                            <a:ea typeface="Cambria Math" panose="02040503050406030204" pitchFamily="18" charset="0"/>
+                            <a:sym typeface="Symbol" panose="05050102010706020507" pitchFamily="18" charset="2"/>
+                          </a:rPr>
+                          <m:t>𝑇</m:t>
+                        </m:r>
+                      </m:e>
+                      <m:sub>
+                        <m:r>
+                          <a:rPr lang="en-US" i="1">
+                            <a:latin typeface="Cambria Math" panose="02040503050406030204" pitchFamily="18" charset="0"/>
+                            <a:ea typeface="Cambria Math" panose="02040503050406030204" pitchFamily="18" charset="0"/>
+                            <a:sym typeface="Symbol" panose="05050102010706020507" pitchFamily="18" charset="2"/>
+                          </a:rPr>
+                          <m:t>𝑖𝑛</m:t>
+                        </m:r>
+                      </m:sub>
+                    </m:sSub>
+                  </m:oMath>
+                </a14:m>
+                <a:endParaRPr lang="en-US" dirty="0"/>
+              </a:p>
+            </p:txBody>
+          </p:sp>
+        </mc:Choice>
+        <mc:Fallback>
+          <p:sp>
+            <p:nvSpPr>
+              <p:cNvPr id="9" name="TextBox 8">
+                <a:extLst>
+                  <a:ext uri="{FF2B5EF4-FFF2-40B4-BE49-F238E27FC236}">
+                    <a16:creationId xmlns:a16="http://schemas.microsoft.com/office/drawing/2014/main" id="{A2652880-E3BA-1526-C57B-FAF4325E25A5}"/>
+                  </a:ext>
+                </a:extLst>
+              </p:cNvPr>
+              <p:cNvSpPr txBox="1">
+                <a:spLocks noRot="1" noChangeAspect="1" noMove="1" noResize="1" noEditPoints="1" noAdjustHandles="1" noChangeArrowheads="1" noChangeShapeType="1" noTextEdit="1"/>
+              </p:cNvSpPr>
+              <p:nvPr/>
+            </p:nvSpPr>
+            <p:spPr>
+              <a:xfrm>
+                <a:off x="2612136" y="2996028"/>
+                <a:ext cx="1316130" cy="369332"/>
+              </a:xfrm>
+              <a:prstGeom prst="rect">
+                <a:avLst/>
+              </a:prstGeom>
+              <a:blipFill>
+                <a:blip r:embed="rId2"/>
+                <a:stretch>
+                  <a:fillRect l="-4186" t="-11475" b="-21311"/>
+                </a:stretch>
+              </a:blipFill>
+            </p:spPr>
+            <p:txBody>
+              <a:bodyPr/>
+              <a:lstStyle/>
+              <a:p>
+                <a:r>
+                  <a:rPr lang="en-US">
+                    <a:noFill/>
+                  </a:rPr>
+                  <a:t> </a:t>
+                </a:r>
+              </a:p>
+            </p:txBody>
+          </p:sp>
+        </mc:Fallback>
+      </mc:AlternateContent>
+      <mc:AlternateContent xmlns:mc="http://schemas.openxmlformats.org/markup-compatibility/2006">
+        <mc:Choice xmlns:a14="http://schemas.microsoft.com/office/drawing/2010/main" Requires="a14">
+          <p:sp>
+            <p:nvSpPr>
+              <p:cNvPr id="10" name="TextBox 9">
+                <a:extLst>
+                  <a:ext uri="{FF2B5EF4-FFF2-40B4-BE49-F238E27FC236}">
+                    <a16:creationId xmlns:a16="http://schemas.microsoft.com/office/drawing/2014/main" id="{329EBA03-A8F7-8263-C359-5DE180645ECE}"/>
+                  </a:ext>
+                </a:extLst>
+              </p:cNvPr>
+              <p:cNvSpPr txBox="1"/>
+              <p:nvPr/>
+            </p:nvSpPr>
+            <p:spPr>
+              <a:xfrm>
+                <a:off x="7000098" y="2996028"/>
+                <a:ext cx="1662378" cy="369332"/>
+              </a:xfrm>
+              <a:prstGeom prst="rect">
+                <a:avLst/>
+              </a:prstGeom>
+              <a:noFill/>
+            </p:spPr>
+            <p:txBody>
+              <a:bodyPr wrap="none" rtlCol="0">
+                <a:spAutoFit/>
+              </a:bodyPr>
+              <a:lstStyle/>
+              <a:p>
+                <a:r>
+                  <a:rPr lang="en-US" dirty="0">
+                    <a:sym typeface="Symbol" panose="05050102010706020507" pitchFamily="18" charset="2"/>
+                  </a:rPr>
+                  <a:t></a:t>
+                </a:r>
+                <a14:m>
+                  <m:oMath xmlns:m="http://schemas.openxmlformats.org/officeDocument/2006/math">
+                    <m:sSub>
+                      <m:sSubPr>
+                        <m:ctrlPr>
+                          <a:rPr lang="en-US" i="1">
+                            <a:latin typeface="Cambria Math" panose="02040503050406030204" pitchFamily="18" charset="0"/>
+                            <a:ea typeface="Cambria Math" panose="02040503050406030204" pitchFamily="18" charset="0"/>
+                            <a:sym typeface="Symbol" panose="05050102010706020507" pitchFamily="18" charset="2"/>
+                          </a:rPr>
+                        </m:ctrlPr>
+                      </m:sSubPr>
+                      <m:e>
+                        <m:r>
+                          <a:rPr lang="en-US" i="1">
+                            <a:latin typeface="Cambria Math" panose="02040503050406030204" pitchFamily="18" charset="0"/>
+                            <a:ea typeface="Cambria Math" panose="02040503050406030204" pitchFamily="18" charset="0"/>
+                            <a:sym typeface="Symbol" panose="05050102010706020507" pitchFamily="18" charset="2"/>
+                          </a:rPr>
+                          <m:t>𝜌</m:t>
+                        </m:r>
+                      </m:e>
+                      <m:sub>
+                        <m:r>
+                          <a:rPr lang="en-US" i="1">
+                            <a:latin typeface="Cambria Math" panose="02040503050406030204" pitchFamily="18" charset="0"/>
+                            <a:ea typeface="Cambria Math" panose="02040503050406030204" pitchFamily="18" charset="0"/>
+                            <a:sym typeface="Symbol" panose="05050102010706020507" pitchFamily="18" charset="2"/>
+                          </a:rPr>
+                          <m:t>𝑜𝑢𝑡</m:t>
+                        </m:r>
+                      </m:sub>
+                    </m:sSub>
+                    <m:r>
+                      <a:rPr lang="en-US" i="1">
+                        <a:latin typeface="Cambria Math" panose="02040503050406030204" pitchFamily="18" charset="0"/>
+                        <a:ea typeface="Cambria Math" panose="02040503050406030204" pitchFamily="18" charset="0"/>
+                        <a:sym typeface="Symbol" panose="05050102010706020507" pitchFamily="18" charset="2"/>
+                      </a:rPr>
+                      <m:t>,</m:t>
+                    </m:r>
+                    <m:sSub>
+                      <m:sSubPr>
+                        <m:ctrlPr>
+                          <a:rPr lang="en-US" i="1">
+                            <a:latin typeface="Cambria Math" panose="02040503050406030204" pitchFamily="18" charset="0"/>
+                            <a:ea typeface="Cambria Math" panose="02040503050406030204" pitchFamily="18" charset="0"/>
+                            <a:sym typeface="Symbol" panose="05050102010706020507" pitchFamily="18" charset="2"/>
+                          </a:rPr>
+                        </m:ctrlPr>
+                      </m:sSubPr>
+                      <m:e>
+                        <m:r>
+                          <a:rPr lang="en-US" i="1">
+                            <a:latin typeface="Cambria Math" panose="02040503050406030204" pitchFamily="18" charset="0"/>
+                            <a:ea typeface="Cambria Math" panose="02040503050406030204" pitchFamily="18" charset="0"/>
+                            <a:sym typeface="Symbol" panose="05050102010706020507" pitchFamily="18" charset="2"/>
+                          </a:rPr>
+                          <m:t>𝑣</m:t>
+                        </m:r>
+                      </m:e>
+                      <m:sub>
+                        <m:r>
+                          <a:rPr lang="en-US" i="1">
+                            <a:latin typeface="Cambria Math" panose="02040503050406030204" pitchFamily="18" charset="0"/>
+                            <a:ea typeface="Cambria Math" panose="02040503050406030204" pitchFamily="18" charset="0"/>
+                            <a:sym typeface="Symbol" panose="05050102010706020507" pitchFamily="18" charset="2"/>
+                          </a:rPr>
+                          <m:t>𝑜𝑢𝑡</m:t>
+                        </m:r>
+                      </m:sub>
+                    </m:sSub>
+                    <m:r>
+                      <a:rPr lang="en-US" i="1">
+                        <a:latin typeface="Cambria Math" panose="02040503050406030204" pitchFamily="18" charset="0"/>
+                        <a:ea typeface="Cambria Math" panose="02040503050406030204" pitchFamily="18" charset="0"/>
+                        <a:sym typeface="Symbol" panose="05050102010706020507" pitchFamily="18" charset="2"/>
+                      </a:rPr>
+                      <m:t>,</m:t>
+                    </m:r>
+                    <m:sSub>
+                      <m:sSubPr>
+                        <m:ctrlPr>
+                          <a:rPr lang="en-US" i="1">
+                            <a:latin typeface="Cambria Math" panose="02040503050406030204" pitchFamily="18" charset="0"/>
+                            <a:ea typeface="Cambria Math" panose="02040503050406030204" pitchFamily="18" charset="0"/>
+                            <a:sym typeface="Symbol" panose="05050102010706020507" pitchFamily="18" charset="2"/>
+                          </a:rPr>
+                        </m:ctrlPr>
+                      </m:sSubPr>
+                      <m:e>
+                        <m:r>
+                          <a:rPr lang="en-US" i="1">
+                            <a:latin typeface="Cambria Math" panose="02040503050406030204" pitchFamily="18" charset="0"/>
+                            <a:ea typeface="Cambria Math" panose="02040503050406030204" pitchFamily="18" charset="0"/>
+                            <a:sym typeface="Symbol" panose="05050102010706020507" pitchFamily="18" charset="2"/>
+                          </a:rPr>
+                          <m:t>𝑇</m:t>
+                        </m:r>
+                      </m:e>
+                      <m:sub>
+                        <m:r>
+                          <a:rPr lang="en-US" i="1">
+                            <a:latin typeface="Cambria Math" panose="02040503050406030204" pitchFamily="18" charset="0"/>
+                            <a:ea typeface="Cambria Math" panose="02040503050406030204" pitchFamily="18" charset="0"/>
+                            <a:sym typeface="Symbol" panose="05050102010706020507" pitchFamily="18" charset="2"/>
+                          </a:rPr>
+                          <m:t>𝑜𝑢𝑡</m:t>
+                        </m:r>
+                      </m:sub>
+                    </m:sSub>
+                  </m:oMath>
+                </a14:m>
+                <a:endParaRPr lang="en-US" dirty="0"/>
+              </a:p>
+            </p:txBody>
+          </p:sp>
+        </mc:Choice>
+        <mc:Fallback>
+          <p:sp>
+            <p:nvSpPr>
+              <p:cNvPr id="10" name="TextBox 9">
+                <a:extLst>
+                  <a:ext uri="{FF2B5EF4-FFF2-40B4-BE49-F238E27FC236}">
+                    <a16:creationId xmlns:a16="http://schemas.microsoft.com/office/drawing/2014/main" id="{329EBA03-A8F7-8263-C359-5DE180645ECE}"/>
+                  </a:ext>
+                </a:extLst>
+              </p:cNvPr>
+              <p:cNvSpPr txBox="1">
+                <a:spLocks noRot="1" noChangeAspect="1" noMove="1" noResize="1" noEditPoints="1" noAdjustHandles="1" noChangeArrowheads="1" noChangeShapeType="1" noTextEdit="1"/>
+              </p:cNvSpPr>
+              <p:nvPr/>
+            </p:nvSpPr>
+            <p:spPr>
+              <a:xfrm>
+                <a:off x="7000098" y="2996028"/>
+                <a:ext cx="1662378" cy="369332"/>
+              </a:xfrm>
+              <a:prstGeom prst="rect">
+                <a:avLst/>
+              </a:prstGeom>
+              <a:blipFill>
+                <a:blip r:embed="rId3"/>
+                <a:stretch>
+                  <a:fillRect l="-2930" t="-11475" b="-21311"/>
+                </a:stretch>
+              </a:blipFill>
+            </p:spPr>
+            <p:txBody>
+              <a:bodyPr/>
+              <a:lstStyle/>
+              <a:p>
+                <a:r>
+                  <a:rPr lang="en-US">
+                    <a:noFill/>
+                  </a:rPr>
+                  <a:t> </a:t>
+                </a:r>
+              </a:p>
+            </p:txBody>
+          </p:sp>
+        </mc:Fallback>
+      </mc:AlternateContent>
+      <p:cxnSp>
+        <p:nvCxnSpPr>
+          <p:cNvPr id="12" name="Straight Connector 11">
+            <a:extLst>
+              <a:ext uri="{FF2B5EF4-FFF2-40B4-BE49-F238E27FC236}">
+                <a16:creationId xmlns:a16="http://schemas.microsoft.com/office/drawing/2014/main" id="{AAC7E8B9-6AB3-FFE6-52BA-931BFBB171E9}"/>
+              </a:ext>
+            </a:extLst>
+          </p:cNvPr>
+          <p:cNvCxnSpPr>
+            <a:cxnSpLocks/>
+          </p:cNvCxnSpPr>
+          <p:nvPr/>
+        </p:nvCxnSpPr>
+        <p:spPr>
+          <a:xfrm>
+            <a:off x="4943856" y="1911096"/>
+            <a:ext cx="0" cy="1145524"/>
+          </a:xfrm>
+          <a:prstGeom prst="line">
+            <a:avLst/>
+          </a:prstGeom>
+          <a:ln>
+            <a:prstDash val="dash"/>
+          </a:ln>
+        </p:spPr>
+        <p:style>
+          <a:lnRef idx="1">
+            <a:schemeClr val="accent1"/>
+          </a:lnRef>
+          <a:fillRef idx="0">
+            <a:schemeClr val="accent1"/>
+          </a:fillRef>
+          <a:effectRef idx="0">
+            <a:schemeClr val="accent1"/>
+          </a:effectRef>
+          <a:fontRef idx="minor">
+            <a:schemeClr val="tx1"/>
+          </a:fontRef>
+        </p:style>
+      </p:cxnSp>
+      <p:cxnSp>
+        <p:nvCxnSpPr>
+          <p:cNvPr id="13" name="Straight Connector 12">
+            <a:extLst>
+              <a:ext uri="{FF2B5EF4-FFF2-40B4-BE49-F238E27FC236}">
+                <a16:creationId xmlns:a16="http://schemas.microsoft.com/office/drawing/2014/main" id="{88EA8E0F-34FE-7F7D-0D65-F49892AABB9A}"/>
+              </a:ext>
+            </a:extLst>
+          </p:cNvPr>
+          <p:cNvCxnSpPr>
+            <a:cxnSpLocks/>
+          </p:cNvCxnSpPr>
+          <p:nvPr/>
+        </p:nvCxnSpPr>
+        <p:spPr>
+          <a:xfrm flipH="1">
+            <a:off x="4943856" y="3044428"/>
+            <a:ext cx="1837944" cy="0"/>
+          </a:xfrm>
+          <a:prstGeom prst="line">
+            <a:avLst/>
+          </a:prstGeom>
+          <a:ln>
+            <a:prstDash val="dash"/>
+          </a:ln>
+        </p:spPr>
+        <p:style>
+          <a:lnRef idx="1">
+            <a:schemeClr val="accent1"/>
+          </a:lnRef>
+          <a:fillRef idx="0">
+            <a:schemeClr val="accent1"/>
+          </a:fillRef>
+          <a:effectRef idx="0">
+            <a:schemeClr val="accent1"/>
+          </a:effectRef>
+          <a:fontRef idx="minor">
+            <a:schemeClr val="tx1"/>
+          </a:fontRef>
+        </p:style>
+      </p:cxnSp>
+      <p:cxnSp>
+        <p:nvCxnSpPr>
+          <p:cNvPr id="17" name="Straight Connector 16">
+            <a:extLst>
+              <a:ext uri="{FF2B5EF4-FFF2-40B4-BE49-F238E27FC236}">
+                <a16:creationId xmlns:a16="http://schemas.microsoft.com/office/drawing/2014/main" id="{5539441F-EAA9-837A-93F1-CCFB58048557}"/>
+              </a:ext>
+            </a:extLst>
+          </p:cNvPr>
+          <p:cNvCxnSpPr>
+            <a:cxnSpLocks/>
+          </p:cNvCxnSpPr>
+          <p:nvPr/>
+        </p:nvCxnSpPr>
+        <p:spPr>
+          <a:xfrm flipH="1">
+            <a:off x="4568952" y="3056620"/>
+            <a:ext cx="374904" cy="369332"/>
+          </a:xfrm>
+          <a:prstGeom prst="line">
+            <a:avLst/>
+          </a:prstGeom>
+          <a:ln>
+            <a:prstDash val="dash"/>
+          </a:ln>
+        </p:spPr>
+        <p:style>
+          <a:lnRef idx="1">
+            <a:schemeClr val="accent1"/>
+          </a:lnRef>
+          <a:fillRef idx="0">
+            <a:schemeClr val="accent1"/>
+          </a:fillRef>
+          <a:effectRef idx="0">
+            <a:schemeClr val="accent1"/>
+          </a:effectRef>
+          <a:fontRef idx="minor">
+            <a:schemeClr val="tx1"/>
+          </a:fontRef>
+        </p:style>
+      </p:cxnSp>
+      <p:sp>
+        <p:nvSpPr>
+          <p:cNvPr id="19" name="TextBox 18">
+            <a:extLst>
+              <a:ext uri="{FF2B5EF4-FFF2-40B4-BE49-F238E27FC236}">
+                <a16:creationId xmlns:a16="http://schemas.microsoft.com/office/drawing/2014/main" id="{30529782-63D2-9A27-B18E-5660AC840788}"/>
+              </a:ext>
+            </a:extLst>
+          </p:cNvPr>
+          <p:cNvSpPr txBox="1"/>
+          <p:nvPr/>
+        </p:nvSpPr>
+        <p:spPr>
+          <a:xfrm>
+            <a:off x="6464084" y="2560748"/>
+            <a:ext cx="320922" cy="369332"/>
+          </a:xfrm>
+          <a:prstGeom prst="rect">
+            <a:avLst/>
+          </a:prstGeom>
+          <a:noFill/>
+        </p:spPr>
+        <p:txBody>
+          <a:bodyPr wrap="none" rtlCol="0">
+            <a:spAutoFit/>
+          </a:bodyPr>
+          <a:lstStyle/>
+          <a:p>
+            <a:r>
+              <a:rPr lang="en-US" dirty="0"/>
+              <a:t>A</a:t>
+            </a:r>
+          </a:p>
+        </p:txBody>
+      </p:sp>
+      <p:sp>
+        <p:nvSpPr>
+          <p:cNvPr id="20" name="TextBox 19">
+            <a:extLst>
+              <a:ext uri="{FF2B5EF4-FFF2-40B4-BE49-F238E27FC236}">
+                <a16:creationId xmlns:a16="http://schemas.microsoft.com/office/drawing/2014/main" id="{76403000-451C-72F1-9B6E-1F8C53CF126C}"/>
+              </a:ext>
+            </a:extLst>
+          </p:cNvPr>
+          <p:cNvSpPr txBox="1"/>
+          <p:nvPr/>
+        </p:nvSpPr>
+        <p:spPr>
+          <a:xfrm>
+            <a:off x="7000098" y="2105275"/>
+            <a:ext cx="1833322" cy="369332"/>
+          </a:xfrm>
+          <a:prstGeom prst="rect">
+            <a:avLst/>
+          </a:prstGeom>
+          <a:noFill/>
+        </p:spPr>
+        <p:txBody>
+          <a:bodyPr wrap="none" rtlCol="0">
+            <a:spAutoFit/>
+          </a:bodyPr>
+          <a:lstStyle/>
+          <a:p>
+            <a:r>
+              <a:rPr lang="en-US" dirty="0"/>
+              <a:t>Sound Wave Out</a:t>
+            </a:r>
+          </a:p>
+        </p:txBody>
+      </p:sp>
+      <p:sp>
+        <p:nvSpPr>
+          <p:cNvPr id="21" name="TextBox 20">
+            <a:extLst>
+              <a:ext uri="{FF2B5EF4-FFF2-40B4-BE49-F238E27FC236}">
+                <a16:creationId xmlns:a16="http://schemas.microsoft.com/office/drawing/2014/main" id="{815EF259-62C8-1D0A-772E-A1AD883B08CB}"/>
+              </a:ext>
+            </a:extLst>
+          </p:cNvPr>
+          <p:cNvSpPr txBox="1"/>
+          <p:nvPr/>
+        </p:nvSpPr>
+        <p:spPr>
+          <a:xfrm>
+            <a:off x="4962144" y="3543348"/>
+            <a:ext cx="1366400" cy="369332"/>
+          </a:xfrm>
+          <a:prstGeom prst="rect">
+            <a:avLst/>
+          </a:prstGeom>
+          <a:noFill/>
+        </p:spPr>
+        <p:txBody>
+          <a:bodyPr wrap="none" rtlCol="0">
+            <a:spAutoFit/>
+          </a:bodyPr>
+          <a:lstStyle/>
+          <a:p>
+            <a:r>
+              <a:rPr lang="en-US" dirty="0"/>
+              <a:t>Parcel of Air</a:t>
+            </a:r>
+          </a:p>
+        </p:txBody>
+      </p:sp>
+    </p:spTree>
+    <p:extLst>
+      <p:ext uri="{BB962C8B-B14F-4D97-AF65-F5344CB8AC3E}">
+        <p14:creationId xmlns:p14="http://schemas.microsoft.com/office/powerpoint/2010/main" val="4168904192"/>
+      </p:ext>
+    </p:extLst>
+  </p:cSld>
+  <p:clrMapOvr>
+    <a:masterClrMapping/>
+  </p:clrMapOvr>
+</p:sld>
+</file>
+
+<file path=ppt/slides/slide16.xml><?xml version="1.0" encoding="utf-8"?>
+<p:sld xmlns:a="http://schemas.openxmlformats.org/drawingml/2006/main" xmlns:r="http://schemas.openxmlformats.org/officeDocument/2006/relationships" xmlns:p="http://schemas.openxmlformats.org/presentationml/2006/main">
+  <p:cSld>
+    <p:spTree>
+      <p:nvGrpSpPr>
+        <p:cNvPr id="1" name="">
+          <a:extLst>
+            <a:ext uri="{FF2B5EF4-FFF2-40B4-BE49-F238E27FC236}">
+              <a16:creationId xmlns:a16="http://schemas.microsoft.com/office/drawing/2014/main" id="{D9E86AD2-BCB5-92CD-EE00-289A1BFC3583}"/>
+            </a:ext>
+          </a:extLst>
+        </p:cNvPr>
+        <p:cNvGrpSpPr/>
+        <p:nvPr/>
+      </p:nvGrpSpPr>
+      <p:grpSpPr>
+        <a:xfrm>
+          <a:off x="0" y="0"/>
+          <a:ext cx="0" cy="0"/>
+          <a:chOff x="0" y="0"/>
+          <a:chExt cx="0" cy="0"/>
+        </a:xfrm>
+      </p:grpSpPr>
+      <p:sp>
+        <p:nvSpPr>
+          <p:cNvPr id="23" name="Rectangle 22">
+            <a:extLst>
+              <a:ext uri="{FF2B5EF4-FFF2-40B4-BE49-F238E27FC236}">
+                <a16:creationId xmlns:a16="http://schemas.microsoft.com/office/drawing/2014/main" id="{D3BE6317-D1B2-E0D8-8603-E3F69B778159}"/>
+              </a:ext>
+            </a:extLst>
+          </p:cNvPr>
+          <p:cNvSpPr/>
+          <p:nvPr/>
+        </p:nvSpPr>
+        <p:spPr>
+          <a:xfrm>
+            <a:off x="2250948" y="1198971"/>
+            <a:ext cx="7488936" cy="3191256"/>
+          </a:xfrm>
+          <a:prstGeom prst="rect">
+            <a:avLst/>
+          </a:prstGeom>
+          <a:solidFill>
+            <a:schemeClr val="bg1"/>
+          </a:solidFill>
+          <a:ln>
+            <a:noFill/>
+          </a:ln>
+        </p:spPr>
+        <p:style>
+          <a:lnRef idx="2">
+            <a:schemeClr val="accent1">
+              <a:shade val="15000"/>
+            </a:schemeClr>
+          </a:lnRef>
+          <a:fillRef idx="1">
+            <a:schemeClr val="accent1"/>
+          </a:fillRef>
+          <a:effectRef idx="0">
+            <a:schemeClr val="accent1"/>
+          </a:effectRef>
+          <a:fontRef idx="minor">
+            <a:schemeClr val="lt1"/>
+          </a:fontRef>
+        </p:style>
+        <p:txBody>
+          <a:bodyPr rtlCol="0" anchor="ctr"/>
+          <a:lstStyle/>
+          <a:p>
+            <a:pPr algn="ctr"/>
+            <a:r>
+              <a:rPr lang="en-US" dirty="0"/>
+              <a:t>P</a:t>
+            </a:r>
+          </a:p>
+        </p:txBody>
+      </p:sp>
+      <p:sp>
+        <p:nvSpPr>
+          <p:cNvPr id="4" name="Cube 3">
+            <a:extLst>
+              <a:ext uri="{FF2B5EF4-FFF2-40B4-BE49-F238E27FC236}">
+                <a16:creationId xmlns:a16="http://schemas.microsoft.com/office/drawing/2014/main" id="{59DFCA99-EC97-278E-AAE4-8423188FEC52}"/>
+              </a:ext>
+            </a:extLst>
+          </p:cNvPr>
+          <p:cNvSpPr/>
+          <p:nvPr/>
+        </p:nvSpPr>
+        <p:spPr>
+          <a:xfrm>
+            <a:off x="4568952" y="1911096"/>
+            <a:ext cx="2212848" cy="1517904"/>
+          </a:xfrm>
+          <a:prstGeom prst="cube">
+            <a:avLst/>
+          </a:prstGeom>
+          <a:solidFill>
+            <a:schemeClr val="accent1">
+              <a:lumMod val="20000"/>
+              <a:lumOff val="80000"/>
+            </a:schemeClr>
+          </a:solidFill>
+        </p:spPr>
+        <p:style>
+          <a:lnRef idx="2">
+            <a:schemeClr val="accent1">
+              <a:shade val="15000"/>
+            </a:schemeClr>
+          </a:lnRef>
+          <a:fillRef idx="1">
+            <a:schemeClr val="accent1"/>
+          </a:fillRef>
+          <a:effectRef idx="0">
+            <a:schemeClr val="accent1"/>
+          </a:effectRef>
+          <a:fontRef idx="minor">
+            <a:schemeClr val="lt1"/>
+          </a:fontRef>
+        </p:style>
+        <p:txBody>
+          <a:bodyPr rtlCol="0" anchor="ctr"/>
+          <a:lstStyle/>
+          <a:p>
+            <a:pPr algn="ctr"/>
+            <a:endParaRPr lang="en-US"/>
+          </a:p>
+        </p:txBody>
+      </p:sp>
+      <p:cxnSp>
+        <p:nvCxnSpPr>
+          <p:cNvPr id="7" name="Straight Arrow Connector 6">
+            <a:extLst>
+              <a:ext uri="{FF2B5EF4-FFF2-40B4-BE49-F238E27FC236}">
+                <a16:creationId xmlns:a16="http://schemas.microsoft.com/office/drawing/2014/main" id="{227D5FB6-7D29-746E-1F5E-AED189F8769D}"/>
+              </a:ext>
+            </a:extLst>
+          </p:cNvPr>
+          <p:cNvCxnSpPr>
+            <a:cxnSpLocks/>
+          </p:cNvCxnSpPr>
+          <p:nvPr/>
+        </p:nvCxnSpPr>
+        <p:spPr>
+          <a:xfrm>
+            <a:off x="3828288" y="2794599"/>
+            <a:ext cx="740664" cy="0"/>
+          </a:xfrm>
+          <a:prstGeom prst="straightConnector1">
+            <a:avLst/>
+          </a:prstGeom>
+          <a:ln w="57150">
+            <a:solidFill>
+              <a:srgbClr val="00B050"/>
+            </a:solidFill>
+            <a:tailEnd type="triangle"/>
+          </a:ln>
+        </p:spPr>
+        <p:style>
+          <a:lnRef idx="1">
+            <a:schemeClr val="accent1"/>
+          </a:lnRef>
+          <a:fillRef idx="0">
+            <a:schemeClr val="accent1"/>
+          </a:fillRef>
+          <a:effectRef idx="0">
+            <a:schemeClr val="accent1"/>
+          </a:effectRef>
+          <a:fontRef idx="minor">
+            <a:schemeClr val="tx1"/>
+          </a:fontRef>
+        </p:style>
+      </p:cxnSp>
+      <p:cxnSp>
+        <p:nvCxnSpPr>
+          <p:cNvPr id="8" name="Straight Arrow Connector 7">
+            <a:extLst>
+              <a:ext uri="{FF2B5EF4-FFF2-40B4-BE49-F238E27FC236}">
+                <a16:creationId xmlns:a16="http://schemas.microsoft.com/office/drawing/2014/main" id="{D0D5F3AA-D694-FAB8-ECD5-256D6B66F29F}"/>
+              </a:ext>
+            </a:extLst>
+          </p:cNvPr>
+          <p:cNvCxnSpPr>
+            <a:cxnSpLocks/>
+          </p:cNvCxnSpPr>
+          <p:nvPr/>
+        </p:nvCxnSpPr>
+        <p:spPr>
+          <a:xfrm flipH="1">
+            <a:off x="6515466" y="2767595"/>
+            <a:ext cx="933846" cy="0"/>
+          </a:xfrm>
+          <a:prstGeom prst="straightConnector1">
+            <a:avLst/>
+          </a:prstGeom>
+          <a:ln w="57150">
+            <a:solidFill>
+              <a:srgbClr val="00B050"/>
+            </a:solidFill>
+            <a:tailEnd type="triangle"/>
+          </a:ln>
+        </p:spPr>
+        <p:style>
+          <a:lnRef idx="1">
+            <a:schemeClr val="accent1"/>
+          </a:lnRef>
+          <a:fillRef idx="0">
+            <a:schemeClr val="accent1"/>
+          </a:fillRef>
+          <a:effectRef idx="0">
+            <a:schemeClr val="accent1"/>
+          </a:effectRef>
+          <a:fontRef idx="minor">
+            <a:schemeClr val="tx1"/>
+          </a:fontRef>
+        </p:style>
+      </p:cxnSp>
+      <p:cxnSp>
+        <p:nvCxnSpPr>
+          <p:cNvPr id="12" name="Straight Connector 11">
+            <a:extLst>
+              <a:ext uri="{FF2B5EF4-FFF2-40B4-BE49-F238E27FC236}">
+                <a16:creationId xmlns:a16="http://schemas.microsoft.com/office/drawing/2014/main" id="{3D8C1748-0B21-B782-ECD1-80EC5F45D008}"/>
+              </a:ext>
+            </a:extLst>
+          </p:cNvPr>
+          <p:cNvCxnSpPr>
+            <a:cxnSpLocks/>
+          </p:cNvCxnSpPr>
+          <p:nvPr/>
+        </p:nvCxnSpPr>
+        <p:spPr>
+          <a:xfrm>
+            <a:off x="4943856" y="1911096"/>
+            <a:ext cx="0" cy="1145524"/>
+          </a:xfrm>
+          <a:prstGeom prst="line">
+            <a:avLst/>
+          </a:prstGeom>
+          <a:ln>
+            <a:prstDash val="dash"/>
+          </a:ln>
+        </p:spPr>
+        <p:style>
+          <a:lnRef idx="1">
+            <a:schemeClr val="accent1"/>
+          </a:lnRef>
+          <a:fillRef idx="0">
+            <a:schemeClr val="accent1"/>
+          </a:fillRef>
+          <a:effectRef idx="0">
+            <a:schemeClr val="accent1"/>
+          </a:effectRef>
+          <a:fontRef idx="minor">
+            <a:schemeClr val="tx1"/>
+          </a:fontRef>
+        </p:style>
+      </p:cxnSp>
+      <p:cxnSp>
+        <p:nvCxnSpPr>
+          <p:cNvPr id="13" name="Straight Connector 12">
+            <a:extLst>
+              <a:ext uri="{FF2B5EF4-FFF2-40B4-BE49-F238E27FC236}">
+                <a16:creationId xmlns:a16="http://schemas.microsoft.com/office/drawing/2014/main" id="{F92FC43E-3A3D-E256-5BC7-DD648457C115}"/>
+              </a:ext>
+            </a:extLst>
+          </p:cNvPr>
+          <p:cNvCxnSpPr>
+            <a:cxnSpLocks/>
+          </p:cNvCxnSpPr>
+          <p:nvPr/>
+        </p:nvCxnSpPr>
+        <p:spPr>
+          <a:xfrm flipH="1">
+            <a:off x="4943856" y="3044428"/>
+            <a:ext cx="1837944" cy="0"/>
+          </a:xfrm>
+          <a:prstGeom prst="line">
+            <a:avLst/>
+          </a:prstGeom>
+          <a:ln>
+            <a:prstDash val="dash"/>
+          </a:ln>
+        </p:spPr>
+        <p:style>
+          <a:lnRef idx="1">
+            <a:schemeClr val="accent1"/>
+          </a:lnRef>
+          <a:fillRef idx="0">
+            <a:schemeClr val="accent1"/>
+          </a:fillRef>
+          <a:effectRef idx="0">
+            <a:schemeClr val="accent1"/>
+          </a:effectRef>
+          <a:fontRef idx="minor">
+            <a:schemeClr val="tx1"/>
+          </a:fontRef>
+        </p:style>
+      </p:cxnSp>
+      <p:cxnSp>
+        <p:nvCxnSpPr>
+          <p:cNvPr id="17" name="Straight Connector 16">
+            <a:extLst>
+              <a:ext uri="{FF2B5EF4-FFF2-40B4-BE49-F238E27FC236}">
+                <a16:creationId xmlns:a16="http://schemas.microsoft.com/office/drawing/2014/main" id="{14ED8DB1-4EFA-B861-6ABD-DA0779AE5525}"/>
+              </a:ext>
+            </a:extLst>
+          </p:cNvPr>
+          <p:cNvCxnSpPr>
+            <a:cxnSpLocks/>
+          </p:cNvCxnSpPr>
+          <p:nvPr/>
+        </p:nvCxnSpPr>
+        <p:spPr>
+          <a:xfrm flipH="1">
+            <a:off x="4568952" y="3056620"/>
+            <a:ext cx="374904" cy="369332"/>
+          </a:xfrm>
+          <a:prstGeom prst="line">
+            <a:avLst/>
+          </a:prstGeom>
+          <a:ln>
+            <a:prstDash val="dash"/>
+          </a:ln>
+        </p:spPr>
+        <p:style>
+          <a:lnRef idx="1">
+            <a:schemeClr val="accent1"/>
+          </a:lnRef>
+          <a:fillRef idx="0">
+            <a:schemeClr val="accent1"/>
+          </a:fillRef>
+          <a:effectRef idx="0">
+            <a:schemeClr val="accent1"/>
+          </a:effectRef>
+          <a:fontRef idx="minor">
+            <a:schemeClr val="tx1"/>
+          </a:fontRef>
+        </p:style>
+      </p:cxnSp>
+      <p:cxnSp>
+        <p:nvCxnSpPr>
+          <p:cNvPr id="2" name="Straight Connector 1">
+            <a:extLst>
+              <a:ext uri="{FF2B5EF4-FFF2-40B4-BE49-F238E27FC236}">
+                <a16:creationId xmlns:a16="http://schemas.microsoft.com/office/drawing/2014/main" id="{B312B2C5-1958-7B69-85F4-8FF656F6F56E}"/>
+              </a:ext>
+            </a:extLst>
+          </p:cNvPr>
+          <p:cNvCxnSpPr/>
+          <p:nvPr/>
+        </p:nvCxnSpPr>
+        <p:spPr>
+          <a:xfrm flipV="1">
+            <a:off x="4943856" y="1325880"/>
+            <a:ext cx="0" cy="521208"/>
+          </a:xfrm>
+          <a:prstGeom prst="line">
+            <a:avLst/>
+          </a:prstGeom>
+          <a:ln>
+            <a:solidFill>
+              <a:schemeClr val="tx1"/>
+            </a:solidFill>
+            <a:prstDash val="dash"/>
+          </a:ln>
+        </p:spPr>
+        <p:style>
+          <a:lnRef idx="1">
+            <a:schemeClr val="accent1"/>
+          </a:lnRef>
+          <a:fillRef idx="0">
+            <a:schemeClr val="accent1"/>
+          </a:fillRef>
+          <a:effectRef idx="0">
+            <a:schemeClr val="accent1"/>
+          </a:effectRef>
+          <a:fontRef idx="minor">
+            <a:schemeClr val="tx1"/>
+          </a:fontRef>
+        </p:style>
+      </p:cxnSp>
+      <p:cxnSp>
+        <p:nvCxnSpPr>
+          <p:cNvPr id="3" name="Straight Connector 2">
+            <a:extLst>
+              <a:ext uri="{FF2B5EF4-FFF2-40B4-BE49-F238E27FC236}">
+                <a16:creationId xmlns:a16="http://schemas.microsoft.com/office/drawing/2014/main" id="{67B02CF7-E812-19A8-4B11-D7076EC55086}"/>
+              </a:ext>
+            </a:extLst>
+          </p:cNvPr>
+          <p:cNvCxnSpPr/>
+          <p:nvPr/>
+        </p:nvCxnSpPr>
+        <p:spPr>
+          <a:xfrm flipV="1">
+            <a:off x="4568952" y="1725168"/>
+            <a:ext cx="0" cy="521208"/>
+          </a:xfrm>
+          <a:prstGeom prst="line">
+            <a:avLst/>
+          </a:prstGeom>
+          <a:ln>
+            <a:solidFill>
+              <a:schemeClr val="tx1"/>
+            </a:solidFill>
+            <a:prstDash val="dash"/>
+          </a:ln>
+        </p:spPr>
+        <p:style>
+          <a:lnRef idx="1">
+            <a:schemeClr val="accent1"/>
+          </a:lnRef>
+          <a:fillRef idx="0">
+            <a:schemeClr val="accent1"/>
+          </a:fillRef>
+          <a:effectRef idx="0">
+            <a:schemeClr val="accent1"/>
+          </a:effectRef>
+          <a:fontRef idx="minor">
+            <a:schemeClr val="tx1"/>
+          </a:fontRef>
+        </p:style>
+      </p:cxnSp>
+      <p:cxnSp>
+        <p:nvCxnSpPr>
+          <p:cNvPr id="6" name="Straight Arrow Connector 5">
+            <a:extLst>
+              <a:ext uri="{FF2B5EF4-FFF2-40B4-BE49-F238E27FC236}">
+                <a16:creationId xmlns:a16="http://schemas.microsoft.com/office/drawing/2014/main" id="{9D26FF9B-056F-AE83-B094-016B369BD14B}"/>
+              </a:ext>
+            </a:extLst>
+          </p:cNvPr>
+          <p:cNvCxnSpPr>
+            <a:cxnSpLocks/>
+          </p:cNvCxnSpPr>
+          <p:nvPr/>
+        </p:nvCxnSpPr>
+        <p:spPr>
+          <a:xfrm flipV="1">
+            <a:off x="4568952" y="1581330"/>
+            <a:ext cx="374904" cy="380107"/>
+          </a:xfrm>
+          <a:prstGeom prst="straightConnector1">
+            <a:avLst/>
+          </a:prstGeom>
+          <a:ln>
+            <a:solidFill>
+              <a:schemeClr val="tx1"/>
+            </a:solidFill>
+            <a:prstDash val="dash"/>
+            <a:headEnd type="triangle"/>
+            <a:tailEnd type="triangle"/>
+          </a:ln>
+        </p:spPr>
+        <p:style>
+          <a:lnRef idx="1">
+            <a:schemeClr val="accent1"/>
+          </a:lnRef>
+          <a:fillRef idx="0">
+            <a:schemeClr val="accent1"/>
+          </a:fillRef>
+          <a:effectRef idx="0">
+            <a:schemeClr val="accent1"/>
+          </a:effectRef>
+          <a:fontRef idx="minor">
+            <a:schemeClr val="tx1"/>
+          </a:fontRef>
+        </p:style>
+      </p:cxnSp>
+      <p:sp>
+        <p:nvSpPr>
+          <p:cNvPr id="14" name="TextBox 13">
+            <a:extLst>
+              <a:ext uri="{FF2B5EF4-FFF2-40B4-BE49-F238E27FC236}">
+                <a16:creationId xmlns:a16="http://schemas.microsoft.com/office/drawing/2014/main" id="{CD173A3B-5D3E-FBEA-F0A4-1FC55D0B6085}"/>
+              </a:ext>
+            </a:extLst>
+          </p:cNvPr>
+          <p:cNvSpPr txBox="1"/>
+          <p:nvPr/>
+        </p:nvSpPr>
+        <p:spPr>
+          <a:xfrm>
+            <a:off x="4495879" y="1296389"/>
+            <a:ext cx="415498" cy="369332"/>
+          </a:xfrm>
+          <a:prstGeom prst="rect">
+            <a:avLst/>
+          </a:prstGeom>
+          <a:noFill/>
+        </p:spPr>
+        <p:txBody>
+          <a:bodyPr wrap="none" rtlCol="0">
+            <a:spAutoFit/>
+          </a:bodyPr>
+          <a:lstStyle/>
+          <a:p>
+            <a:r>
+              <a:rPr lang="en-US" dirty="0" err="1">
+                <a:sym typeface="Symbol" panose="05050102010706020507" pitchFamily="18" charset="2"/>
+              </a:rPr>
+              <a:t>d</a:t>
+            </a:r>
+            <a:r>
+              <a:rPr lang="en-US" dirty="0" err="1"/>
+              <a:t>z</a:t>
+            </a:r>
+            <a:endParaRPr lang="en-US" dirty="0"/>
+          </a:p>
+        </p:txBody>
+      </p:sp>
+      <p:cxnSp>
+        <p:nvCxnSpPr>
+          <p:cNvPr id="15" name="Straight Connector 14">
+            <a:extLst>
+              <a:ext uri="{FF2B5EF4-FFF2-40B4-BE49-F238E27FC236}">
+                <a16:creationId xmlns:a16="http://schemas.microsoft.com/office/drawing/2014/main" id="{8CE21D82-5BB2-7B20-4B76-32D44A3F31D6}"/>
+              </a:ext>
+            </a:extLst>
+          </p:cNvPr>
+          <p:cNvCxnSpPr/>
+          <p:nvPr/>
+        </p:nvCxnSpPr>
+        <p:spPr>
+          <a:xfrm flipV="1">
+            <a:off x="4568952" y="3520702"/>
+            <a:ext cx="0" cy="521208"/>
+          </a:xfrm>
+          <a:prstGeom prst="line">
+            <a:avLst/>
+          </a:prstGeom>
+          <a:ln>
+            <a:solidFill>
+              <a:schemeClr val="tx1"/>
+            </a:solidFill>
+            <a:prstDash val="dash"/>
+          </a:ln>
+        </p:spPr>
+        <p:style>
+          <a:lnRef idx="1">
+            <a:schemeClr val="accent1"/>
+          </a:lnRef>
+          <a:fillRef idx="0">
+            <a:schemeClr val="accent1"/>
+          </a:fillRef>
+          <a:effectRef idx="0">
+            <a:schemeClr val="accent1"/>
+          </a:effectRef>
+          <a:fontRef idx="minor">
+            <a:schemeClr val="tx1"/>
+          </a:fontRef>
+        </p:style>
+      </p:cxnSp>
+      <p:cxnSp>
+        <p:nvCxnSpPr>
+          <p:cNvPr id="16" name="Straight Connector 15">
+            <a:extLst>
+              <a:ext uri="{FF2B5EF4-FFF2-40B4-BE49-F238E27FC236}">
+                <a16:creationId xmlns:a16="http://schemas.microsoft.com/office/drawing/2014/main" id="{3D11ADD0-C44A-A4CF-B328-B85E48DB8A42}"/>
+              </a:ext>
+            </a:extLst>
+          </p:cNvPr>
+          <p:cNvCxnSpPr/>
+          <p:nvPr/>
+        </p:nvCxnSpPr>
+        <p:spPr>
+          <a:xfrm flipV="1">
+            <a:off x="6385560" y="3444764"/>
+            <a:ext cx="0" cy="521208"/>
+          </a:xfrm>
+          <a:prstGeom prst="line">
+            <a:avLst/>
+          </a:prstGeom>
+          <a:ln>
+            <a:solidFill>
+              <a:schemeClr val="tx1"/>
+            </a:solidFill>
+            <a:prstDash val="dash"/>
+          </a:ln>
+        </p:spPr>
+        <p:style>
+          <a:lnRef idx="1">
+            <a:schemeClr val="accent1"/>
+          </a:lnRef>
+          <a:fillRef idx="0">
+            <a:schemeClr val="accent1"/>
+          </a:fillRef>
+          <a:effectRef idx="0">
+            <a:schemeClr val="accent1"/>
+          </a:effectRef>
+          <a:fontRef idx="minor">
+            <a:schemeClr val="tx1"/>
+          </a:fontRef>
+        </p:style>
+      </p:cxnSp>
+      <p:cxnSp>
+        <p:nvCxnSpPr>
+          <p:cNvPr id="18" name="Straight Arrow Connector 17">
+            <a:extLst>
+              <a:ext uri="{FF2B5EF4-FFF2-40B4-BE49-F238E27FC236}">
+                <a16:creationId xmlns:a16="http://schemas.microsoft.com/office/drawing/2014/main" id="{576D556B-E548-114E-10DA-CE5E435BBBB1}"/>
+              </a:ext>
+            </a:extLst>
+          </p:cNvPr>
+          <p:cNvCxnSpPr>
+            <a:cxnSpLocks/>
+          </p:cNvCxnSpPr>
+          <p:nvPr/>
+        </p:nvCxnSpPr>
+        <p:spPr>
+          <a:xfrm>
+            <a:off x="4568952" y="3781306"/>
+            <a:ext cx="1787652" cy="0"/>
+          </a:xfrm>
+          <a:prstGeom prst="straightConnector1">
+            <a:avLst/>
+          </a:prstGeom>
+          <a:ln>
+            <a:solidFill>
+              <a:schemeClr val="tx1"/>
+            </a:solidFill>
+            <a:prstDash val="dash"/>
+            <a:headEnd type="triangle"/>
+            <a:tailEnd type="triangle"/>
+          </a:ln>
+        </p:spPr>
+        <p:style>
+          <a:lnRef idx="1">
+            <a:schemeClr val="accent1"/>
+          </a:lnRef>
+          <a:fillRef idx="0">
+            <a:schemeClr val="accent1"/>
+          </a:fillRef>
+          <a:effectRef idx="0">
+            <a:schemeClr val="accent1"/>
+          </a:effectRef>
+          <a:fontRef idx="minor">
+            <a:schemeClr val="tx1"/>
+          </a:fontRef>
+        </p:style>
+      </p:cxnSp>
+      <p:sp>
+        <p:nvSpPr>
+          <p:cNvPr id="22" name="TextBox 21">
+            <a:extLst>
+              <a:ext uri="{FF2B5EF4-FFF2-40B4-BE49-F238E27FC236}">
+                <a16:creationId xmlns:a16="http://schemas.microsoft.com/office/drawing/2014/main" id="{56BD8E51-928B-6538-9DE3-75C3BE796E18}"/>
+              </a:ext>
+            </a:extLst>
+          </p:cNvPr>
+          <p:cNvSpPr txBox="1"/>
+          <p:nvPr/>
+        </p:nvSpPr>
+        <p:spPr>
+          <a:xfrm>
+            <a:off x="5264698" y="3596640"/>
+            <a:ext cx="417102" cy="369332"/>
+          </a:xfrm>
+          <a:prstGeom prst="rect">
+            <a:avLst/>
+          </a:prstGeom>
+          <a:solidFill>
+            <a:schemeClr val="bg1"/>
+          </a:solidFill>
+        </p:spPr>
+        <p:txBody>
+          <a:bodyPr wrap="none" rtlCol="0">
+            <a:spAutoFit/>
+          </a:bodyPr>
+          <a:lstStyle/>
+          <a:p>
+            <a:r>
+              <a:rPr lang="en-US" dirty="0">
+                <a:sym typeface="Symbol" panose="05050102010706020507" pitchFamily="18" charset="2"/>
+              </a:rPr>
+              <a:t>d</a:t>
+            </a:r>
+            <a:r>
+              <a:rPr lang="en-US" dirty="0"/>
+              <a:t>x</a:t>
+            </a:r>
+          </a:p>
+        </p:txBody>
+      </p:sp>
+      <p:cxnSp>
+        <p:nvCxnSpPr>
+          <p:cNvPr id="25" name="Straight Connector 24">
+            <a:extLst>
+              <a:ext uri="{FF2B5EF4-FFF2-40B4-BE49-F238E27FC236}">
+                <a16:creationId xmlns:a16="http://schemas.microsoft.com/office/drawing/2014/main" id="{86912471-0A70-708E-897C-E86A10876C71}"/>
+              </a:ext>
+            </a:extLst>
+          </p:cNvPr>
+          <p:cNvCxnSpPr>
+            <a:cxnSpLocks/>
+          </p:cNvCxnSpPr>
+          <p:nvPr/>
+        </p:nvCxnSpPr>
+        <p:spPr>
+          <a:xfrm flipH="1">
+            <a:off x="4105735" y="2316480"/>
+            <a:ext cx="408432" cy="0"/>
+          </a:xfrm>
+          <a:prstGeom prst="line">
+            <a:avLst/>
+          </a:prstGeom>
+          <a:ln>
+            <a:solidFill>
+              <a:schemeClr val="tx1"/>
+            </a:solidFill>
+            <a:prstDash val="dash"/>
+          </a:ln>
+        </p:spPr>
+        <p:style>
+          <a:lnRef idx="1">
+            <a:schemeClr val="accent1"/>
+          </a:lnRef>
+          <a:fillRef idx="0">
+            <a:schemeClr val="accent1"/>
+          </a:fillRef>
+          <a:effectRef idx="0">
+            <a:schemeClr val="accent1"/>
+          </a:effectRef>
+          <a:fontRef idx="minor">
+            <a:schemeClr val="tx1"/>
+          </a:fontRef>
+        </p:style>
+      </p:cxnSp>
+      <p:cxnSp>
+        <p:nvCxnSpPr>
+          <p:cNvPr id="27" name="Straight Connector 26">
+            <a:extLst>
+              <a:ext uri="{FF2B5EF4-FFF2-40B4-BE49-F238E27FC236}">
+                <a16:creationId xmlns:a16="http://schemas.microsoft.com/office/drawing/2014/main" id="{F16C13D7-78AB-6F8F-5255-33E8C51B6E3D}"/>
+              </a:ext>
+            </a:extLst>
+          </p:cNvPr>
+          <p:cNvCxnSpPr>
+            <a:cxnSpLocks/>
+          </p:cNvCxnSpPr>
+          <p:nvPr/>
+        </p:nvCxnSpPr>
+        <p:spPr>
+          <a:xfrm flipH="1">
+            <a:off x="4111831" y="3429000"/>
+            <a:ext cx="408432" cy="0"/>
+          </a:xfrm>
+          <a:prstGeom prst="line">
+            <a:avLst/>
+          </a:prstGeom>
+          <a:ln>
+            <a:solidFill>
+              <a:schemeClr val="tx1"/>
+            </a:solidFill>
+            <a:prstDash val="dash"/>
+          </a:ln>
+        </p:spPr>
+        <p:style>
+          <a:lnRef idx="1">
+            <a:schemeClr val="accent1"/>
+          </a:lnRef>
+          <a:fillRef idx="0">
+            <a:schemeClr val="accent1"/>
+          </a:fillRef>
+          <a:effectRef idx="0">
+            <a:schemeClr val="accent1"/>
+          </a:effectRef>
+          <a:fontRef idx="minor">
+            <a:schemeClr val="tx1"/>
+          </a:fontRef>
+        </p:style>
+      </p:cxnSp>
+      <p:cxnSp>
+        <p:nvCxnSpPr>
+          <p:cNvPr id="28" name="Straight Arrow Connector 27">
+            <a:extLst>
+              <a:ext uri="{FF2B5EF4-FFF2-40B4-BE49-F238E27FC236}">
+                <a16:creationId xmlns:a16="http://schemas.microsoft.com/office/drawing/2014/main" id="{464582FE-08BD-FCC6-657F-10BBC29128F9}"/>
+              </a:ext>
+            </a:extLst>
+          </p:cNvPr>
+          <p:cNvCxnSpPr>
+            <a:cxnSpLocks/>
+          </p:cNvCxnSpPr>
+          <p:nvPr/>
+        </p:nvCxnSpPr>
+        <p:spPr>
+          <a:xfrm flipV="1">
+            <a:off x="4308348" y="2316480"/>
+            <a:ext cx="0" cy="1102114"/>
+          </a:xfrm>
+          <a:prstGeom prst="straightConnector1">
+            <a:avLst/>
+          </a:prstGeom>
+          <a:ln>
+            <a:solidFill>
+              <a:schemeClr val="tx1"/>
+            </a:solidFill>
+            <a:prstDash val="dash"/>
+            <a:headEnd type="triangle"/>
+            <a:tailEnd type="triangle"/>
+          </a:ln>
+        </p:spPr>
+        <p:style>
+          <a:lnRef idx="1">
+            <a:schemeClr val="accent1"/>
+          </a:lnRef>
+          <a:fillRef idx="0">
+            <a:schemeClr val="accent1"/>
+          </a:fillRef>
+          <a:effectRef idx="0">
+            <a:schemeClr val="accent1"/>
+          </a:effectRef>
+          <a:fontRef idx="minor">
+            <a:schemeClr val="tx1"/>
+          </a:fontRef>
+        </p:style>
+      </p:cxnSp>
+      <p:sp>
+        <p:nvSpPr>
+          <p:cNvPr id="30" name="TextBox 29">
+            <a:extLst>
+              <a:ext uri="{FF2B5EF4-FFF2-40B4-BE49-F238E27FC236}">
+                <a16:creationId xmlns:a16="http://schemas.microsoft.com/office/drawing/2014/main" id="{97BE651B-D294-EA86-5F53-24780C613604}"/>
+              </a:ext>
+            </a:extLst>
+          </p:cNvPr>
+          <p:cNvSpPr txBox="1"/>
+          <p:nvPr/>
+        </p:nvSpPr>
+        <p:spPr>
+          <a:xfrm>
+            <a:off x="4111515" y="2923460"/>
+            <a:ext cx="418704" cy="369332"/>
+          </a:xfrm>
+          <a:prstGeom prst="rect">
+            <a:avLst/>
+          </a:prstGeom>
+          <a:solidFill>
+            <a:schemeClr val="bg1"/>
+          </a:solidFill>
+        </p:spPr>
+        <p:txBody>
+          <a:bodyPr wrap="none" rtlCol="0">
+            <a:spAutoFit/>
+          </a:bodyPr>
+          <a:lstStyle/>
+          <a:p>
+            <a:r>
+              <a:rPr lang="en-US" dirty="0" err="1">
+                <a:sym typeface="Symbol" panose="05050102010706020507" pitchFamily="18" charset="2"/>
+              </a:rPr>
+              <a:t>dy</a:t>
+            </a:r>
+            <a:endParaRPr lang="en-US" dirty="0"/>
+          </a:p>
+        </p:txBody>
+      </p:sp>
+      <p:sp>
+        <p:nvSpPr>
+          <p:cNvPr id="33" name="TextBox 32">
+            <a:extLst>
+              <a:ext uri="{FF2B5EF4-FFF2-40B4-BE49-F238E27FC236}">
+                <a16:creationId xmlns:a16="http://schemas.microsoft.com/office/drawing/2014/main" id="{939DC9B8-FE62-186B-4C4B-54EDA73AA9B5}"/>
+              </a:ext>
+            </a:extLst>
+          </p:cNvPr>
+          <p:cNvSpPr txBox="1"/>
+          <p:nvPr/>
+        </p:nvSpPr>
+        <p:spPr>
+          <a:xfrm>
+            <a:off x="3383618" y="2549236"/>
+            <a:ext cx="362600" cy="461665"/>
+          </a:xfrm>
+          <a:prstGeom prst="rect">
+            <a:avLst/>
+          </a:prstGeom>
+          <a:noFill/>
+        </p:spPr>
+        <p:txBody>
+          <a:bodyPr wrap="none" rtlCol="0">
+            <a:spAutoFit/>
+          </a:bodyPr>
+          <a:lstStyle/>
+          <a:p>
+            <a:r>
+              <a:rPr lang="en-US" sz="2400" dirty="0">
+                <a:solidFill>
+                  <a:srgbClr val="00B050"/>
+                </a:solidFill>
+              </a:rPr>
+              <a:t>P</a:t>
+            </a:r>
+          </a:p>
+        </p:txBody>
+      </p:sp>
+      <p:sp>
+        <p:nvSpPr>
+          <p:cNvPr id="34" name="TextBox 33">
+            <a:extLst>
+              <a:ext uri="{FF2B5EF4-FFF2-40B4-BE49-F238E27FC236}">
+                <a16:creationId xmlns:a16="http://schemas.microsoft.com/office/drawing/2014/main" id="{02A560B1-56B2-9197-9B9F-10AA18A1D6A5}"/>
+              </a:ext>
+            </a:extLst>
+          </p:cNvPr>
+          <p:cNvSpPr txBox="1"/>
+          <p:nvPr/>
+        </p:nvSpPr>
+        <p:spPr>
+          <a:xfrm>
+            <a:off x="7529090" y="2536210"/>
+            <a:ext cx="878767" cy="461665"/>
+          </a:xfrm>
+          <a:prstGeom prst="rect">
+            <a:avLst/>
+          </a:prstGeom>
+          <a:noFill/>
+        </p:spPr>
+        <p:txBody>
+          <a:bodyPr wrap="none" rtlCol="0">
+            <a:spAutoFit/>
+          </a:bodyPr>
+          <a:lstStyle/>
+          <a:p>
+            <a:r>
+              <a:rPr lang="en-US" sz="2400" dirty="0" err="1">
+                <a:solidFill>
+                  <a:srgbClr val="00B050"/>
+                </a:solidFill>
+              </a:rPr>
+              <a:t>P+dP</a:t>
+            </a:r>
+            <a:endParaRPr lang="en-US" sz="2400" dirty="0">
+              <a:solidFill>
+                <a:srgbClr val="00B050"/>
+              </a:solidFill>
+            </a:endParaRPr>
+          </a:p>
+        </p:txBody>
+      </p:sp>
+    </p:spTree>
+    <p:extLst>
+      <p:ext uri="{BB962C8B-B14F-4D97-AF65-F5344CB8AC3E}">
+        <p14:creationId xmlns:p14="http://schemas.microsoft.com/office/powerpoint/2010/main" val="1325716157"/>
+      </p:ext>
+    </p:extLst>
+  </p:cSld>
+  <p:clrMapOvr>
+    <a:masterClrMapping/>
+  </p:clrMapOvr>
+</p:sld>
+</file>
+
+<file path=ppt/slides/slide17.xml><?xml version="1.0" encoding="utf-8"?>
 <p:sld xmlns:a="http://schemas.openxmlformats.org/drawingml/2006/main" xmlns:r="http://schemas.openxmlformats.org/officeDocument/2006/relationships" xmlns:p="http://schemas.openxmlformats.org/presentationml/2006/main">
   <p:cSld>
     <p:spTree>

</xml_diff>

<commit_message>
complete edited text at end of semester
</commit_message>
<xml_diff>
--- a/Lecture_Slides/PH 123 Lecture 36.pptx
+++ b/Lecture_Slides/PH 123 Lecture 36.pptx
@@ -132,7 +132,7 @@
 <file path=ppt/revisionInfo.xml><?xml version="1.0" encoding="utf-8"?>
 <p1510:revInfo xmlns:a="http://schemas.openxmlformats.org/drawingml/2006/main" xmlns:r="http://schemas.openxmlformats.org/officeDocument/2006/relationships" xmlns:p1510="http://schemas.microsoft.com/office/powerpoint/2015/10/main">
   <p1510:revLst>
-    <p1510:client id="{A188FBDB-A577-4F86-A794-33773316D8C5}" v="46" dt="2026-03-31T19:47:52.001"/>
+    <p1510:client id="{A188FBDB-A577-4F86-A794-33773316D8C5}" v="47" dt="2026-03-31T21:56:07.660"/>
   </p1510:revLst>
 </p1510:revInfo>
 </file>
@@ -142,12 +142,12 @@
   <pc:docChgLst>
     <pc:chgData name="Lines, Todd" userId="afaf7c3a-e8aa-4568-882a-02ad8f9e19b0" providerId="ADAL" clId="{5FF5AC1B-ABA9-43D7-A1E3-2D92732CD6E2}"/>
     <pc:docChg chg="undo custSel addSld modSld">
-      <pc:chgData name="Lines, Todd" userId="afaf7c3a-e8aa-4568-882a-02ad8f9e19b0" providerId="ADAL" clId="{5FF5AC1B-ABA9-43D7-A1E3-2D92732CD6E2}" dt="2026-03-31T19:47:56.233" v="552" actId="21"/>
+      <pc:chgData name="Lines, Todd" userId="afaf7c3a-e8aa-4568-882a-02ad8f9e19b0" providerId="ADAL" clId="{5FF5AC1B-ABA9-43D7-A1E3-2D92732CD6E2}" dt="2026-03-31T21:56:13.452" v="557" actId="21"/>
       <pc:docMkLst>
         <pc:docMk/>
       </pc:docMkLst>
       <pc:sldChg chg="addSp delSp modSp new mod">
-        <pc:chgData name="Lines, Todd" userId="afaf7c3a-e8aa-4568-882a-02ad8f9e19b0" providerId="ADAL" clId="{5FF5AC1B-ABA9-43D7-A1E3-2D92732CD6E2}" dt="2026-03-31T19:47:56.233" v="552" actId="21"/>
+        <pc:chgData name="Lines, Todd" userId="afaf7c3a-e8aa-4568-882a-02ad8f9e19b0" providerId="ADAL" clId="{5FF5AC1B-ABA9-43D7-A1E3-2D92732CD6E2}" dt="2026-03-31T21:56:13.452" v="557" actId="21"/>
         <pc:sldMkLst>
           <pc:docMk/>
           <pc:sldMk cId="403151843" sldId="491"/>
@@ -345,7 +345,7 @@
           </ac:spMkLst>
         </pc:spChg>
         <pc:spChg chg="add del mod ord">
-          <ac:chgData name="Lines, Todd" userId="afaf7c3a-e8aa-4568-882a-02ad8f9e19b0" providerId="ADAL" clId="{5FF5AC1B-ABA9-43D7-A1E3-2D92732CD6E2}" dt="2026-03-31T17:20:03.506" v="447" actId="1076"/>
+          <ac:chgData name="Lines, Todd" userId="afaf7c3a-e8aa-4568-882a-02ad8f9e19b0" providerId="ADAL" clId="{5FF5AC1B-ABA9-43D7-A1E3-2D92732CD6E2}" dt="2026-03-31T21:55:50.580" v="554" actId="207"/>
           <ac:spMkLst>
             <pc:docMk/>
             <pc:sldMk cId="403151843" sldId="491"/>
@@ -353,7 +353,7 @@
           </ac:spMkLst>
         </pc:spChg>
         <pc:spChg chg="add mod ord">
-          <ac:chgData name="Lines, Todd" userId="afaf7c3a-e8aa-4568-882a-02ad8f9e19b0" providerId="ADAL" clId="{5FF5AC1B-ABA9-43D7-A1E3-2D92732CD6E2}" dt="2026-03-31T17:20:03.506" v="447" actId="1076"/>
+          <ac:chgData name="Lines, Todd" userId="afaf7c3a-e8aa-4568-882a-02ad8f9e19b0" providerId="ADAL" clId="{5FF5AC1B-ABA9-43D7-A1E3-2D92732CD6E2}" dt="2026-03-31T21:55:55.210" v="555" actId="108"/>
           <ac:spMkLst>
             <pc:docMk/>
             <pc:sldMk cId="403151843" sldId="491"/>
@@ -462,6 +462,14 @@
             <pc:docMk/>
             <pc:sldMk cId="403151843" sldId="491"/>
             <ac:picMk id="6" creationId="{843D8325-5718-BCD1-9BE3-31EACC93AA4F}"/>
+          </ac:picMkLst>
+        </pc:picChg>
+        <pc:picChg chg="del mod">
+          <ac:chgData name="Lines, Todd" userId="afaf7c3a-e8aa-4568-882a-02ad8f9e19b0" providerId="ADAL" clId="{5FF5AC1B-ABA9-43D7-A1E3-2D92732CD6E2}" dt="2026-03-31T21:56:13.452" v="557" actId="21"/>
+          <ac:picMkLst>
+            <pc:docMk/>
+            <pc:sldMk cId="403151843" sldId="491"/>
+            <ac:picMk id="9" creationId="{E49870DB-BA70-AFE6-8ED6-DE1760C6DD29}"/>
           </ac:picMkLst>
         </pc:picChg>
         <pc:picChg chg="del mod">
@@ -8302,18 +8310,24 @@
             <a:gsLst>
               <a:gs pos="0">
                 <a:schemeClr val="accent2">
+                  <a:lumMod val="60000"/>
+                  <a:lumOff val="40000"/>
                   <a:shade val="30000"/>
                   <a:satMod val="115000"/>
                 </a:schemeClr>
               </a:gs>
               <a:gs pos="50000">
                 <a:schemeClr val="accent2">
+                  <a:lumMod val="60000"/>
+                  <a:lumOff val="40000"/>
                   <a:shade val="67500"/>
                   <a:satMod val="115000"/>
                 </a:schemeClr>
               </a:gs>
               <a:gs pos="100000">
                 <a:schemeClr val="accent2">
+                  <a:lumMod val="60000"/>
+                  <a:lumOff val="40000"/>
                   <a:shade val="100000"/>
                   <a:satMod val="115000"/>
                 </a:schemeClr>
@@ -8375,18 +8389,24 @@
             <a:gsLst>
               <a:gs pos="0">
                 <a:schemeClr val="accent2">
+                  <a:lumMod val="60000"/>
+                  <a:lumOff val="40000"/>
                   <a:shade val="30000"/>
                   <a:satMod val="115000"/>
                 </a:schemeClr>
               </a:gs>
               <a:gs pos="50000">
                 <a:schemeClr val="accent2">
+                  <a:lumMod val="60000"/>
+                  <a:lumOff val="40000"/>
                   <a:shade val="67500"/>
                   <a:satMod val="115000"/>
                 </a:schemeClr>
               </a:gs>
               <a:gs pos="100000">
                 <a:schemeClr val="accent2">
+                  <a:lumMod val="60000"/>
+                  <a:lumOff val="40000"/>
                   <a:shade val="100000"/>
                   <a:satMod val="115000"/>
                 </a:schemeClr>

</xml_diff>